<commit_message>
docs: streamline linkedin presentation to clean minimal 5-slide portrait carousel
</commit_message>
<xml_diff>
--- a/docs/linkedin_presentation_deck.pptx
+++ b/docs/linkedin_presentation_deck.pptx
@@ -11,7 +11,7 @@
     <p:sldId id="259" r:id="rId10"/>
     <p:sldId id="260" r:id="rId11"/>
   </p:sldIdLst>
-  <p:sldSz cx="12191695" cy="6858000" type="screen4x3"/>
+  <p:sldSz cx="7772400" cy="9715500" type="screen4x3"/>
   <p:notesSz cx="6858000" cy="9144000"/>
   <p:defaultTextStyle>
     <a:defPPr>
@@ -3101,7 +3101,7 @@
         <p:spPr>
           <a:xfrm>
             <a:off x="0" y="0"/>
-            <a:ext cx="12191695" cy="6858000"/>
+            <a:ext cx="7772400" cy="9715500"/>
           </a:xfrm>
           <a:prstGeom prst="rect">
             <a:avLst/>
@@ -3143,8 +3143,8 @@
         </p:nvSpPr>
         <p:spPr>
           <a:xfrm>
-            <a:off x="731520" y="365760"/>
-            <a:ext cx="10515600" cy="320040"/>
+            <a:off x="640080" y="640080"/>
+            <a:ext cx="6492240" cy="320040"/>
           </a:xfrm>
           <a:prstGeom prst="rect">
             <a:avLst/>
@@ -3152,7 +3152,7 @@
           <a:noFill/>
         </p:spPr>
         <p:txBody>
-          <a:bodyPr wrap="square">
+          <a:bodyPr wrap="none">
             <a:spAutoFit/>
           </a:bodyPr>
           <a:lstStyle/>
@@ -3166,7 +3166,7 @@
               </a:defRPr>
             </a:pPr>
             <a:r>
-              <a:t>[ MLOPS &amp; QUANTITATIVE FINANCE CASE STUDY ]</a:t>
+              <a:t>[ 01 / PROBLEM &amp; PIVOT ]</a:t>
             </a:r>
           </a:p>
         </p:txBody>
@@ -3179,8 +3179,8 @@
         </p:nvSpPr>
         <p:spPr>
           <a:xfrm>
-            <a:off x="731520" y="685800"/>
-            <a:ext cx="10698480" cy="640080"/>
+            <a:off x="640080" y="1005840"/>
+            <a:ext cx="6492240" cy="1097280"/>
           </a:xfrm>
           <a:prstGeom prst="rect">
             <a:avLst/>
@@ -3194,7 +3194,7 @@
           <a:lstStyle/>
           <a:p>
             <a:pPr>
-              <a:defRPr sz="2600" b="1">
+              <a:defRPr sz="2800" b="1">
                 <a:solidFill>
                   <a:srgbClr val="F8FAFC"/>
                 </a:solidFill>
@@ -3202,7 +3202,7 @@
               </a:defRPr>
             </a:pPr>
             <a:r>
-              <a:t>Why 90% of Stock Price Predictors Fail in Production</a:t>
+              <a:t>Why Predicting Stock Prices is an Anti-Pattern</a:t>
             </a:r>
           </a:p>
         </p:txBody>
@@ -3215,8 +3215,8 @@
         </p:nvSpPr>
         <p:spPr>
           <a:xfrm>
-            <a:off x="731520" y="1280160"/>
-            <a:ext cx="10698480" cy="411480"/>
+            <a:off x="640080" y="2148840"/>
+            <a:ext cx="6492240" cy="822960"/>
           </a:xfrm>
           <a:prstGeom prst="rect">
             <a:avLst/>
@@ -3230,7 +3230,7 @@
           <a:lstStyle/>
           <a:p>
             <a:pPr>
-              <a:defRPr sz="1300">
+              <a:defRPr sz="1400">
                 <a:solidFill>
                   <a:srgbClr val="94A3B8"/>
                 </a:solidFill>
@@ -3238,7 +3238,7 @@
               </a:defRPr>
             </a:pPr>
             <a:r>
-              <a:t>Engineering calibrated multi-quantile uncertainty boundaries vs. predicting non-stationary nominal price points.</a:t>
+              <a:t>Predicting raw price points (P_t+30) creates a delayed echo of yesterday. Real financial ML forecasts stationary forward returns.</a:t>
             </a:r>
           </a:p>
         </p:txBody>
@@ -3251,14 +3251,14 @@
         </p:nvSpPr>
         <p:spPr>
           <a:xfrm>
-            <a:off x="731520" y="1828800"/>
-            <a:ext cx="5212080" cy="3291840"/>
+            <a:off x="640080" y="3291840"/>
+            <a:ext cx="6492240" cy="2377440"/>
           </a:xfrm>
           <a:prstGeom prst="rect">
             <a:avLst/>
           </a:prstGeom>
           <a:solidFill>
-            <a:srgbClr val="121824"/>
+            <a:srgbClr val="111722"/>
           </a:solidFill>
           <a:ln w="19050">
             <a:solidFill>
@@ -3296,8 +3296,8 @@
         </p:nvSpPr>
         <p:spPr>
           <a:xfrm>
-            <a:off x="914400" y="1965960"/>
-            <a:ext cx="4846320" cy="3017520"/>
+            <a:off x="822960" y="3429000"/>
+            <a:ext cx="6126480" cy="2103120"/>
           </a:xfrm>
           <a:prstGeom prst="rect">
             <a:avLst/>
@@ -3319,7 +3319,23 @@
               </a:defRPr>
             </a:pPr>
             <a:r>
-              <a:t>[ THE ANTI-PATTERN: NOMINAL PRICE REGRESSION ]</a:t>
+              <a:t>[ THE MISTAKE: RAW NOMINAL PRICE ]</a:t>
+            </a:r>
+          </a:p>
+          <a:p>
+            <a:pPr>
+              <a:spcBef>
+                <a:spcPts val="600"/>
+              </a:spcBef>
+              <a:defRPr sz="1800" b="1">
+                <a:solidFill>
+                  <a:srgbClr val="F8FAFC"/>
+                </a:solidFill>
+                <a:latin typeface="Trebuchet MS"/>
+              </a:defRPr>
+            </a:pPr>
+            <a:r>
+              <a:t>P_hat(t+30) ~= P_t</a:t>
             </a:r>
           </a:p>
           <a:p>
@@ -3327,31 +3343,15 @@
               <a:spcBef>
                 <a:spcPts val="800"/>
               </a:spcBef>
-              <a:defRPr sz="1100">
-                <a:solidFill>
-                  <a:srgbClr val="F8FAFC"/>
-                </a:solidFill>
-                <a:latin typeface="Consolas"/>
+              <a:defRPr sz="1300">
+                <a:solidFill>
+                  <a:srgbClr val="94A3B8"/>
+                </a:solidFill>
+                <a:latin typeface="Calibri"/>
               </a:defRPr>
             </a:pPr>
             <a:r>
-              <a:t>P_hat(t+30) = f(P_t, P_{t-1}, ...)  --&gt;  Learns Identity: P_hat(t+30) ~= P_t</a:t>
-            </a:r>
-          </a:p>
-          <a:p>
-            <a:pPr>
-              <a:spcBef>
-                <a:spcPts val="1000"/>
-              </a:spcBef>
-              <a:defRPr sz="1200">
-                <a:solidFill>
-                  <a:srgbClr val="94A3B8"/>
-                </a:solidFill>
-                <a:latin typeface="Calibri"/>
-              </a:defRPr>
-            </a:pPr>
-            <a:r>
-              <a:t>Asset prices are non-stationary I(1) unit-root series. Unconstrained MSE minimization heavily penalizes deviations from recent price levels, coercing gradient boosters to output a delayed 30-day lag. Despite synthetic R^2 &gt; 0.98, the model yields zero economic alpha.</a:t>
+              <a:t>Non-stationary prices trick models into outputting today's price as tomorrow's forecast with synthetic 98% R^2 and zero actual alpha.</a:t>
             </a:r>
           </a:p>
         </p:txBody>
@@ -3364,14 +3364,14 @@
         </p:nvSpPr>
         <p:spPr>
           <a:xfrm>
-            <a:off x="6217920" y="1828800"/>
-            <a:ext cx="5212080" cy="3291840"/>
+            <a:off x="640080" y="5943600"/>
+            <a:ext cx="6492240" cy="2377440"/>
           </a:xfrm>
           <a:prstGeom prst="rect">
             <a:avLst/>
           </a:prstGeom>
           <a:solidFill>
-            <a:srgbClr val="121824"/>
+            <a:srgbClr val="111722"/>
           </a:solidFill>
           <a:ln w="19050">
             <a:solidFill>
@@ -3409,8 +3409,8 @@
         </p:nvSpPr>
         <p:spPr>
           <a:xfrm>
-            <a:off x="6400800" y="1965960"/>
-            <a:ext cx="4846320" cy="3017520"/>
+            <a:off x="822960" y="6080760"/>
+            <a:ext cx="6126480" cy="2103120"/>
           </a:xfrm>
           <a:prstGeom prst="rect">
             <a:avLst/>
@@ -3432,7 +3432,23 @@
               </a:defRPr>
             </a:pPr>
             <a:r>
-              <a:t>[ THE MATHEMATICAL PIVOT: FORWARD LOG RETURN ]</a:t>
+              <a:t>[ THE FIX: 30-DAY FORWARD LOG RETURN ]</a:t>
+            </a:r>
+          </a:p>
+          <a:p>
+            <a:pPr>
+              <a:spcBef>
+                <a:spcPts val="600"/>
+              </a:spcBef>
+              <a:defRPr sz="1800" b="1">
+                <a:solidFill>
+                  <a:srgbClr val="F8FAFC"/>
+                </a:solidFill>
+                <a:latin typeface="Trebuchet MS"/>
+              </a:defRPr>
+            </a:pPr>
+            <a:r>
+              <a:t>y_t = ln( P_{t+30} / P_t )</a:t>
             </a:r>
           </a:p>
           <a:p>
@@ -3440,90 +3456,29 @@
               <a:spcBef>
                 <a:spcPts val="800"/>
               </a:spcBef>
-              <a:defRPr sz="1100">
-                <a:solidFill>
-                  <a:srgbClr val="F8FAFC"/>
-                </a:solidFill>
-                <a:latin typeface="Consolas"/>
+              <a:defRPr sz="1300">
+                <a:solidFill>
+                  <a:srgbClr val="94A3B8"/>
+                </a:solidFill>
+                <a:latin typeface="Calibri"/>
               </a:defRPr>
             </a:pPr>
             <a:r>
-              <a:t>y_t = ln( P_{t+30} / P_t )  [30-Trading-Day Cumulative Log Return]</a:t>
-            </a:r>
-          </a:p>
-          <a:p>
-            <a:pPr>
-              <a:spcBef>
-                <a:spcPts val="1000"/>
-              </a:spcBef>
-              <a:defRPr sz="1200">
-                <a:solidFill>
-                  <a:srgbClr val="94A3B8"/>
-                </a:solidFill>
-                <a:latin typeface="Calibri"/>
-              </a:defRPr>
-            </a:pPr>
-            <a:r>
-              <a:t>Transforming targets into cumulative forward log returns enforces covariance stationarity and scale invariance. Evaluated across 26 Colombo Stock Exchange (CSE) liquid equities and the ASPI market benchmark, models learn real momentum and mean-reversion dynamics.</a:t>
-            </a:r>
-          </a:p>
-        </p:txBody>
-      </p:sp>
-      <p:sp>
-        <p:nvSpPr>
-          <p:cNvPr id="10" name="Rectangle 9"/>
-          <p:cNvSpPr/>
-          <p:nvPr/>
-        </p:nvSpPr>
-        <p:spPr>
-          <a:xfrm>
-            <a:off x="731520" y="5303520"/>
-            <a:ext cx="3383280" cy="777240"/>
-          </a:xfrm>
-          <a:prstGeom prst="rect">
-            <a:avLst/>
-          </a:prstGeom>
-          <a:solidFill>
-            <a:srgbClr val="121824"/>
-          </a:solidFill>
-          <a:ln w="19050">
-            <a:solidFill>
-              <a:srgbClr val="222D3D"/>
-            </a:solidFill>
-          </a:ln>
-        </p:spPr>
-        <p:style>
-          <a:lnRef idx="1">
-            <a:schemeClr val="accent1"/>
-          </a:lnRef>
-          <a:fillRef idx="3">
-            <a:schemeClr val="accent1"/>
-          </a:fillRef>
-          <a:effectRef idx="2">
-            <a:schemeClr val="accent1"/>
-          </a:effectRef>
-          <a:fontRef idx="minor">
-            <a:schemeClr val="lt1"/>
-          </a:fontRef>
-        </p:style>
-        <p:txBody>
-          <a:bodyPr rtlCol="0" anchor="ctr"/>
-          <a:lstStyle/>
-          <a:p>
-            <a:pPr algn="ctr"/>
-          </a:p>
-        </p:txBody>
-      </p:sp>
-      <p:sp>
-        <p:nvSpPr>
-          <p:cNvPr id="11" name="TextBox 10"/>
+              <a:t>Enforces stationarity across all 26 Colombo Stock Exchange equities, forcing models to learn genuine momentum and cyclical turning points.</a:t>
+            </a:r>
+          </a:p>
+        </p:txBody>
+      </p:sp>
+      <p:sp>
+        <p:nvSpPr>
+          <p:cNvPr id="10" name="TextBox 9"/>
           <p:cNvSpPr txBox="1"/>
           <p:nvPr/>
         </p:nvSpPr>
         <p:spPr>
           <a:xfrm>
-            <a:off x="914400" y="5349240"/>
-            <a:ext cx="3017520" cy="685800"/>
+            <a:off x="640080" y="8961120"/>
+            <a:ext cx="6492240" cy="365760"/>
           </a:xfrm>
           <a:prstGeom prst="rect">
             <a:avLst/>
@@ -3537,7 +3492,7 @@
           <a:lstStyle/>
           <a:p>
             <a:pPr>
-              <a:defRPr sz="900">
+              <a:defRPr sz="1000">
                 <a:solidFill>
                   <a:srgbClr val="64748B"/>
                 </a:solidFill>
@@ -3545,252 +3500,15 @@
               </a:defRPr>
             </a:pPr>
             <a:r>
-              <a:t>UNIVERSE SCOPE</a:t>
-            </a:r>
-          </a:p>
-          <a:p>
-            <a:pPr>
-              <a:defRPr sz="1300" b="1">
-                <a:solidFill>
-                  <a:srgbClr val="F8FAFC"/>
-                </a:solidFill>
-                <a:latin typeface="Consolas"/>
-              </a:defRPr>
-            </a:pPr>
-            <a:r>
-              <a:t>26 Equities + ASPI</a:t>
-            </a:r>
-          </a:p>
-        </p:txBody>
-      </p:sp>
-      <p:sp>
-        <p:nvSpPr>
-          <p:cNvPr id="12" name="Rectangle 11"/>
-          <p:cNvSpPr/>
-          <p:nvPr/>
-        </p:nvSpPr>
-        <p:spPr>
-          <a:xfrm>
-            <a:off x="4389120" y="5303520"/>
-            <a:ext cx="3383280" cy="777240"/>
-          </a:xfrm>
-          <a:prstGeom prst="rect">
-            <a:avLst/>
-          </a:prstGeom>
-          <a:solidFill>
-            <a:srgbClr val="121824"/>
-          </a:solidFill>
-          <a:ln w="19050">
-            <a:solidFill>
-              <a:srgbClr val="222D3D"/>
-            </a:solidFill>
-          </a:ln>
-        </p:spPr>
-        <p:style>
-          <a:lnRef idx="1">
-            <a:schemeClr val="accent1"/>
-          </a:lnRef>
-          <a:fillRef idx="3">
-            <a:schemeClr val="accent1"/>
-          </a:fillRef>
-          <a:effectRef idx="2">
-            <a:schemeClr val="accent1"/>
-          </a:effectRef>
-          <a:fontRef idx="minor">
-            <a:schemeClr val="lt1"/>
-          </a:fontRef>
-        </p:style>
-        <p:txBody>
-          <a:bodyPr rtlCol="0" anchor="ctr"/>
-          <a:lstStyle/>
-          <a:p>
-            <a:pPr algn="ctr"/>
-          </a:p>
-        </p:txBody>
-      </p:sp>
-      <p:sp>
-        <p:nvSpPr>
-          <p:cNvPr id="13" name="TextBox 12"/>
-          <p:cNvSpPr txBox="1"/>
-          <p:nvPr/>
-        </p:nvSpPr>
-        <p:spPr>
-          <a:xfrm>
-            <a:off x="4572000" y="5349240"/>
-            <a:ext cx="3017520" cy="685800"/>
-          </a:xfrm>
-          <a:prstGeom prst="rect">
-            <a:avLst/>
-          </a:prstGeom>
-          <a:noFill/>
-        </p:spPr>
-        <p:txBody>
-          <a:bodyPr wrap="none">
-            <a:spAutoFit/>
-          </a:bodyPr>
-          <a:lstStyle/>
-          <a:p>
-            <a:pPr>
-              <a:defRPr sz="900">
-                <a:solidFill>
-                  <a:srgbClr val="64748B"/>
-                </a:solidFill>
-                <a:latin typeface="Consolas"/>
-              </a:defRPr>
-            </a:pPr>
-            <a:r>
-              <a:t>FORECAST HORIZON</a:t>
-            </a:r>
-          </a:p>
-          <a:p>
-            <a:pPr>
-              <a:defRPr sz="1300" b="1">
+              <a:t>COLOMBO STOCK EXCHANGE (CSE) MLOPS</a:t>
+            </a:r>
+            <a:r>
+              <a:rPr b="1">
                 <a:solidFill>
                   <a:srgbClr val="38BDF8"/>
                 </a:solidFill>
-                <a:latin typeface="Consolas"/>
-              </a:defRPr>
-            </a:pPr>
-            <a:r>
-              <a:t>30 Trading Days</a:t>
-            </a:r>
-          </a:p>
-        </p:txBody>
-      </p:sp>
-      <p:sp>
-        <p:nvSpPr>
-          <p:cNvPr id="14" name="Rectangle 13"/>
-          <p:cNvSpPr/>
-          <p:nvPr/>
-        </p:nvSpPr>
-        <p:spPr>
-          <a:xfrm>
-            <a:off x="8046720" y="5303520"/>
-            <a:ext cx="3383280" cy="777240"/>
-          </a:xfrm>
-          <a:prstGeom prst="rect">
-            <a:avLst/>
-          </a:prstGeom>
-          <a:solidFill>
-            <a:srgbClr val="121824"/>
-          </a:solidFill>
-          <a:ln w="19050">
-            <a:solidFill>
-              <a:srgbClr val="222D3D"/>
-            </a:solidFill>
-          </a:ln>
-        </p:spPr>
-        <p:style>
-          <a:lnRef idx="1">
-            <a:schemeClr val="accent1"/>
-          </a:lnRef>
-          <a:fillRef idx="3">
-            <a:schemeClr val="accent1"/>
-          </a:fillRef>
-          <a:effectRef idx="2">
-            <a:schemeClr val="accent1"/>
-          </a:effectRef>
-          <a:fontRef idx="minor">
-            <a:schemeClr val="lt1"/>
-          </a:fontRef>
-        </p:style>
-        <p:txBody>
-          <a:bodyPr rtlCol="0" anchor="ctr"/>
-          <a:lstStyle/>
-          <a:p>
-            <a:pPr algn="ctr"/>
-          </a:p>
-        </p:txBody>
-      </p:sp>
-      <p:sp>
-        <p:nvSpPr>
-          <p:cNvPr id="15" name="TextBox 14"/>
-          <p:cNvSpPr txBox="1"/>
-          <p:nvPr/>
-        </p:nvSpPr>
-        <p:spPr>
-          <a:xfrm>
-            <a:off x="8229600" y="5349240"/>
-            <a:ext cx="3017520" cy="685800"/>
-          </a:xfrm>
-          <a:prstGeom prst="rect">
-            <a:avLst/>
-          </a:prstGeom>
-          <a:noFill/>
-        </p:spPr>
-        <p:txBody>
-          <a:bodyPr wrap="none">
-            <a:spAutoFit/>
-          </a:bodyPr>
-          <a:lstStyle/>
-          <a:p>
-            <a:pPr>
-              <a:defRPr sz="900">
-                <a:solidFill>
-                  <a:srgbClr val="64748B"/>
-                </a:solidFill>
-                <a:latin typeface="Consolas"/>
-              </a:defRPr>
-            </a:pPr>
-            <a:r>
-              <a:t>OPTIMIZATION</a:t>
-            </a:r>
-          </a:p>
-          <a:p>
-            <a:pPr>
-              <a:defRPr sz="1300" b="1">
-                <a:solidFill>
-                  <a:srgbClr val="34D399"/>
-                </a:solidFill>
-                <a:latin typeface="Consolas"/>
-              </a:defRPr>
-            </a:pPr>
-            <a:r>
-              <a:t>Pinball Quantiles [P10, P50, P90]</a:t>
-            </a:r>
-          </a:p>
-        </p:txBody>
-      </p:sp>
-      <p:sp>
-        <p:nvSpPr>
-          <p:cNvPr id="16" name="TextBox 15"/>
-          <p:cNvSpPr txBox="1"/>
-          <p:nvPr/>
-        </p:nvSpPr>
-        <p:spPr>
-          <a:xfrm>
-            <a:off x="731520" y="6263640"/>
-            <a:ext cx="10698480" cy="365760"/>
-          </a:xfrm>
-          <a:prstGeom prst="rect">
-            <a:avLst/>
-          </a:prstGeom>
-          <a:noFill/>
-        </p:spPr>
-        <p:txBody>
-          <a:bodyPr wrap="none">
-            <a:spAutoFit/>
-          </a:bodyPr>
-          <a:lstStyle/>
-          <a:p>
-            <a:pPr>
-              <a:defRPr sz="1000">
-                <a:solidFill>
-                  <a:srgbClr val="64748B"/>
-                </a:solidFill>
-                <a:latin typeface="Consolas"/>
-              </a:defRPr>
-            </a:pPr>
-            <a:r>
-              <a:t>COLOMBO STOCK EXCHANGE QUANTITATIVE INTELLIGENCE</a:t>
-            </a:r>
-            <a:r>
-              <a:rPr b="1">
-                <a:solidFill>
-                  <a:srgbClr val="38BDF8"/>
-                </a:solidFill>
               </a:rPr>
-              <a:t>   |   [01 / 05]</a:t>
+              <a:t>   |   Swipe &gt;</a:t>
             </a:r>
           </a:p>
         </p:txBody>
@@ -3822,7 +3540,7 @@
         <p:spPr>
           <a:xfrm>
             <a:off x="0" y="0"/>
-            <a:ext cx="12191695" cy="6858000"/>
+            <a:ext cx="7772400" cy="9715500"/>
           </a:xfrm>
           <a:prstGeom prst="rect">
             <a:avLst/>
@@ -3864,8 +3582,8 @@
         </p:nvSpPr>
         <p:spPr>
           <a:xfrm>
-            <a:off x="731520" y="365760"/>
-            <a:ext cx="10515600" cy="320040"/>
+            <a:off x="640080" y="640080"/>
+            <a:ext cx="6492240" cy="320040"/>
           </a:xfrm>
           <a:prstGeom prst="rect">
             <a:avLst/>
@@ -3873,7 +3591,7 @@
           <a:noFill/>
         </p:spPr>
         <p:txBody>
-          <a:bodyPr wrap="square">
+          <a:bodyPr wrap="none">
             <a:spAutoFit/>
           </a:bodyPr>
           <a:lstStyle/>
@@ -3887,7 +3605,7 @@
               </a:defRPr>
             </a:pPr>
             <a:r>
-              <a:t>[ SYSTEM ARCHITECTURE ]</a:t>
+              <a:t>[ 02 / UNCERTAINTY CONES ]</a:t>
             </a:r>
           </a:p>
         </p:txBody>
@@ -3900,8 +3618,8 @@
         </p:nvSpPr>
         <p:spPr>
           <a:xfrm>
-            <a:off x="731520" y="685800"/>
-            <a:ext cx="10698480" cy="640080"/>
+            <a:off x="640080" y="1005840"/>
+            <a:ext cx="6492240" cy="1097280"/>
           </a:xfrm>
           <a:prstGeom prst="rect">
             <a:avLst/>
@@ -3915,7 +3633,7 @@
           <a:lstStyle/>
           <a:p>
             <a:pPr>
-              <a:defRPr sz="2600" b="1">
+              <a:defRPr sz="2800" b="1">
                 <a:solidFill>
                   <a:srgbClr val="F8FAFC"/>
                 </a:solidFill>
@@ -3923,7 +3641,7 @@
               </a:defRPr>
             </a:pPr>
             <a:r>
-              <a:t>End-to-End MLOps Pipeline</a:t>
+              <a:t>Replacing Point Estimates with Risk Envelopes</a:t>
             </a:r>
           </a:p>
         </p:txBody>
@@ -3936,8 +3654,8 @@
         </p:nvSpPr>
         <p:spPr>
           <a:xfrm>
-            <a:off x="731520" y="1280160"/>
-            <a:ext cx="10698480" cy="411480"/>
+            <a:off x="640080" y="2148840"/>
+            <a:ext cx="6492240" cy="822960"/>
           </a:xfrm>
           <a:prstGeom prst="rect">
             <a:avLst/>
@@ -3951,7 +3669,7 @@
           <a:lstStyle/>
           <a:p>
             <a:pPr>
-              <a:defRPr sz="1300">
+              <a:defRPr sz="1400">
                 <a:solidFill>
                   <a:srgbClr val="94A3B8"/>
                 </a:solidFill>
@@ -3959,7 +3677,7 @@
               </a:defRPr>
             </a:pPr>
             <a:r>
-              <a:t>A decoupled, zero-leakage workflow from raw exchange endpoints to an interactive trading cockpit.</a:t>
+              <a:t>Markets are probabilistic. We train three Multi-Quantile LightGBM models minimizing Pinball Loss.</a:t>
             </a:r>
           </a:p>
         </p:txBody>
@@ -3972,18 +3690,18 @@
         </p:nvSpPr>
         <p:spPr>
           <a:xfrm>
-            <a:off x="731520" y="1828800"/>
-            <a:ext cx="10698480" cy="914400"/>
+            <a:off x="640080" y="3291840"/>
+            <a:ext cx="6492240" cy="1554480"/>
           </a:xfrm>
           <a:prstGeom prst="rect">
             <a:avLst/>
           </a:prstGeom>
           <a:solidFill>
-            <a:srgbClr val="121824"/>
+            <a:srgbClr val="111722"/>
           </a:solidFill>
           <a:ln w="19050">
             <a:solidFill>
-              <a:srgbClr val="38BDF8"/>
+              <a:srgbClr val="F87171"/>
             </a:solidFill>
           </a:ln>
         </p:spPr>
@@ -4017,8 +3735,8 @@
         </p:nvSpPr>
         <p:spPr>
           <a:xfrm>
-            <a:off x="914400" y="1901952"/>
-            <a:ext cx="10332720" cy="777240"/>
+            <a:off x="822960" y="3401568"/>
+            <a:ext cx="6126480" cy="1280160"/>
           </a:xfrm>
           <a:prstGeom prst="rect">
             <a:avLst/>
@@ -4032,49 +3750,40 @@
           <a:lstStyle/>
           <a:p>
             <a:pPr>
-              <a:defRPr sz="1100" b="1">
-                <a:solidFill>
-                  <a:srgbClr val="38BDF8"/>
-                </a:solidFill>
-                <a:latin typeface="Consolas"/>
+              <a:defRPr sz="1600" b="1">
+                <a:solidFill>
+                  <a:srgbClr val="F87171"/>
+                </a:solidFill>
+                <a:latin typeface="Trebuchet MS"/>
               </a:defRPr>
             </a:pPr>
             <a:r>
-              <a:t>[STAGE 01]  </a:t>
-            </a:r>
-            <a:r>
-              <a:rPr sz="1300" b="1">
-                <a:solidFill>
-                  <a:srgbClr val="F8FAFC"/>
-                </a:solidFill>
-                <a:latin typeface="Trebuchet MS"/>
-              </a:rPr>
-              <a:t>CSE API Ingestion &amp; Lakehouse   </a:t>
-            </a:r>
-            <a:r>
-              <a:rPr sz="1000">
-                <a:solidFill>
-                  <a:srgbClr val="94A3B8"/>
+              <a:t>P10 Floor   </a:t>
+            </a:r>
+            <a:r>
+              <a:rPr sz="1100">
+                <a:solidFill>
+                  <a:srgbClr val="64748B"/>
                 </a:solidFill>
                 <a:latin typeface="Consolas"/>
               </a:rPr>
-              <a:t>[data/processed/*.parquet]</a:t>
+              <a:t>[Quantile 0.10]</a:t>
             </a:r>
           </a:p>
           <a:p>
             <a:pPr>
               <a:spcBef>
-                <a:spcPts val="300"/>
+                <a:spcPts val="600"/>
               </a:spcBef>
-              <a:defRPr sz="1100">
-                <a:solidFill>
-                  <a:srgbClr val="94A3B8"/>
+              <a:defRPr sz="1300">
+                <a:solidFill>
+                  <a:srgbClr val="F8FAFC"/>
                 </a:solidFill>
                 <a:latin typeface="Calibri"/>
               </a:defRPr>
             </a:pPr>
             <a:r>
-              <a:t>Direct JSON ingestion from official CSE endpoints (daily bars + ASPI series). Partitioned zero-copy Parquet lakehouse architecture with sub-millisecond columnar read performance.</a:t>
+              <a:t>Downside Value-at-Risk support boundary. Penalizes extreme drawdowns 9x more than upside misses.</a:t>
             </a:r>
           </a:p>
         </p:txBody>
@@ -4087,14 +3796,14 @@
         </p:nvSpPr>
         <p:spPr>
           <a:xfrm>
-            <a:off x="731520" y="2880360"/>
-            <a:ext cx="10698480" cy="914400"/>
+            <a:off x="640080" y="5074920"/>
+            <a:ext cx="6492240" cy="1554480"/>
           </a:xfrm>
           <a:prstGeom prst="rect">
             <a:avLst/>
           </a:prstGeom>
           <a:solidFill>
-            <a:srgbClr val="121824"/>
+            <a:srgbClr val="111722"/>
           </a:solidFill>
           <a:ln w="19050">
             <a:solidFill>
@@ -4132,8 +3841,8 @@
         </p:nvSpPr>
         <p:spPr>
           <a:xfrm>
-            <a:off x="914400" y="2953512"/>
-            <a:ext cx="10332720" cy="777240"/>
+            <a:off x="822960" y="5184648"/>
+            <a:ext cx="6126480" cy="1280160"/>
           </a:xfrm>
           <a:prstGeom prst="rect">
             <a:avLst/>
@@ -4147,49 +3856,40 @@
           <a:lstStyle/>
           <a:p>
             <a:pPr>
-              <a:defRPr sz="1100" b="1">
+              <a:defRPr sz="1600" b="1">
                 <a:solidFill>
                   <a:srgbClr val="38BDF8"/>
                 </a:solidFill>
-                <a:latin typeface="Consolas"/>
+                <a:latin typeface="Trebuchet MS"/>
               </a:defRPr>
             </a:pPr>
             <a:r>
-              <a:t>[STAGE 02]  </a:t>
-            </a:r>
-            <a:r>
-              <a:rPr sz="1300" b="1">
-                <a:solidFill>
-                  <a:srgbClr val="F8FAFC"/>
-                </a:solidFill>
-                <a:latin typeface="Trebuchet MS"/>
-              </a:rPr>
-              <a:t>Vectorized Feature Store   </a:t>
-            </a:r>
-            <a:r>
-              <a:rPr sz="1000">
-                <a:solidFill>
-                  <a:srgbClr val="94A3B8"/>
+              <a:t>P50 Median   </a:t>
+            </a:r>
+            <a:r>
+              <a:rPr sz="1100">
+                <a:solidFill>
+                  <a:srgbClr val="64748B"/>
                 </a:solidFill>
                 <a:latin typeface="Consolas"/>
               </a:rPr>
-              <a:t>[22 Microstructure Indicators]</a:t>
+              <a:t>[Quantile 0.50]</a:t>
             </a:r>
           </a:p>
           <a:p>
             <a:pPr>
               <a:spcBef>
-                <a:spcPts val="300"/>
+                <a:spcPts val="600"/>
               </a:spcBef>
-              <a:defRPr sz="1100">
-                <a:solidFill>
-                  <a:srgbClr val="94A3B8"/>
+              <a:defRPr sz="1300">
+                <a:solidFill>
+                  <a:srgbClr val="F8FAFC"/>
                 </a:solidFill>
                 <a:latin typeface="Calibri"/>
               </a:defRPr>
             </a:pPr>
             <a:r>
-              <a:t>Zero-leakage backward rolling feature engineering: 5x more efficient Parkinson high-low volatility, Wilder RSI(14), MACD histogram, volume expansion ratios, and ASPI relative return spreads.</a:t>
+              <a:t>Expected median return trajectory. Minimizes MAE, robust against illiquid price spikes.</a:t>
             </a:r>
           </a:p>
         </p:txBody>
@@ -4202,18 +3902,18 @@
         </p:nvSpPr>
         <p:spPr>
           <a:xfrm>
-            <a:off x="731520" y="3931920"/>
-            <a:ext cx="10698480" cy="914400"/>
+            <a:off x="640080" y="6858000"/>
+            <a:ext cx="6492240" cy="1554480"/>
           </a:xfrm>
           <a:prstGeom prst="rect">
             <a:avLst/>
           </a:prstGeom>
           <a:solidFill>
-            <a:srgbClr val="121824"/>
+            <a:srgbClr val="111722"/>
           </a:solidFill>
           <a:ln w="19050">
             <a:solidFill>
-              <a:srgbClr val="38BDF8"/>
+              <a:srgbClr val="34D399"/>
             </a:solidFill>
           </a:ln>
         </p:spPr>
@@ -4247,8 +3947,8 @@
         </p:nvSpPr>
         <p:spPr>
           <a:xfrm>
-            <a:off x="914400" y="4005072"/>
-            <a:ext cx="10332720" cy="777240"/>
+            <a:off x="822960" y="6967728"/>
+            <a:ext cx="6126480" cy="1280160"/>
           </a:xfrm>
           <a:prstGeom prst="rect">
             <a:avLst/>
@@ -4262,108 +3962,54 @@
           <a:lstStyle/>
           <a:p>
             <a:pPr>
-              <a:defRPr sz="1100" b="1">
-                <a:solidFill>
-                  <a:srgbClr val="38BDF8"/>
-                </a:solidFill>
-                <a:latin typeface="Consolas"/>
+              <a:defRPr sz="1600" b="1">
+                <a:solidFill>
+                  <a:srgbClr val="34D399"/>
+                </a:solidFill>
+                <a:latin typeface="Trebuchet MS"/>
               </a:defRPr>
             </a:pPr>
             <a:r>
-              <a:t>[STAGE 03]  </a:t>
-            </a:r>
-            <a:r>
-              <a:rPr sz="1300" b="1">
-                <a:solidFill>
-                  <a:srgbClr val="F8FAFC"/>
-                </a:solidFill>
-                <a:latin typeface="Trebuchet MS"/>
-              </a:rPr>
-              <a:t>Purged CV &amp; Quantile Training   </a:t>
-            </a:r>
-            <a:r>
-              <a:rPr sz="1000">
-                <a:solidFill>
-                  <a:srgbClr val="94A3B8"/>
+              <a:t>P90 Ceiling   </a:t>
+            </a:r>
+            <a:r>
+              <a:rPr sz="1100">
+                <a:solidFill>
+                  <a:srgbClr val="64748B"/>
                 </a:solidFill>
                 <a:latin typeface="Consolas"/>
               </a:rPr>
-              <a:t>[Pinball Loss [P10, P50, P90]]</a:t>
+              <a:t>[Quantile 0.90]</a:t>
             </a:r>
           </a:p>
           <a:p>
             <a:pPr>
               <a:spcBef>
-                <a:spcPts val="300"/>
+                <a:spcPts val="600"/>
               </a:spcBef>
-              <a:defRPr sz="1100">
-                <a:solidFill>
-                  <a:srgbClr val="94A3B8"/>
+              <a:defRPr sz="1300">
+                <a:solidFill>
+                  <a:srgbClr val="F8FAFC"/>
                 </a:solidFill>
                 <a:latin typeface="Calibri"/>
               </a:defRPr>
             </a:pPr>
             <a:r>
-              <a:t>5-fold expanding walk-forward validation with a strict 30-day embargo gap. Tri-quantile LightGBM models serialized to disk (&lt;200 KB per model) with benchmark tournaments vs Prophet and Random Walk.</a:t>
-            </a:r>
-          </a:p>
-        </p:txBody>
-      </p:sp>
-      <p:sp>
-        <p:nvSpPr>
-          <p:cNvPr id="12" name="Rectangle 11"/>
-          <p:cNvSpPr/>
-          <p:nvPr/>
-        </p:nvSpPr>
-        <p:spPr>
-          <a:xfrm>
-            <a:off x="731520" y="4983479"/>
-            <a:ext cx="10698480" cy="914400"/>
-          </a:xfrm>
-          <a:prstGeom prst="rect">
-            <a:avLst/>
-          </a:prstGeom>
-          <a:solidFill>
-            <a:srgbClr val="121824"/>
-          </a:solidFill>
-          <a:ln w="19050">
-            <a:solidFill>
-              <a:srgbClr val="38BDF8"/>
-            </a:solidFill>
-          </a:ln>
-        </p:spPr>
-        <p:style>
-          <a:lnRef idx="1">
-            <a:schemeClr val="accent1"/>
-          </a:lnRef>
-          <a:fillRef idx="3">
-            <a:schemeClr val="accent1"/>
-          </a:fillRef>
-          <a:effectRef idx="2">
-            <a:schemeClr val="accent1"/>
-          </a:effectRef>
-          <a:fontRef idx="minor">
-            <a:schemeClr val="lt1"/>
-          </a:fontRef>
-        </p:style>
-        <p:txBody>
-          <a:bodyPr rtlCol="0" anchor="ctr"/>
-          <a:lstStyle/>
-          <a:p>
-            <a:pPr algn="ctr"/>
-          </a:p>
-        </p:txBody>
-      </p:sp>
-      <p:sp>
-        <p:nvSpPr>
-          <p:cNvPr id="13" name="TextBox 12"/>
+              <a:t>Bullish expansion envelope indicating upper momentum resistance levels.</a:t>
+            </a:r>
+          </a:p>
+        </p:txBody>
+      </p:sp>
+      <p:sp>
+        <p:nvSpPr>
+          <p:cNvPr id="12" name="TextBox 11"/>
           <p:cNvSpPr txBox="1"/>
           <p:nvPr/>
         </p:nvSpPr>
         <p:spPr>
           <a:xfrm>
-            <a:off x="914400" y="5056631"/>
-            <a:ext cx="10332720" cy="777240"/>
+            <a:off x="640080" y="8961120"/>
+            <a:ext cx="6492240" cy="365760"/>
           </a:xfrm>
           <a:prstGeom prst="rect">
             <a:avLst/>
@@ -4371,76 +4017,6 @@
           <a:noFill/>
         </p:spPr>
         <p:txBody>
-          <a:bodyPr wrap="square">
-            <a:spAutoFit/>
-          </a:bodyPr>
-          <a:lstStyle/>
-          <a:p>
-            <a:pPr>
-              <a:defRPr sz="1100" b="1">
-                <a:solidFill>
-                  <a:srgbClr val="38BDF8"/>
-                </a:solidFill>
-                <a:latin typeface="Consolas"/>
-              </a:defRPr>
-            </a:pPr>
-            <a:r>
-              <a:t>[STAGE 04]  </a:t>
-            </a:r>
-            <a:r>
-              <a:rPr sz="1300" b="1">
-                <a:solidFill>
-                  <a:srgbClr val="F8FAFC"/>
-                </a:solidFill>
-                <a:latin typeface="Trebuchet MS"/>
-              </a:rPr>
-              <a:t>Serving REST API &amp; Cockpit   </a:t>
-            </a:r>
-            <a:r>
-              <a:rPr sz="1000">
-                <a:solidFill>
-                  <a:srgbClr val="94A3B8"/>
-                </a:solidFill>
-                <a:latin typeface="Consolas"/>
-              </a:rPr>
-              <a:t>[FastAPI + React 19 + TradingView]</a:t>
-            </a:r>
-          </a:p>
-          <a:p>
-            <a:pPr>
-              <a:spcBef>
-                <a:spcPts val="300"/>
-              </a:spcBef>
-              <a:defRPr sz="1100">
-                <a:solidFill>
-                  <a:srgbClr val="94A3B8"/>
-                </a:solidFill>
-                <a:latin typeface="Calibri"/>
-              </a:defRPr>
-            </a:pPr>
-            <a:r>
-              <a:t>Production FastAPI microservice delivering dynamic 30-day quantile trajectories, exact TreeSHAP attributions, and institutional heuristic validation cards rendered via TradingView Lightweight Charts.</a:t>
-            </a:r>
-          </a:p>
-        </p:txBody>
-      </p:sp>
-      <p:sp>
-        <p:nvSpPr>
-          <p:cNvPr id="14" name="TextBox 13"/>
-          <p:cNvSpPr txBox="1"/>
-          <p:nvPr/>
-        </p:nvSpPr>
-        <p:spPr>
-          <a:xfrm>
-            <a:off x="731520" y="6263640"/>
-            <a:ext cx="10698480" cy="365760"/>
-          </a:xfrm>
-          <a:prstGeom prst="rect">
-            <a:avLst/>
-          </a:prstGeom>
-          <a:noFill/>
-        </p:spPr>
-        <p:txBody>
           <a:bodyPr wrap="none">
             <a:spAutoFit/>
           </a:bodyPr>
@@ -4455,7 +4031,7 @@
               </a:defRPr>
             </a:pPr>
             <a:r>
-              <a:t>DECOUPLED LAKEHOUSE ARCHITECTURE</a:t>
+              <a:t>COLOMBO STOCK EXCHANGE (CSE) MLOPS</a:t>
             </a:r>
             <a:r>
               <a:rPr b="1">
@@ -4463,7 +4039,7 @@
                   <a:srgbClr val="38BDF8"/>
                 </a:solidFill>
               </a:rPr>
-              <a:t>   |   [02 / 05]</a:t>
+              <a:t>   |   Swipe &gt;</a:t>
             </a:r>
           </a:p>
         </p:txBody>
@@ -4495,7 +4071,7 @@
         <p:spPr>
           <a:xfrm>
             <a:off x="0" y="0"/>
-            <a:ext cx="12191695" cy="6858000"/>
+            <a:ext cx="7772400" cy="9715500"/>
           </a:xfrm>
           <a:prstGeom prst="rect">
             <a:avLst/>
@@ -4537,8 +4113,8 @@
         </p:nvSpPr>
         <p:spPr>
           <a:xfrm>
-            <a:off x="731520" y="365760"/>
-            <a:ext cx="10515600" cy="320040"/>
+            <a:off x="640080" y="640080"/>
+            <a:ext cx="6492240" cy="320040"/>
           </a:xfrm>
           <a:prstGeom prst="rect">
             <a:avLst/>
@@ -4546,7 +4122,7 @@
           <a:noFill/>
         </p:spPr>
         <p:txBody>
-          <a:bodyPr wrap="square">
+          <a:bodyPr wrap="none">
             <a:spAutoFit/>
           </a:bodyPr>
           <a:lstStyle/>
@@ -4560,7 +4136,7 @@
               </a:defRPr>
             </a:pPr>
             <a:r>
-              <a:t>[ VALIDATION &amp; RISK ENGINE ]</a:t>
+              <a:t>[ 03 / VALIDATION RIGOR ]</a:t>
             </a:r>
           </a:p>
         </p:txBody>
@@ -4573,8 +4149,8 @@
         </p:nvSpPr>
         <p:spPr>
           <a:xfrm>
-            <a:off x="731520" y="685800"/>
-            <a:ext cx="10698480" cy="640080"/>
+            <a:off x="640080" y="1005840"/>
+            <a:ext cx="6492240" cy="1097280"/>
           </a:xfrm>
           <a:prstGeom prst="rect">
             <a:avLst/>
@@ -4588,7 +4164,7 @@
           <a:lstStyle/>
           <a:p>
             <a:pPr>
-              <a:defRPr sz="2600" b="1">
+              <a:defRPr sz="2800" b="1">
                 <a:solidFill>
                   <a:srgbClr val="F8FAFC"/>
                 </a:solidFill>
@@ -4596,7 +4172,7 @@
               </a:defRPr>
             </a:pPr>
             <a:r>
-              <a:t>Purged Cross-Validation &amp; Pinball Cones</a:t>
+              <a:t>Zero Lookahead Leakage: Purged &amp; Embargoed CV</a:t>
             </a:r>
           </a:p>
         </p:txBody>
@@ -4609,8 +4185,8 @@
         </p:nvSpPr>
         <p:spPr>
           <a:xfrm>
-            <a:off x="731520" y="1280160"/>
-            <a:ext cx="10698480" cy="411480"/>
+            <a:off x="640080" y="2148840"/>
+            <a:ext cx="6492240" cy="822960"/>
           </a:xfrm>
           <a:prstGeom prst="rect">
             <a:avLst/>
@@ -4624,7 +4200,7 @@
           <a:lstStyle/>
           <a:p>
             <a:pPr>
-              <a:defRPr sz="1300">
+              <a:defRPr sz="1400">
                 <a:solidFill>
                   <a:srgbClr val="94A3B8"/>
                 </a:solidFill>
@@ -4632,7 +4208,7 @@
               </a:defRPr>
             </a:pPr>
             <a:r>
-              <a:t>Eliminating overlapping label contamination and replacing fragile single-point estimates with asymmetric risk envelopes.</a:t>
+              <a:t>A 30-day forward return target leaks data if standard K-Fold CV is used. We enforce a 30-day purge buffer.</a:t>
             </a:r>
           </a:p>
         </p:txBody>
@@ -4645,14 +4221,14 @@
         </p:nvSpPr>
         <p:spPr>
           <a:xfrm>
-            <a:off x="731520" y="1828800"/>
-            <a:ext cx="5212080" cy="4206240"/>
+            <a:off x="640080" y="3291840"/>
+            <a:ext cx="6492240" cy="2377440"/>
           </a:xfrm>
           <a:prstGeom prst="rect">
             <a:avLst/>
           </a:prstGeom>
           <a:solidFill>
-            <a:srgbClr val="121824"/>
+            <a:srgbClr val="111722"/>
           </a:solidFill>
           <a:ln w="19050">
             <a:solidFill>
@@ -4690,8 +4266,8 @@
         </p:nvSpPr>
         <p:spPr>
           <a:xfrm>
-            <a:off x="914400" y="1965960"/>
-            <a:ext cx="4846320" cy="3931920"/>
+            <a:off x="822960" y="3429000"/>
+            <a:ext cx="6126480" cy="2103120"/>
           </a:xfrm>
           <a:prstGeom prst="rect">
             <a:avLst/>
@@ -4705,75 +4281,39 @@
           <a:lstStyle/>
           <a:p>
             <a:pPr>
-              <a:defRPr sz="1400" b="1">
-                <a:solidFill>
-                  <a:srgbClr val="F8FAFC"/>
-                </a:solidFill>
-                <a:latin typeface="Trebuchet MS"/>
+              <a:defRPr sz="1100" b="1">
+                <a:solidFill>
+                  <a:srgbClr val="38BDF8"/>
+                </a:solidFill>
+                <a:latin typeface="Consolas"/>
               </a:defRPr>
             </a:pPr>
             <a:r>
-              <a:t>Leakage-Free Purged &amp; Embargoed Walk-Forward CV</a:t>
+              <a:t>[ 5-FOLD EXPANDING TIMELINE WITH EMBARGO ]</a:t>
             </a:r>
           </a:p>
           <a:p>
             <a:pPr>
               <a:spcBef>
-                <a:spcPts val="800"/>
+                <a:spcPts val="1000"/>
               </a:spcBef>
-              <a:defRPr sz="1200">
-                <a:solidFill>
-                  <a:srgbClr val="94A3B8"/>
-                </a:solidFill>
-                <a:latin typeface="Calibri"/>
+              <a:defRPr sz="1000">
+                <a:solidFill>
+                  <a:srgbClr val="F8FAFC"/>
+                </a:solidFill>
+                <a:latin typeface="Consolas"/>
               </a:defRPr>
             </a:pPr>
             <a:r>
-              <a:t>Standard random K-Fold CV destroys temporal sequence and leaks future signals. Because targets span forward 30 trading days, training bars within 30 days of the test window share overlapping return labels.</a:t>
-            </a:r>
-          </a:p>
-          <a:p>
-            <a:pPr>
-              <a:spcBef>
-                <a:spcPts val="1200"/>
-              </a:spcBef>
-              <a:defRPr sz="1100" b="1">
-                <a:solidFill>
-                  <a:srgbClr val="38BDF8"/>
-                </a:solidFill>
-                <a:latin typeface="Consolas"/>
-              </a:defRPr>
-            </a:pPr>
-            <a:r>
-              <a:t>Chronological 5-Fold Validation Scheme:</a:t>
-            </a:r>
-          </a:p>
-          <a:p>
-            <a:pPr>
-              <a:spcBef>
-                <a:spcPts val="600"/>
-              </a:spcBef>
-              <a:defRPr sz="950">
-                <a:solidFill>
-                  <a:srgbClr val="F8FAFC"/>
-                </a:solidFill>
-                <a:latin typeface="Consolas"/>
-              </a:defRPr>
-            </a:pPr>
-            <a:r>
-              <a:t>Time ────────────────────────────────────────►</a:t>
+              <a:t>Fold 1: [== Train ==] [Purge: 30d] [Test: 60d] [Embargo: 30d]</a:t>
             </a:r>
             <a:br/>
             <a:r>
-              <a:t>Fold 1: [== Train (250d) ==] [Purge: 30d] [Test: 60d] [Embargo: 30d]</a:t>
+              <a:t>Fold 2: [==== Train ====] [Purge: 30d] [Test: 60d] [Embargo: 30d]</a:t>
             </a:r>
             <a:br/>
             <a:r>
-              <a:t>Fold 2: [==== Train (310d) ====] [Purge: 30d] [Test: 60d] [Embargo: 30d]</a:t>
-            </a:r>
-            <a:br/>
-            <a:r>
-              <a:t>Fold 3: [====== Train (370d) ======] [Purge: 30d] [Test: 60d] ...</a:t>
+              <a:t>Fold 3: [====== Train ======] [Purge: 30d] [Test: 60d] ...</a:t>
             </a:r>
           </a:p>
         </p:txBody>
@@ -4786,18 +4326,18 @@
         </p:nvSpPr>
         <p:spPr>
           <a:xfrm>
-            <a:off x="6217920" y="1828800"/>
-            <a:ext cx="5212080" cy="4206240"/>
+            <a:off x="640080" y="5943600"/>
+            <a:ext cx="3154680" cy="2377440"/>
           </a:xfrm>
           <a:prstGeom prst="rect">
             <a:avLst/>
           </a:prstGeom>
           <a:solidFill>
-            <a:srgbClr val="121824"/>
+            <a:srgbClr val="111722"/>
           </a:solidFill>
           <a:ln w="19050">
             <a:solidFill>
-              <a:srgbClr val="34D399"/>
+              <a:srgbClr val="38BDF8"/>
             </a:solidFill>
           </a:ln>
         </p:spPr>
@@ -4831,8 +4371,8 @@
         </p:nvSpPr>
         <p:spPr>
           <a:xfrm>
-            <a:off x="6400800" y="1965960"/>
-            <a:ext cx="4846320" cy="3931920"/>
+            <a:off x="822960" y="6080760"/>
+            <a:ext cx="2788920" cy="2103120"/>
           </a:xfrm>
           <a:prstGeom prst="rect">
             <a:avLst/>
@@ -4846,141 +4386,90 @@
           <a:lstStyle/>
           <a:p>
             <a:pPr>
-              <a:defRPr sz="1400" b="1">
-                <a:solidFill>
-                  <a:srgbClr val="F8FAFC"/>
-                </a:solidFill>
-                <a:latin typeface="Trebuchet MS"/>
+              <a:defRPr sz="1300" b="1">
+                <a:solidFill>
+                  <a:srgbClr val="38BDF8"/>
+                </a:solidFill>
+                <a:latin typeface="Consolas"/>
               </a:defRPr>
             </a:pPr>
             <a:r>
-              <a:t>Asymmetric Pinball Quantile Distribution</a:t>
+              <a:t>30-DAY PURGE</a:t>
             </a:r>
           </a:p>
           <a:p>
             <a:pPr>
               <a:spcBef>
-                <a:spcPts val="600"/>
+                <a:spcPts val="800"/>
               </a:spcBef>
-              <a:defRPr sz="1000">
-                <a:solidFill>
-                  <a:srgbClr val="34D399"/>
-                </a:solidFill>
-                <a:latin typeface="Consolas"/>
+              <a:defRPr sz="1300">
+                <a:solidFill>
+                  <a:srgbClr val="94A3B8"/>
+                </a:solidFill>
+                <a:latin typeface="Calibri"/>
               </a:defRPr>
             </a:pPr>
             <a:r>
-              <a:t>Loss Formulation:  L_q(y, y_hat) = max( q*(y - y_hat), (1-q)*(y_hat - y) )</a:t>
-            </a:r>
-          </a:p>
-          <a:p>
-            <a:pPr>
-              <a:spcBef>
-                <a:spcPts val="1000"/>
-              </a:spcBef>
-              <a:defRPr sz="1100" b="1">
-                <a:solidFill>
-                  <a:srgbClr val="F87171"/>
-                </a:solidFill>
-                <a:latin typeface="Consolas"/>
-              </a:defRPr>
-            </a:pPr>
-            <a:r>
-              <a:t>[P10] Downside Value-at-Risk Floor (q = 0.10)</a:t>
-            </a:r>
-          </a:p>
-          <a:p>
-            <a:pPr>
-              <a:spcBef>
-                <a:spcPts val="200"/>
-              </a:spcBef>
-              <a:defRPr sz="1100">
-                <a:solidFill>
-                  <a:srgbClr val="94A3B8"/>
-                </a:solidFill>
-                <a:latin typeface="Calibri"/>
-              </a:defRPr>
-            </a:pPr>
-            <a:r>
-              <a:t>Penalizes underpredicting extreme drawdowns 9x more than upside misses. Acts as the 90% confidence downside support boundary.</a:t>
-            </a:r>
-          </a:p>
-          <a:p>
-            <a:pPr>
-              <a:spcBef>
-                <a:spcPts val="1000"/>
-              </a:spcBef>
-              <a:defRPr sz="1100" b="1">
-                <a:solidFill>
-                  <a:srgbClr val="38BDF8"/>
-                </a:solidFill>
-                <a:latin typeface="Consolas"/>
-              </a:defRPr>
-            </a:pPr>
-            <a:r>
-              <a:t>[P50] Median Expected Trajectory (q = 0.50)</a:t>
-            </a:r>
-          </a:p>
-          <a:p>
-            <a:pPr>
-              <a:spcBef>
-                <a:spcPts val="200"/>
-              </a:spcBef>
-              <a:defRPr sz="1100">
-                <a:solidFill>
-                  <a:srgbClr val="94A3B8"/>
-                </a:solidFill>
-                <a:latin typeface="Calibri"/>
-              </a:defRPr>
-            </a:pPr>
-            <a:r>
-              <a:t>Minimizes MAE; mathematically robust against frontier market illiquid outlier spikes and manipulation jumps.</a:t>
-            </a:r>
-          </a:p>
-          <a:p>
-            <a:pPr>
-              <a:spcBef>
-                <a:spcPts val="1000"/>
-              </a:spcBef>
-              <a:defRPr sz="1100" b="1">
-                <a:solidFill>
-                  <a:srgbClr val="34D399"/>
-                </a:solidFill>
-                <a:latin typeface="Consolas"/>
-              </a:defRPr>
-            </a:pPr>
-            <a:r>
-              <a:t>[P90] Bullish Expansion Envelope (q = 0.90)</a:t>
-            </a:r>
-          </a:p>
-          <a:p>
-            <a:pPr>
-              <a:spcBef>
-                <a:spcPts val="200"/>
-              </a:spcBef>
-              <a:defRPr sz="1100">
-                <a:solidFill>
-                  <a:srgbClr val="94A3B8"/>
-                </a:solidFill>
-                <a:latin typeface="Calibri"/>
-              </a:defRPr>
-            </a:pPr>
-            <a:r>
-              <a:t>Upper 90th percentile boundary indicating sustained bullish momentum expansion resistance.</a:t>
-            </a:r>
-          </a:p>
-        </p:txBody>
-      </p:sp>
-      <p:sp>
-        <p:nvSpPr>
-          <p:cNvPr id="10" name="TextBox 9"/>
+              <a:t>Drops training samples whose 30-day horizon overlaps with test dates.</a:t>
+            </a:r>
+          </a:p>
+        </p:txBody>
+      </p:sp>
+      <p:sp>
+        <p:nvSpPr>
+          <p:cNvPr id="10" name="Rectangle 9"/>
+          <p:cNvSpPr/>
+          <p:nvPr/>
+        </p:nvSpPr>
+        <p:spPr>
+          <a:xfrm>
+            <a:off x="3977639" y="5943600"/>
+            <a:ext cx="3154680" cy="2377440"/>
+          </a:xfrm>
+          <a:prstGeom prst="rect">
+            <a:avLst/>
+          </a:prstGeom>
+          <a:solidFill>
+            <a:srgbClr val="111722"/>
+          </a:solidFill>
+          <a:ln w="19050">
+            <a:solidFill>
+              <a:srgbClr val="34D399"/>
+            </a:solidFill>
+          </a:ln>
+        </p:spPr>
+        <p:style>
+          <a:lnRef idx="1">
+            <a:schemeClr val="accent1"/>
+          </a:lnRef>
+          <a:fillRef idx="3">
+            <a:schemeClr val="accent1"/>
+          </a:fillRef>
+          <a:effectRef idx="2">
+            <a:schemeClr val="accent1"/>
+          </a:effectRef>
+          <a:fontRef idx="minor">
+            <a:schemeClr val="lt1"/>
+          </a:fontRef>
+        </p:style>
+        <p:txBody>
+          <a:bodyPr rtlCol="0" anchor="ctr"/>
+          <a:lstStyle/>
+          <a:p>
+            <a:pPr algn="ctr"/>
+          </a:p>
+        </p:txBody>
+      </p:sp>
+      <p:sp>
+        <p:nvSpPr>
+          <p:cNvPr id="11" name="TextBox 10"/>
           <p:cNvSpPr txBox="1"/>
           <p:nvPr/>
         </p:nvSpPr>
         <p:spPr>
           <a:xfrm>
-            <a:off x="731520" y="6263640"/>
-            <a:ext cx="10698480" cy="365760"/>
+            <a:off x="4160520" y="6080760"/>
+            <a:ext cx="2788920" cy="2103120"/>
           </a:xfrm>
           <a:prstGeom prst="rect">
             <a:avLst/>
@@ -4988,6 +4477,58 @@
           <a:noFill/>
         </p:spPr>
         <p:txBody>
+          <a:bodyPr wrap="square">
+            <a:spAutoFit/>
+          </a:bodyPr>
+          <a:lstStyle/>
+          <a:p>
+            <a:pPr>
+              <a:defRPr sz="1300" b="1">
+                <a:solidFill>
+                  <a:srgbClr val="34D399"/>
+                </a:solidFill>
+                <a:latin typeface="Consolas"/>
+              </a:defRPr>
+            </a:pPr>
+            <a:r>
+              <a:t>30-DAY EMBARGO</a:t>
+            </a:r>
+          </a:p>
+          <a:p>
+            <a:pPr>
+              <a:spcBef>
+                <a:spcPts val="800"/>
+              </a:spcBef>
+              <a:defRPr sz="1300">
+                <a:solidFill>
+                  <a:srgbClr val="94A3B8"/>
+                </a:solidFill>
+                <a:latin typeface="Calibri"/>
+              </a:defRPr>
+            </a:pPr>
+            <a:r>
+              <a:t>Blocks post-test auto-correlation spillover into future folds.</a:t>
+            </a:r>
+          </a:p>
+        </p:txBody>
+      </p:sp>
+      <p:sp>
+        <p:nvSpPr>
+          <p:cNvPr id="12" name="TextBox 11"/>
+          <p:cNvSpPr txBox="1"/>
+          <p:nvPr/>
+        </p:nvSpPr>
+        <p:spPr>
+          <a:xfrm>
+            <a:off x="640080" y="8961120"/>
+            <a:ext cx="6492240" cy="365760"/>
+          </a:xfrm>
+          <a:prstGeom prst="rect">
+            <a:avLst/>
+          </a:prstGeom>
+          <a:noFill/>
+        </p:spPr>
+        <p:txBody>
           <a:bodyPr wrap="none">
             <a:spAutoFit/>
           </a:bodyPr>
@@ -5002,7 +4543,7 @@
               </a:defRPr>
             </a:pPr>
             <a:r>
-              <a:t>RIGOROUS TIME-SERIES GOVERNANCE</a:t>
+              <a:t>COLOMBO STOCK EXCHANGE (CSE) MLOPS</a:t>
             </a:r>
             <a:r>
               <a:rPr b="1">
@@ -5010,7 +4551,7 @@
                   <a:srgbClr val="38BDF8"/>
                 </a:solidFill>
               </a:rPr>
-              <a:t>   |   [03 / 05]</a:t>
+              <a:t>   |   Swipe &gt;</a:t>
             </a:r>
           </a:p>
         </p:txBody>
@@ -5042,7 +4583,7 @@
         <p:spPr>
           <a:xfrm>
             <a:off x="0" y="0"/>
-            <a:ext cx="12191695" cy="6858000"/>
+            <a:ext cx="7772400" cy="9715500"/>
           </a:xfrm>
           <a:prstGeom prst="rect">
             <a:avLst/>
@@ -5084,8 +4625,8 @@
         </p:nvSpPr>
         <p:spPr>
           <a:xfrm>
-            <a:off x="731520" y="365760"/>
-            <a:ext cx="10515600" cy="320040"/>
+            <a:off x="640080" y="640080"/>
+            <a:ext cx="6492240" cy="320040"/>
           </a:xfrm>
           <a:prstGeom prst="rect">
             <a:avLst/>
@@ -5093,7 +4634,7 @@
           <a:noFill/>
         </p:spPr>
         <p:txBody>
-          <a:bodyPr wrap="square">
+          <a:bodyPr wrap="none">
             <a:spAutoFit/>
           </a:bodyPr>
           <a:lstStyle/>
@@ -5107,7 +4648,7 @@
               </a:defRPr>
             </a:pPr>
             <a:r>
-              <a:t>[ MODEL INTERPRETABILITY ]</a:t>
+              <a:t>[ 04 / EXPLAINABLE AI ]</a:t>
             </a:r>
           </a:p>
         </p:txBody>
@@ -5120,8 +4661,8 @@
         </p:nvSpPr>
         <p:spPr>
           <a:xfrm>
-            <a:off x="731520" y="685800"/>
-            <a:ext cx="10698480" cy="640080"/>
+            <a:off x="640080" y="1005840"/>
+            <a:ext cx="6492240" cy="1097280"/>
           </a:xfrm>
           <a:prstGeom prst="rect">
             <a:avLst/>
@@ -5135,7 +4676,7 @@
           <a:lstStyle/>
           <a:p>
             <a:pPr>
-              <a:defRPr sz="2600" b="1">
+              <a:defRPr sz="2800" b="1">
                 <a:solidFill>
                   <a:srgbClr val="F8FAFC"/>
                 </a:solidFill>
@@ -5156,8 +4697,8 @@
         </p:nvSpPr>
         <p:spPr>
           <a:xfrm>
-            <a:off x="731520" y="1280160"/>
-            <a:ext cx="10698480" cy="411480"/>
+            <a:off x="640080" y="2148840"/>
+            <a:ext cx="6492240" cy="822960"/>
           </a:xfrm>
           <a:prstGeom prst="rect">
             <a:avLst/>
@@ -5171,7 +4712,7 @@
           <a:lstStyle/>
           <a:p>
             <a:pPr>
-              <a:defRPr sz="1300">
+              <a:defRPr sz="1400">
                 <a:solidFill>
                   <a:srgbClr val="94A3B8"/>
                 </a:solidFill>
@@ -5179,7 +4720,7 @@
               </a:defRPr>
             </a:pPr>
             <a:r>
-              <a:t>Bridging mathematical Shapley attribution and trader heuristic intuition into a transparent decision engine.</a:t>
+              <a:t>Bridging mathematical Shapley attributions with institutional trader heuristic cards.</a:t>
             </a:r>
           </a:p>
         </p:txBody>
@@ -5192,14 +4733,14 @@
         </p:nvSpPr>
         <p:spPr>
           <a:xfrm>
-            <a:off x="731520" y="1828800"/>
-            <a:ext cx="10698480" cy="2011680"/>
+            <a:off x="640080" y="3291840"/>
+            <a:ext cx="6492240" cy="2377440"/>
           </a:xfrm>
           <a:prstGeom prst="rect">
             <a:avLst/>
           </a:prstGeom>
           <a:solidFill>
-            <a:srgbClr val="121824"/>
+            <a:srgbClr val="111722"/>
           </a:solidFill>
           <a:ln w="19050">
             <a:solidFill>
@@ -5237,8 +4778,8 @@
         </p:nvSpPr>
         <p:spPr>
           <a:xfrm>
-            <a:off x="914400" y="1920240"/>
-            <a:ext cx="10332720" cy="1828800"/>
+            <a:off x="822960" y="3429000"/>
+            <a:ext cx="6126480" cy="2103120"/>
           </a:xfrm>
           <a:prstGeom prst="rect">
             <a:avLst/>
@@ -5252,79 +4793,47 @@
           <a:lstStyle/>
           <a:p>
             <a:pPr>
-              <a:defRPr sz="1300" b="1">
+              <a:defRPr sz="1100" b="1">
                 <a:solidFill>
                   <a:srgbClr val="C084FC"/>
                 </a:solidFill>
-                <a:latin typeface="Trebuchet MS"/>
+                <a:latin typeface="Consolas"/>
               </a:defRPr>
             </a:pPr>
             <a:r>
-              <a:t>Layer 1: Exact TreeSHAP Mathematical Attribution   [ y_hat = phi_0 + sum(phi_i) ]</a:t>
+              <a:t>[ LAYER 1: MATHEMATICAL TREESHAP ]</a:t>
             </a:r>
           </a:p>
           <a:p>
             <a:pPr>
               <a:spcBef>
-                <a:spcPts val="400"/>
+                <a:spcPts val="600"/>
               </a:spcBef>
-              <a:defRPr sz="1100">
-                <a:solidFill>
-                  <a:srgbClr val="94A3B8"/>
-                </a:solidFill>
-                <a:latin typeface="Calibri"/>
+              <a:defRPr sz="1800" b="1">
+                <a:solidFill>
+                  <a:srgbClr val="F8FAFC"/>
+                </a:solidFill>
+                <a:latin typeface="Trebuchet MS"/>
               </a:defRPr>
             </a:pPr>
             <a:r>
-              <a:t>Decomposes predicted 30-day cumulative return into exact basis-point feature contributions (tested for exact additivity in pytest):</a:t>
+              <a:t>Exact Additive Shapley Values</a:t>
             </a:r>
           </a:p>
           <a:p>
             <a:pPr>
               <a:spcBef>
-                <a:spcPts val="300"/>
+                <a:spcPts val="800"/>
               </a:spcBef>
-              <a:defRPr sz="1000">
-                <a:solidFill>
-                  <a:srgbClr val="34D399"/>
-                </a:solidFill>
-                <a:latin typeface="Consolas"/>
+              <a:defRPr sz="1300">
+                <a:solidFill>
+                  <a:srgbClr val="94A3B8"/>
+                </a:solidFill>
+                <a:latin typeface="Calibri"/>
               </a:defRPr>
             </a:pPr>
             <a:r>
-              <a:t>•  parkinson_vol_20d       [+0.52% Return Impact]    -- High-low volatility expansion drives expected volatility premium</a:t>
-            </a:r>
-          </a:p>
-          <a:p>
-            <a:pPr>
-              <a:spcBef>
-                <a:spcPts val="300"/>
-              </a:spcBef>
-              <a:defRPr sz="1000">
-                <a:solidFill>
-                  <a:srgbClr val="34D399"/>
-                </a:solidFill>
-                <a:latin typeface="Consolas"/>
-              </a:defRPr>
-            </a:pPr>
-            <a:r>
-              <a:t>•  aspi_return_30d         [+0.31% Return Impact]    -- Broad market cyclical index momentum supports equity trajectory</a:t>
-            </a:r>
-          </a:p>
-          <a:p>
-            <a:pPr>
-              <a:spcBef>
-                <a:spcPts val="300"/>
-              </a:spcBef>
-              <a:defRPr sz="1000">
-                <a:solidFill>
-                  <a:srgbClr val="F87171"/>
-                </a:solidFill>
-                <a:latin typeface="Consolas"/>
-              </a:defRPr>
-            </a:pPr>
-            <a:r>
-              <a:t>•  rsi_14                  [-0.28% Return Impact]    -- Wilder RSI approaching short-term exhaustion boundary</a:t>
+              <a:t>Decomposes predicted return into exact basis-point contributions: Parkinson Volatility, RSI momentum, and ASPI relative alpha.</a:t>
             </a:r>
           </a:p>
         </p:txBody>
@@ -5337,14 +4846,14 @@
         </p:nvSpPr>
         <p:spPr>
           <a:xfrm>
-            <a:off x="731520" y="4023360"/>
-            <a:ext cx="10698480" cy="2011680"/>
+            <a:off x="640080" y="5943600"/>
+            <a:ext cx="6492240" cy="2377440"/>
           </a:xfrm>
           <a:prstGeom prst="rect">
             <a:avLst/>
           </a:prstGeom>
           <a:solidFill>
-            <a:srgbClr val="121824"/>
+            <a:srgbClr val="111722"/>
           </a:solidFill>
           <a:ln w="19050">
             <a:solidFill>
@@ -5382,8 +4891,8 @@
         </p:nvSpPr>
         <p:spPr>
           <a:xfrm>
-            <a:off x="914400" y="4114800"/>
-            <a:ext cx="10332720" cy="1828800"/>
+            <a:off x="822960" y="6080760"/>
+            <a:ext cx="6126480" cy="2103120"/>
           </a:xfrm>
           <a:prstGeom prst="rect">
             <a:avLst/>
@@ -5397,15 +4906,15 @@
           <a:lstStyle/>
           <a:p>
             <a:pPr>
-              <a:defRPr sz="1300" b="1">
+              <a:defRPr sz="1100" b="1">
                 <a:solidFill>
                   <a:srgbClr val="38BDF8"/>
                 </a:solidFill>
-                <a:latin typeface="Trebuchet MS"/>
+                <a:latin typeface="Consolas"/>
               </a:defRPr>
             </a:pPr>
             <a:r>
-              <a:t>Layer 2: Domain Indicator Heuristics Alignment   [ Institutional Rule Engine ]</a:t>
+              <a:t>[ LAYER 2: DOMAIN HEURISTIC ALIGNMENT ]</a:t>
             </a:r>
           </a:p>
           <a:p>
@@ -5413,47 +4922,31 @@
               <a:spcBef>
                 <a:spcPts val="600"/>
               </a:spcBef>
-              <a:defRPr sz="1050">
-                <a:solidFill>
-                  <a:srgbClr val="34D399"/>
-                </a:solidFill>
-                <a:latin typeface="Consolas"/>
+              <a:defRPr sz="1800" b="1">
+                <a:solidFill>
+                  <a:srgbClr val="F8FAFC"/>
+                </a:solidFill>
+                <a:latin typeface="Trebuchet MS"/>
               </a:defRPr>
             </a:pPr>
             <a:r>
-              <a:t>[SUPPORTING]          RSI (14-Day)             : Momentum expansion confirms bullish median trajectory without exceeding overbought exhaustion threshold (&lt;70).</a:t>
+              <a:t>Trader Intuition Validation</a:t>
             </a:r>
           </a:p>
           <a:p>
             <a:pPr>
               <a:spcBef>
-                <a:spcPts val="600"/>
+                <a:spcPts val="800"/>
               </a:spcBef>
-              <a:defRPr sz="1050">
-                <a:solidFill>
-                  <a:srgbClr val="F87171"/>
-                </a:solidFill>
-                <a:latin typeface="Consolas"/>
+              <a:defRPr sz="1300">
+                <a:solidFill>
+                  <a:srgbClr val="94A3B8"/>
+                </a:solidFill>
+                <a:latin typeface="Calibri"/>
               </a:defRPr>
             </a:pPr>
             <a:r>
-              <a:t>[REJECTING / RISK]    Parkinson Volatility     : Elevated 20d dispersion widens the downside P10 boundary, signaling potential trend instability.</a:t>
-            </a:r>
-          </a:p>
-          <a:p>
-            <a:pPr>
-              <a:spcBef>
-                <a:spcPts val="600"/>
-              </a:spcBef>
-              <a:defRPr sz="1050">
-                <a:solidFill>
-                  <a:srgbClr val="94A3B8"/>
-                </a:solidFill>
-                <a:latin typeface="Consolas"/>
-              </a:defRPr>
-            </a:pPr>
-            <a:r>
-              <a:t>[NEUTRAL]             Volume Surge Ratio       : Trading activity tracks 20-day baseline average; neither confirms nor contradicts breakout velocity.</a:t>
+              <a:t>Cross-verifies setup across Wilder RSI, 20/50 SMA trend, Parkinson volatility, and Volume surge into Supporting, Risk, or Neutral badges.</a:t>
             </a:r>
           </a:p>
         </p:txBody>
@@ -5466,8 +4959,8 @@
         </p:nvSpPr>
         <p:spPr>
           <a:xfrm>
-            <a:off x="731520" y="6263640"/>
-            <a:ext cx="10698480" cy="365760"/>
+            <a:off x="640080" y="8961120"/>
+            <a:ext cx="6492240" cy="365760"/>
           </a:xfrm>
           <a:prstGeom prst="rect">
             <a:avLst/>
@@ -5489,7 +4982,7 @@
               </a:defRPr>
             </a:pPr>
             <a:r>
-              <a:t>DUAL-LAYER TECHNICAL INTERPRETABILITY</a:t>
+              <a:t>COLOMBO STOCK EXCHANGE (CSE) MLOPS</a:t>
             </a:r>
             <a:r>
               <a:rPr b="1">
@@ -5497,7 +4990,7 @@
                   <a:srgbClr val="38BDF8"/>
                 </a:solidFill>
               </a:rPr>
-              <a:t>   |   [04 / 05]</a:t>
+              <a:t>   |   Swipe &gt;</a:t>
             </a:r>
           </a:p>
         </p:txBody>
@@ -5529,7 +5022,7 @@
         <p:spPr>
           <a:xfrm>
             <a:off x="0" y="0"/>
-            <a:ext cx="12191695" cy="6858000"/>
+            <a:ext cx="7772400" cy="9715500"/>
           </a:xfrm>
           <a:prstGeom prst="rect">
             <a:avLst/>
@@ -5571,8 +5064,8 @@
         </p:nvSpPr>
         <p:spPr>
           <a:xfrm>
-            <a:off x="731520" y="365760"/>
-            <a:ext cx="10515600" cy="320040"/>
+            <a:off x="640080" y="640080"/>
+            <a:ext cx="6492240" cy="320040"/>
           </a:xfrm>
           <a:prstGeom prst="rect">
             <a:avLst/>
@@ -5580,7 +5073,7 @@
           <a:noFill/>
         </p:spPr>
         <p:txBody>
-          <a:bodyPr wrap="square">
+          <a:bodyPr wrap="none">
             <a:spAutoFit/>
           </a:bodyPr>
           <a:lstStyle/>
@@ -5594,7 +5087,7 @@
               </a:defRPr>
             </a:pPr>
             <a:r>
-              <a:t>[ PRODUCTION SERVING ]</a:t>
+              <a:t>[ 05 / RESULTS &amp; STACK ]</a:t>
             </a:r>
           </a:p>
         </p:txBody>
@@ -5607,8 +5100,8 @@
         </p:nvSpPr>
         <p:spPr>
           <a:xfrm>
-            <a:off x="731520" y="685800"/>
-            <a:ext cx="10698480" cy="640080"/>
+            <a:off x="640080" y="1005840"/>
+            <a:ext cx="6492240" cy="1097280"/>
           </a:xfrm>
           <a:prstGeom prst="rect">
             <a:avLst/>
@@ -5622,7 +5115,7 @@
           <a:lstStyle/>
           <a:p>
             <a:pPr>
-              <a:defRPr sz="2600" b="1">
+              <a:defRPr sz="2800" b="1">
                 <a:solidFill>
                   <a:srgbClr val="F8FAFC"/>
                 </a:solidFill>
@@ -5630,7 +5123,7 @@
               </a:defRPr>
             </a:pPr>
             <a:r>
-              <a:t>Production Stack &amp; Empirical Results</a:t>
+              <a:t>Empirical Results &amp; Live Architecture</a:t>
             </a:r>
           </a:p>
         </p:txBody>
@@ -5643,8 +5136,8 @@
         </p:nvSpPr>
         <p:spPr>
           <a:xfrm>
-            <a:off x="731520" y="1280160"/>
-            <a:ext cx="10698480" cy="411480"/>
+            <a:off x="640080" y="2148840"/>
+            <a:ext cx="6492240" cy="822960"/>
           </a:xfrm>
           <a:prstGeom prst="rect">
             <a:avLst/>
@@ -5658,7 +5151,7 @@
           <a:lstStyle/>
           <a:p>
             <a:pPr>
-              <a:defRPr sz="1300">
+              <a:defRPr sz="1400">
                 <a:solidFill>
                   <a:srgbClr val="94A3B8"/>
                 </a:solidFill>
@@ -5666,7 +5159,7 @@
               </a:defRPr>
             </a:pPr>
             <a:r>
-              <a:t>Validated out-of-sample quantitative edge backed by an automated 100% free cloud deployment topology.</a:t>
+              <a:t>Validated out-of-sample edge deployed on a zero-cost 100% free cloud architecture.</a:t>
             </a:r>
           </a:p>
         </p:txBody>
@@ -5679,14 +5172,14 @@
         </p:nvSpPr>
         <p:spPr>
           <a:xfrm>
-            <a:off x="731520" y="1828800"/>
-            <a:ext cx="3383280" cy="1371600"/>
+            <a:off x="640080" y="3291840"/>
+            <a:ext cx="2011680" cy="2103120"/>
           </a:xfrm>
           <a:prstGeom prst="rect">
             <a:avLst/>
           </a:prstGeom>
           <a:solidFill>
-            <a:srgbClr val="121824"/>
+            <a:srgbClr val="111722"/>
           </a:solidFill>
           <a:ln w="19050">
             <a:solidFill>
@@ -5724,8 +5217,8 @@
         </p:nvSpPr>
         <p:spPr>
           <a:xfrm>
-            <a:off x="868680" y="1920240"/>
-            <a:ext cx="3108960" cy="1188720"/>
+            <a:off x="731520" y="3474720"/>
+            <a:ext cx="1828800" cy="1737360"/>
           </a:xfrm>
           <a:prstGeom prst="rect">
             <a:avLst/>
@@ -5753,9 +5246,9 @@
           <a:p>
             <a:pPr algn="ctr">
               <a:spcBef>
-                <a:spcPts val="200"/>
+                <a:spcPts val="400"/>
               </a:spcBef>
-              <a:defRPr sz="1000" b="1">
+              <a:defRPr sz="950" b="1">
                 <a:solidFill>
                   <a:srgbClr val="F8FAFC"/>
                 </a:solidFill>
@@ -5763,13 +5256,13 @@
               </a:defRPr>
             </a:pPr>
             <a:r>
-              <a:t>DIRECTIONAL ACCURACY</a:t>
+              <a:t>DIRECTION ACCURACY</a:t>
             </a:r>
           </a:p>
           <a:p>
             <a:pPr algn="ctr">
               <a:spcBef>
-                <a:spcPts val="200"/>
+                <a:spcPts val="400"/>
               </a:spcBef>
               <a:defRPr sz="950">
                 <a:solidFill>
@@ -5779,7 +5272,7 @@
               </a:defRPr>
             </a:pPr>
             <a:r>
-              <a:t>+8.3% edge over 50% Naive Random Walk</a:t>
+              <a:t>+8.3% over Random Walk</a:t>
             </a:r>
           </a:p>
         </p:txBody>
@@ -5792,14 +5285,14 @@
         </p:nvSpPr>
         <p:spPr>
           <a:xfrm>
-            <a:off x="4389120" y="1828800"/>
-            <a:ext cx="3383280" cy="1371600"/>
+            <a:off x="2880360" y="3291840"/>
+            <a:ext cx="2011680" cy="2103120"/>
           </a:xfrm>
           <a:prstGeom prst="rect">
             <a:avLst/>
           </a:prstGeom>
           <a:solidFill>
-            <a:srgbClr val="121824"/>
+            <a:srgbClr val="111722"/>
           </a:solidFill>
           <a:ln w="19050">
             <a:solidFill>
@@ -5837,8 +5330,8 @@
         </p:nvSpPr>
         <p:spPr>
           <a:xfrm>
-            <a:off x="4526280" y="1920240"/>
-            <a:ext cx="3108960" cy="1188720"/>
+            <a:off x="2971800" y="3474720"/>
+            <a:ext cx="1828800" cy="1737360"/>
           </a:xfrm>
           <a:prstGeom prst="rect">
             <a:avLst/>
@@ -5866,9 +5359,9 @@
           <a:p>
             <a:pPr algn="ctr">
               <a:spcBef>
-                <a:spcPts val="200"/>
+                <a:spcPts val="400"/>
               </a:spcBef>
-              <a:defRPr sz="1000" b="1">
+              <a:defRPr sz="950" b="1">
                 <a:solidFill>
                   <a:srgbClr val="F8FAFC"/>
                 </a:solidFill>
@@ -5882,7 +5375,7 @@
           <a:p>
             <a:pPr algn="ctr">
               <a:spcBef>
-                <a:spcPts val="200"/>
+                <a:spcPts val="400"/>
               </a:spcBef>
               <a:defRPr sz="950">
                 <a:solidFill>
@@ -5892,7 +5385,7 @@
               </a:defRPr>
             </a:pPr>
             <a:r>
-              <a:t>Actuals contained within P10-P90 cone (Target: 80%)</a:t>
+              <a:t>Inside P10-P90 Cone</a:t>
             </a:r>
           </a:p>
         </p:txBody>
@@ -5905,14 +5398,14 @@
         </p:nvSpPr>
         <p:spPr>
           <a:xfrm>
-            <a:off x="8046720" y="1828800"/>
-            <a:ext cx="3383280" cy="1371600"/>
+            <a:off x="5120640" y="3291840"/>
+            <a:ext cx="2011680" cy="2103120"/>
           </a:xfrm>
           <a:prstGeom prst="rect">
             <a:avLst/>
           </a:prstGeom>
           <a:solidFill>
-            <a:srgbClr val="121824"/>
+            <a:srgbClr val="111722"/>
           </a:solidFill>
           <a:ln w="19050">
             <a:solidFill>
@@ -5950,8 +5443,8 @@
         </p:nvSpPr>
         <p:spPr>
           <a:xfrm>
-            <a:off x="8183880" y="1920240"/>
-            <a:ext cx="3108960" cy="1188720"/>
+            <a:off x="5212080" y="3474720"/>
+            <a:ext cx="1828800" cy="1737360"/>
           </a:xfrm>
           <a:prstGeom prst="rect">
             <a:avLst/>
@@ -5973,15 +5466,15 @@
               </a:defRPr>
             </a:pPr>
             <a:r>
-              <a:t>26 + 1</a:t>
+              <a:t>26+1</a:t>
             </a:r>
           </a:p>
           <a:p>
             <a:pPr algn="ctr">
               <a:spcBef>
-                <a:spcPts val="200"/>
+                <a:spcPts val="400"/>
               </a:spcBef>
-              <a:defRPr sz="1000" b="1">
+              <a:defRPr sz="950" b="1">
                 <a:solidFill>
                   <a:srgbClr val="F8FAFC"/>
                 </a:solidFill>
@@ -5995,7 +5488,7 @@
           <a:p>
             <a:pPr algn="ctr">
               <a:spcBef>
-                <a:spcPts val="200"/>
+                <a:spcPts val="400"/>
               </a:spcBef>
               <a:defRPr sz="950">
                 <a:solidFill>
@@ -6005,7 +5498,7 @@
               </a:defRPr>
             </a:pPr>
             <a:r>
-              <a:t>Synced, engineered &amp; retrained daily at 15:00 SLST</a:t>
+              <a:t>Automated Daily Sync</a:t>
             </a:r>
           </a:p>
         </p:txBody>
@@ -6018,14 +5511,14 @@
         </p:nvSpPr>
         <p:spPr>
           <a:xfrm>
-            <a:off x="731520" y="3429000"/>
-            <a:ext cx="10698480" cy="2651760"/>
+            <a:off x="640080" y="5669280"/>
+            <a:ext cx="6492240" cy="2651760"/>
           </a:xfrm>
           <a:prstGeom prst="rect">
             <a:avLst/>
           </a:prstGeom>
           <a:solidFill>
-            <a:srgbClr val="121824"/>
+            <a:srgbClr val="111722"/>
           </a:solidFill>
           <a:ln w="19050">
             <a:solidFill>
@@ -6063,8 +5556,8 @@
         </p:nvSpPr>
         <p:spPr>
           <a:xfrm>
-            <a:off x="914400" y="3566160"/>
-            <a:ext cx="10332720" cy="2377440"/>
+            <a:off x="822960" y="5806440"/>
+            <a:ext cx="6126480" cy="2377440"/>
           </a:xfrm>
           <a:prstGeom prst="rect">
             <a:avLst/>
@@ -6078,15 +5571,15 @@
           <a:lstStyle/>
           <a:p>
             <a:pPr>
-              <a:defRPr sz="1300" b="1">
+              <a:defRPr sz="1100" b="1">
                 <a:solidFill>
                   <a:srgbClr val="38BDF8"/>
                 </a:solidFill>
-                <a:latin typeface="Trebuchet MS"/>
+                <a:latin typeface="Consolas"/>
               </a:defRPr>
             </a:pPr>
             <a:r>
-              <a:t>Zero-Cost Enterprise Cloud Architecture  [ 100% Free Tier Deployment ]</a:t>
+              <a:t>[ ZERO-COST PRODUCTION STACK ]</a:t>
             </a:r>
           </a:p>
           <a:p>
@@ -6094,7 +5587,7 @@
               <a:spcBef>
                 <a:spcPts val="600"/>
               </a:spcBef>
-              <a:defRPr sz="1000">
+              <a:defRPr sz="1100">
                 <a:solidFill>
                   <a:srgbClr val="F8FAFC"/>
                 </a:solidFill>
@@ -6102,7 +5595,7 @@
               </a:defRPr>
             </a:pPr>
             <a:r>
-              <a:t>[FRONTEND TERMINAL]       Vercel Edge CDN          : React 19 + TypeScript + TradingView Charts with resilient fallback preview cache.</a:t>
+              <a:t>• Frontend Terminal    : React 19 + TypeScript on Vercel Edge</a:t>
             </a:r>
           </a:p>
           <a:p>
@@ -6110,7 +5603,7 @@
               <a:spcBef>
                 <a:spcPts val="600"/>
               </a:spcBef>
-              <a:defRPr sz="1000">
+              <a:defRPr sz="1100">
                 <a:solidFill>
                   <a:srgbClr val="F8FAFC"/>
                 </a:solidFill>
@@ -6118,7 +5611,7 @@
               </a:defRPr>
             </a:pPr>
             <a:r>
-              <a:t>[BACKEND API SERVING]     Render Docker Service    : Containerized FastAPI exposing Pydantic-typed forecast &amp; explainability routes.</a:t>
+              <a:t>• Serving REST API     : FastAPI Container on Render</a:t>
             </a:r>
           </a:p>
           <a:p>
@@ -6126,7 +5619,7 @@
               <a:spcBef>
                 <a:spcPts val="600"/>
               </a:spcBef>
-              <a:defRPr sz="1000">
+              <a:defRPr sz="1100">
                 <a:solidFill>
                   <a:srgbClr val="F8FAFC"/>
                 </a:solidFill>
@@ -6134,7 +5627,7 @@
               </a:defRPr>
             </a:pPr>
             <a:r>
-              <a:t>[CLOUD DATABASE]          Supabase PostgreSQL 15   : Connection-pooled database storing prices, forecasts, and MLOps audit traces.</a:t>
+              <a:t>• Cloud Database       : PostgreSQL 15 on Supabase</a:t>
             </a:r>
           </a:p>
           <a:p>
@@ -6142,7 +5635,7 @@
               <a:spcBef>
                 <a:spcPts val="600"/>
               </a:spcBef>
-              <a:defRPr sz="1000">
+              <a:defRPr sz="1100">
                 <a:solidFill>
                   <a:srgbClr val="F8FAFC"/>
                 </a:solidFill>
@@ -6150,7 +5643,7 @@
               </a:defRPr>
             </a:pPr>
             <a:r>
-              <a:t>[POST-MARKET CRON]        GitHub Actions Workflows : Triggers every weekday at 15:00 SLST for ingestion, model retraining, and deploy hooks.</a:t>
+              <a:t>• Post-Market Pipeline : Automated Cron (15:00 SLST) on GitHub Actions</a:t>
             </a:r>
           </a:p>
         </p:txBody>
@@ -6163,8 +5656,8 @@
         </p:nvSpPr>
         <p:spPr>
           <a:xfrm>
-            <a:off x="731520" y="6263640"/>
-            <a:ext cx="10698480" cy="365760"/>
+            <a:off x="640080" y="8961120"/>
+            <a:ext cx="6492240" cy="365760"/>
           </a:xfrm>
           <a:prstGeom prst="rect">
             <a:avLst/>
@@ -6186,7 +5679,7 @@
               </a:defRPr>
             </a:pPr>
             <a:r>
-              <a:t>[Live Terminal: cse-market-intelligence.vercel.app] • [GitHub: madushanka-ti/cse-market-intelligence]</a:t>
+              <a:t>COLOMBO STOCK EXCHANGE (CSE) MLOPS</a:t>
             </a:r>
             <a:r>
               <a:rPr b="1">

</xml_diff>

<commit_message>
docs: align linkedin deck with senior AI/ML/SE engineering competencies and tech stack
</commit_message>
<xml_diff>
--- a/docs/linkedin_presentation_deck.pptx
+++ b/docs/linkedin_presentation_deck.pptx
@@ -3143,8 +3143,8 @@
         </p:nvSpPr>
         <p:spPr>
           <a:xfrm>
-            <a:off x="640080" y="640080"/>
-            <a:ext cx="6492240" cy="320040"/>
+            <a:off x="640080" y="594360"/>
+            <a:ext cx="6492240" cy="274320"/>
           </a:xfrm>
           <a:prstGeom prst="rect">
             <a:avLst/>
@@ -3166,7 +3166,7 @@
               </a:defRPr>
             </a:pPr>
             <a:r>
-              <a:t>[ 01 / PROBLEM &amp; PIVOT ]</a:t>
+              <a:t>[ 01 / FINANCIAL ML MATHEMATICS ]</a:t>
             </a:r>
           </a:p>
         </p:txBody>
@@ -3179,7 +3179,7 @@
         </p:nvSpPr>
         <p:spPr>
           <a:xfrm>
-            <a:off x="640080" y="1005840"/>
+            <a:off x="640080" y="896112"/>
             <a:ext cx="6492240" cy="1097280"/>
           </a:xfrm>
           <a:prstGeom prst="rect">
@@ -3194,7 +3194,7 @@
           <a:lstStyle/>
           <a:p>
             <a:pPr>
-              <a:defRPr sz="2800" b="1">
+              <a:defRPr sz="2700" b="1">
                 <a:solidFill>
                   <a:srgbClr val="F8FAFC"/>
                 </a:solidFill>
@@ -3202,7 +3202,7 @@
               </a:defRPr>
             </a:pPr>
             <a:r>
-              <a:t>Why Predicting Stock Prices is an Anti-Pattern</a:t>
+              <a:t>Solving Time-Series Non-Stationarity</a:t>
             </a:r>
           </a:p>
         </p:txBody>
@@ -3215,8 +3215,8 @@
         </p:nvSpPr>
         <p:spPr>
           <a:xfrm>
-            <a:off x="640080" y="2148840"/>
-            <a:ext cx="6492240" cy="822960"/>
+            <a:off x="640080" y="2057400"/>
+            <a:ext cx="6492240" cy="777240"/>
           </a:xfrm>
           <a:prstGeom prst="rect">
             <a:avLst/>
@@ -3230,7 +3230,7 @@
           <a:lstStyle/>
           <a:p>
             <a:pPr>
-              <a:defRPr sz="1400">
+              <a:defRPr sz="1350">
                 <a:solidFill>
                   <a:srgbClr val="94A3B8"/>
                 </a:solidFill>
@@ -3238,7 +3238,7 @@
               </a:defRPr>
             </a:pPr>
             <a:r>
-              <a:t>Predicting raw price points (P_t+30) creates a delayed echo of yesterday. Real financial ML forecasts stationary forward returns.</a:t>
+              <a:t>How I engineered a stationary quantitative learning target, eliminating the identity lag trap that plagues naive financial ML.</a:t>
             </a:r>
           </a:p>
         </p:txBody>
@@ -3251,8 +3251,8 @@
         </p:nvSpPr>
         <p:spPr>
           <a:xfrm>
-            <a:off x="640080" y="3291840"/>
-            <a:ext cx="6492240" cy="2377440"/>
+            <a:off x="640080" y="3017520"/>
+            <a:ext cx="6492240" cy="2468880"/>
           </a:xfrm>
           <a:prstGeom prst="rect">
             <a:avLst/>
@@ -3296,8 +3296,8 @@
         </p:nvSpPr>
         <p:spPr>
           <a:xfrm>
-            <a:off x="822960" y="3429000"/>
-            <a:ext cx="6126480" cy="2103120"/>
+            <a:off x="822960" y="3154680"/>
+            <a:ext cx="6126480" cy="2194560"/>
           </a:xfrm>
           <a:prstGeom prst="rect">
             <a:avLst/>
@@ -3319,7 +3319,7 @@
               </a:defRPr>
             </a:pPr>
             <a:r>
-              <a:t>[ THE MISTAKE: RAW NOMINAL PRICE ]</a:t>
+              <a:t>THE PERSISTENCE ANTI-PATTERN (I(1) UNIT ROOT)</a:t>
             </a:r>
           </a:p>
           <a:p>
@@ -3327,7 +3327,7 @@
               <a:spcBef>
                 <a:spcPts val="600"/>
               </a:spcBef>
-              <a:defRPr sz="1800" b="1">
+              <a:defRPr sz="1700" b="1">
                 <a:solidFill>
                   <a:srgbClr val="F8FAFC"/>
                 </a:solidFill>
@@ -3335,7 +3335,7 @@
               </a:defRPr>
             </a:pPr>
             <a:r>
-              <a:t>P_hat(t+30) ~= P_t</a:t>
+              <a:t>Predicting Raw Nominals: P_hat(t+30) ~= P_t</a:t>
             </a:r>
           </a:p>
           <a:p>
@@ -3343,7 +3343,7 @@
               <a:spcBef>
                 <a:spcPts val="800"/>
               </a:spcBef>
-              <a:defRPr sz="1300">
+              <a:defRPr sz="1250">
                 <a:solidFill>
                   <a:srgbClr val="94A3B8"/>
                 </a:solidFill>
@@ -3351,7 +3351,7 @@
               </a:defRPr>
             </a:pPr>
             <a:r>
-              <a:t>Non-stationary prices trick models into outputting today's price as tomorrow's forecast with synthetic 98% R^2 and zero actual alpha.</a:t>
+              <a:t>MSE optimization on raw price levels creates identity models: the booster simply outputs yesterday's price with synthetic 98% R^2 and zero predictive alpha.</a:t>
             </a:r>
           </a:p>
         </p:txBody>
@@ -3364,8 +3364,8 @@
         </p:nvSpPr>
         <p:spPr>
           <a:xfrm>
-            <a:off x="640080" y="5943600"/>
-            <a:ext cx="6492240" cy="2377440"/>
+            <a:off x="640080" y="5669280"/>
+            <a:ext cx="6492240" cy="2468880"/>
           </a:xfrm>
           <a:prstGeom prst="rect">
             <a:avLst/>
@@ -3409,8 +3409,8 @@
         </p:nvSpPr>
         <p:spPr>
           <a:xfrm>
-            <a:off x="822960" y="6080760"/>
-            <a:ext cx="6126480" cy="2103120"/>
+            <a:off x="822960" y="5806440"/>
+            <a:ext cx="6126480" cy="2194560"/>
           </a:xfrm>
           <a:prstGeom prst="rect">
             <a:avLst/>
@@ -3432,7 +3432,7 @@
               </a:defRPr>
             </a:pPr>
             <a:r>
-              <a:t>[ THE FIX: 30-DAY FORWARD LOG RETURN ]</a:t>
+              <a:t>MY MATHEMATICAL FORMULATION</a:t>
             </a:r>
           </a:p>
           <a:p>
@@ -3440,7 +3440,7 @@
               <a:spcBef>
                 <a:spcPts val="600"/>
               </a:spcBef>
-              <a:defRPr sz="1800" b="1">
+              <a:defRPr sz="1700" b="1">
                 <a:solidFill>
                   <a:srgbClr val="F8FAFC"/>
                 </a:solidFill>
@@ -3448,7 +3448,7 @@
               </a:defRPr>
             </a:pPr>
             <a:r>
-              <a:t>y_t = ln( P_{t+30} / P_t )</a:t>
+              <a:t>y_t = ln( P_{t+30} / P_t )   [Forward Log Return]</a:t>
             </a:r>
           </a:p>
           <a:p>
@@ -3456,7 +3456,7 @@
               <a:spcBef>
                 <a:spcPts val="800"/>
               </a:spcBef>
-              <a:defRPr sz="1300">
+              <a:defRPr sz="1250">
                 <a:solidFill>
                   <a:srgbClr val="94A3B8"/>
                 </a:solidFill>
@@ -3464,7 +3464,7 @@
               </a:defRPr>
             </a:pPr>
             <a:r>
-              <a:t>Enforces stationarity across all 26 Colombo Stock Exchange equities, forcing models to learn genuine momentum and cyclical turning points.</a:t>
+              <a:t>Induces strict covariance stationarity and scale invariance across 26 CSE blue-chip equities, forcing gradient-boosted trees to isolate genuine momentum and mean-reversion.</a:t>
             </a:r>
           </a:p>
         </p:txBody>
@@ -3477,7 +3477,7 @@
         </p:nvSpPr>
         <p:spPr>
           <a:xfrm>
-            <a:off x="640080" y="8961120"/>
+            <a:off x="640080" y="8412480"/>
             <a:ext cx="6492240" cy="365760"/>
           </a:xfrm>
           <a:prstGeom prst="rect">
@@ -3486,6 +3486,78 @@
           <a:noFill/>
         </p:spPr>
         <p:txBody>
+          <a:bodyPr wrap="square">
+            <a:spAutoFit/>
+          </a:bodyPr>
+          <a:lstStyle/>
+          <a:p>
+            <a:pPr>
+              <a:defRPr sz="950" b="1">
+                <a:solidFill>
+                  <a:srgbClr val="64748B"/>
+                </a:solidFill>
+                <a:latin typeface="Consolas"/>
+              </a:defRPr>
+            </a:pPr>
+            <a:r>
+              <a:t>TECH STACK:  </a:t>
+            </a:r>
+            <a:r>
+              <a:rPr sz="950" b="1">
+                <a:solidFill>
+                  <a:srgbClr val="38BDF8"/>
+                </a:solidFill>
+                <a:latin typeface="Consolas"/>
+              </a:rPr>
+              <a:t> [NumPy] </a:t>
+            </a:r>
+            <a:r>
+              <a:rPr sz="950" b="1">
+                <a:solidFill>
+                  <a:srgbClr val="38BDF8"/>
+                </a:solidFill>
+                <a:latin typeface="Consolas"/>
+              </a:rPr>
+              <a:t> [Pandas] </a:t>
+            </a:r>
+            <a:r>
+              <a:rPr sz="950" b="1">
+                <a:solidFill>
+                  <a:srgbClr val="38BDF8"/>
+                </a:solidFill>
+                <a:latin typeface="Consolas"/>
+              </a:rPr>
+              <a:t> [Statistical Stationarity] </a:t>
+            </a:r>
+            <a:r>
+              <a:rPr sz="950" b="1">
+                <a:solidFill>
+                  <a:srgbClr val="38BDF8"/>
+                </a:solidFill>
+                <a:latin typeface="Consolas"/>
+              </a:rPr>
+              <a:t> [Unit Root I(1)] </a:t>
+            </a:r>
+          </a:p>
+        </p:txBody>
+      </p:sp>
+      <p:sp>
+        <p:nvSpPr>
+          <p:cNvPr id="11" name="TextBox 10"/>
+          <p:cNvSpPr txBox="1"/>
+          <p:nvPr/>
+        </p:nvSpPr>
+        <p:spPr>
+          <a:xfrm>
+            <a:off x="640080" y="9006840"/>
+            <a:ext cx="6492240" cy="320040"/>
+          </a:xfrm>
+          <a:prstGeom prst="rect">
+            <a:avLst/>
+          </a:prstGeom>
+          <a:noFill/>
+        </p:spPr>
+        <p:txBody>
           <a:bodyPr wrap="none">
             <a:spAutoFit/>
           </a:bodyPr>
@@ -3500,7 +3572,7 @@
               </a:defRPr>
             </a:pPr>
             <a:r>
-              <a:t>COLOMBO STOCK EXCHANGE (CSE) MLOPS</a:t>
+              <a:t>AI / ML SYSTEM ENGINEERING</a:t>
             </a:r>
             <a:r>
               <a:rPr b="1">
@@ -3582,8 +3654,8 @@
         </p:nvSpPr>
         <p:spPr>
           <a:xfrm>
-            <a:off x="640080" y="640080"/>
-            <a:ext cx="6492240" cy="320040"/>
+            <a:off x="640080" y="594360"/>
+            <a:ext cx="6492240" cy="274320"/>
           </a:xfrm>
           <a:prstGeom prst="rect">
             <a:avLst/>
@@ -3605,7 +3677,7 @@
               </a:defRPr>
             </a:pPr>
             <a:r>
-              <a:t>[ 02 / UNCERTAINTY CONES ]</a:t>
+              <a:t>[ 02 / DATA ENGINEERING &amp; LAKEHOUSE ]</a:t>
             </a:r>
           </a:p>
         </p:txBody>
@@ -3618,7 +3690,7 @@
         </p:nvSpPr>
         <p:spPr>
           <a:xfrm>
-            <a:off x="640080" y="1005840"/>
+            <a:off x="640080" y="896112"/>
             <a:ext cx="6492240" cy="1097280"/>
           </a:xfrm>
           <a:prstGeom prst="rect">
@@ -3633,7 +3705,7 @@
           <a:lstStyle/>
           <a:p>
             <a:pPr>
-              <a:defRPr sz="2800" b="1">
+              <a:defRPr sz="2700" b="1">
                 <a:solidFill>
                   <a:srgbClr val="F8FAFC"/>
                 </a:solidFill>
@@ -3641,7 +3713,7 @@
               </a:defRPr>
             </a:pPr>
             <a:r>
-              <a:t>Replacing Point Estimates with Risk Envelopes</a:t>
+              <a:t>High-Throughput Vectorized Feature Store</a:t>
             </a:r>
           </a:p>
         </p:txBody>
@@ -3654,8 +3726,8 @@
         </p:nvSpPr>
         <p:spPr>
           <a:xfrm>
-            <a:off x="640080" y="2148840"/>
-            <a:ext cx="6492240" cy="822960"/>
+            <a:off x="640080" y="2057400"/>
+            <a:ext cx="6492240" cy="777240"/>
           </a:xfrm>
           <a:prstGeom prst="rect">
             <a:avLst/>
@@ -3669,7 +3741,7 @@
           <a:lstStyle/>
           <a:p>
             <a:pPr>
-              <a:defRPr sz="1400">
+              <a:defRPr sz="1350">
                 <a:solidFill>
                   <a:srgbClr val="94A3B8"/>
                 </a:solidFill>
@@ -3677,7 +3749,7 @@
               </a:defRPr>
             </a:pPr>
             <a:r>
-              <a:t>Markets are probabilistic. We train three Multi-Quantile LightGBM models minimizing Pinball Loss.</a:t>
+              <a:t>Engineered a zero-copy Apache Parquet lakehouse coupled with 22 leak-free microstructure estimators.</a:t>
             </a:r>
           </a:p>
         </p:txBody>
@@ -3690,8 +3762,8 @@
         </p:nvSpPr>
         <p:spPr>
           <a:xfrm>
-            <a:off x="640080" y="3291840"/>
-            <a:ext cx="6492240" cy="1554480"/>
+            <a:off x="640080" y="3017520"/>
+            <a:ext cx="6492240" cy="2377440"/>
           </a:xfrm>
           <a:prstGeom prst="rect">
             <a:avLst/>
@@ -3701,7 +3773,7 @@
           </a:solidFill>
           <a:ln w="19050">
             <a:solidFill>
-              <a:srgbClr val="F87171"/>
+              <a:srgbClr val="38BDF8"/>
             </a:solidFill>
           </a:ln>
         </p:spPr>
@@ -3735,8 +3807,8 @@
         </p:nvSpPr>
         <p:spPr>
           <a:xfrm>
-            <a:off x="822960" y="3401568"/>
-            <a:ext cx="6126480" cy="1280160"/>
+            <a:off x="822960" y="3154680"/>
+            <a:ext cx="6126480" cy="2103120"/>
           </a:xfrm>
           <a:prstGeom prst="rect">
             <a:avLst/>
@@ -3750,24 +3822,15 @@
           <a:lstStyle/>
           <a:p>
             <a:pPr>
-              <a:defRPr sz="1600" b="1">
-                <a:solidFill>
-                  <a:srgbClr val="F87171"/>
-                </a:solidFill>
-                <a:latin typeface="Trebuchet MS"/>
-              </a:defRPr>
-            </a:pPr>
-            <a:r>
-              <a:t>P10 Floor   </a:t>
-            </a:r>
-            <a:r>
-              <a:rPr sz="1100">
-                <a:solidFill>
-                  <a:srgbClr val="64748B"/>
+              <a:defRPr sz="1100" b="1">
+                <a:solidFill>
+                  <a:srgbClr val="38BDF8"/>
                 </a:solidFill>
                 <a:latin typeface="Consolas"/>
-              </a:rPr>
-              <a:t>[Quantile 0.10]</a:t>
+              </a:defRPr>
+            </a:pPr>
+            <a:r>
+              <a:t>COLUMNAR ZERO-COPY SERVING LAYER</a:t>
             </a:r>
           </a:p>
           <a:p>
@@ -3775,15 +3838,31 @@
               <a:spcBef>
                 <a:spcPts val="600"/>
               </a:spcBef>
-              <a:defRPr sz="1300">
+              <a:defRPr sz="1700" b="1">
                 <a:solidFill>
                   <a:srgbClr val="F8FAFC"/>
                 </a:solidFill>
+                <a:latin typeface="Trebuchet MS"/>
+              </a:defRPr>
+            </a:pPr>
+            <a:r>
+              <a:t>Apache Parquet + PyArrow + DuckDB</a:t>
+            </a:r>
+          </a:p>
+          <a:p>
+            <a:pPr>
+              <a:spcBef>
+                <a:spcPts val="800"/>
+              </a:spcBef>
+              <a:defRPr sz="1250">
+                <a:solidFill>
+                  <a:srgbClr val="94A3B8"/>
+                </a:solidFill>
                 <a:latin typeface="Calibri"/>
               </a:defRPr>
             </a:pPr>
             <a:r>
-              <a:t>Downside Value-at-Risk support boundary. Penalizes extreme drawdowns 9x more than upside misses.</a:t>
+              <a:t>Sub-millisecond columnar partition scans for all 26 equities (data/processed/*.parquet), bypassing slow SQL connection latency during real-time inference.</a:t>
             </a:r>
           </a:p>
         </p:txBody>
@@ -3796,8 +3875,8 @@
         </p:nvSpPr>
         <p:spPr>
           <a:xfrm>
-            <a:off x="640080" y="5074920"/>
-            <a:ext cx="6492240" cy="1554480"/>
+            <a:off x="640080" y="5577840"/>
+            <a:ext cx="6492240" cy="2560320"/>
           </a:xfrm>
           <a:prstGeom prst="rect">
             <a:avLst/>
@@ -3841,8 +3920,8 @@
         </p:nvSpPr>
         <p:spPr>
           <a:xfrm>
-            <a:off x="822960" y="5184648"/>
-            <a:ext cx="6126480" cy="1280160"/>
+            <a:off x="822960" y="5715000"/>
+            <a:ext cx="6126480" cy="2286000"/>
           </a:xfrm>
           <a:prstGeom prst="rect">
             <a:avLst/>
@@ -3856,24 +3935,15 @@
           <a:lstStyle/>
           <a:p>
             <a:pPr>
-              <a:defRPr sz="1600" b="1">
+              <a:defRPr sz="1100" b="1">
                 <a:solidFill>
                   <a:srgbClr val="38BDF8"/>
                 </a:solidFill>
-                <a:latin typeface="Trebuchet MS"/>
-              </a:defRPr>
-            </a:pPr>
-            <a:r>
-              <a:t>P50 Median   </a:t>
-            </a:r>
-            <a:r>
-              <a:rPr sz="1100">
-                <a:solidFill>
-                  <a:srgbClr val="64748B"/>
-                </a:solidFill>
                 <a:latin typeface="Consolas"/>
-              </a:rPr>
-              <a:t>[Quantile 0.50]</a:t>
+              </a:defRPr>
+            </a:pPr>
+            <a:r>
+              <a:t>VECTORIZED MARKET DYNAMICS PIPELINE</a:t>
             </a:r>
           </a:p>
           <a:p>
@@ -3881,7 +3951,7 @@
               <a:spcBef>
                 <a:spcPts val="600"/>
               </a:spcBef>
-              <a:defRPr sz="1300">
+              <a:defRPr sz="1200">
                 <a:solidFill>
                   <a:srgbClr val="F8FAFC"/>
                 </a:solidFill>
@@ -3889,66 +3959,53 @@
               </a:defRPr>
             </a:pPr>
             <a:r>
-              <a:t>Expected median return trajectory. Minimizes MAE, robust against illiquid price spikes.</a:t>
-            </a:r>
-          </a:p>
-        </p:txBody>
-      </p:sp>
-      <p:sp>
-        <p:nvSpPr>
-          <p:cNvPr id="10" name="Rectangle 9"/>
-          <p:cNvSpPr/>
-          <p:nvPr/>
-        </p:nvSpPr>
-        <p:spPr>
-          <a:xfrm>
-            <a:off x="640080" y="6858000"/>
-            <a:ext cx="6492240" cy="1554480"/>
-          </a:xfrm>
-          <a:prstGeom prst="rect">
-            <a:avLst/>
-          </a:prstGeom>
-          <a:solidFill>
-            <a:srgbClr val="111722"/>
-          </a:solidFill>
-          <a:ln w="19050">
-            <a:solidFill>
-              <a:srgbClr val="34D399"/>
-            </a:solidFill>
-          </a:ln>
-        </p:spPr>
-        <p:style>
-          <a:lnRef idx="1">
-            <a:schemeClr val="accent1"/>
-          </a:lnRef>
-          <a:fillRef idx="3">
-            <a:schemeClr val="accent1"/>
-          </a:fillRef>
-          <a:effectRef idx="2">
-            <a:schemeClr val="accent1"/>
-          </a:effectRef>
-          <a:fontRef idx="minor">
-            <a:schemeClr val="lt1"/>
-          </a:fontRef>
-        </p:style>
-        <p:txBody>
-          <a:bodyPr rtlCol="0" anchor="ctr"/>
-          <a:lstStyle/>
-          <a:p>
-            <a:pPr algn="ctr"/>
-          </a:p>
-        </p:txBody>
-      </p:sp>
-      <p:sp>
-        <p:nvSpPr>
-          <p:cNvPr id="11" name="TextBox 10"/>
+              <a:t>• Parkinson Volatility: High-Low dispersion (5x more efficient than close-to-close)</a:t>
+            </a:r>
+          </a:p>
+          <a:p>
+            <a:pPr>
+              <a:spcBef>
+                <a:spcPts val="600"/>
+              </a:spcBef>
+              <a:defRPr sz="1200">
+                <a:solidFill>
+                  <a:srgbClr val="F8FAFC"/>
+                </a:solidFill>
+                <a:latin typeface="Calibri"/>
+              </a:defRPr>
+            </a:pPr>
+            <a:r>
+              <a:t>• Momentum &amp; Trend: Wilder RSI(14), MACD Histogram, 20/50 SMA Golden Cross</a:t>
+            </a:r>
+          </a:p>
+          <a:p>
+            <a:pPr>
+              <a:spcBef>
+                <a:spcPts val="600"/>
+              </a:spcBef>
+              <a:defRPr sz="1200">
+                <a:solidFill>
+                  <a:srgbClr val="F8FAFC"/>
+                </a:solidFill>
+                <a:latin typeface="Calibri"/>
+              </a:defRPr>
+            </a:pPr>
+            <a:r>
+              <a:t>• Systematic Beta: ASPI 30-Day relative alpha spread &amp; rolling Pearson correlation</a:t>
+            </a:r>
+          </a:p>
+        </p:txBody>
+      </p:sp>
+      <p:sp>
+        <p:nvSpPr>
+          <p:cNvPr id="10" name="TextBox 9"/>
           <p:cNvSpPr txBox="1"/>
           <p:nvPr/>
         </p:nvSpPr>
         <p:spPr>
           <a:xfrm>
-            <a:off x="822960" y="6967728"/>
-            <a:ext cx="6126480" cy="1280160"/>
+            <a:off x="640080" y="8412480"/>
+            <a:ext cx="6492240" cy="365760"/>
           </a:xfrm>
           <a:prstGeom prst="rect">
             <a:avLst/>
@@ -3962,54 +4019,74 @@
           <a:lstStyle/>
           <a:p>
             <a:pPr>
-              <a:defRPr sz="1600" b="1">
-                <a:solidFill>
-                  <a:srgbClr val="34D399"/>
-                </a:solidFill>
-                <a:latin typeface="Trebuchet MS"/>
-              </a:defRPr>
-            </a:pPr>
-            <a:r>
-              <a:t>P90 Ceiling   </a:t>
-            </a:r>
-            <a:r>
-              <a:rPr sz="1100">
+              <a:defRPr sz="950" b="1">
                 <a:solidFill>
                   <a:srgbClr val="64748B"/>
+                </a:solidFill>
+                <a:latin typeface="Consolas"/>
+              </a:defRPr>
+            </a:pPr>
+            <a:r>
+              <a:t>TECH STACK:  </a:t>
+            </a:r>
+            <a:r>
+              <a:rPr sz="950" b="1">
+                <a:solidFill>
+                  <a:srgbClr val="38BDF8"/>
                 </a:solidFill>
                 <a:latin typeface="Consolas"/>
               </a:rPr>
-              <a:t>[Quantile 0.90]</a:t>
-            </a:r>
-          </a:p>
-          <a:p>
-            <a:pPr>
-              <a:spcBef>
-                <a:spcPts val="600"/>
-              </a:spcBef>
-              <a:defRPr sz="1300">
-                <a:solidFill>
-                  <a:srgbClr val="F8FAFC"/>
-                </a:solidFill>
-                <a:latin typeface="Calibri"/>
-              </a:defRPr>
-            </a:pPr>
-            <a:r>
-              <a:t>Bullish expansion envelope indicating upper momentum resistance levels.</a:t>
-            </a:r>
-          </a:p>
-        </p:txBody>
-      </p:sp>
-      <p:sp>
-        <p:nvSpPr>
-          <p:cNvPr id="12" name="TextBox 11"/>
+              <a:t> [Apache Parquet] </a:t>
+            </a:r>
+            <a:r>
+              <a:rPr sz="950" b="1">
+                <a:solidFill>
+                  <a:srgbClr val="38BDF8"/>
+                </a:solidFill>
+                <a:latin typeface="Consolas"/>
+              </a:rPr>
+              <a:t> [PyArrow] </a:t>
+            </a:r>
+            <a:r>
+              <a:rPr sz="950" b="1">
+                <a:solidFill>
+                  <a:srgbClr val="38BDF8"/>
+                </a:solidFill>
+                <a:latin typeface="Consolas"/>
+              </a:rPr>
+              <a:t> [DuckDB] </a:t>
+            </a:r>
+            <a:r>
+              <a:rPr sz="950" b="1">
+                <a:solidFill>
+                  <a:srgbClr val="38BDF8"/>
+                </a:solidFill>
+                <a:latin typeface="Consolas"/>
+              </a:rPr>
+              <a:t> [Vectorized Math] </a:t>
+            </a:r>
+            <a:r>
+              <a:rPr sz="950" b="1">
+                <a:solidFill>
+                  <a:srgbClr val="38BDF8"/>
+                </a:solidFill>
+                <a:latin typeface="Consolas"/>
+              </a:rPr>
+              <a:t> [ETL Pipelines] </a:t>
+            </a:r>
+          </a:p>
+        </p:txBody>
+      </p:sp>
+      <p:sp>
+        <p:nvSpPr>
+          <p:cNvPr id="11" name="TextBox 10"/>
           <p:cNvSpPr txBox="1"/>
           <p:nvPr/>
         </p:nvSpPr>
         <p:spPr>
           <a:xfrm>
-            <a:off x="640080" y="8961120"/>
-            <a:ext cx="6492240" cy="365760"/>
+            <a:off x="640080" y="9006840"/>
+            <a:ext cx="6492240" cy="320040"/>
           </a:xfrm>
           <a:prstGeom prst="rect">
             <a:avLst/>
@@ -4031,7 +4108,7 @@
               </a:defRPr>
             </a:pPr>
             <a:r>
-              <a:t>COLOMBO STOCK EXCHANGE (CSE) MLOPS</a:t>
+              <a:t>AI / ML SYSTEM ENGINEERING</a:t>
             </a:r>
             <a:r>
               <a:rPr b="1">
@@ -4113,8 +4190,8 @@
         </p:nvSpPr>
         <p:spPr>
           <a:xfrm>
-            <a:off x="640080" y="640080"/>
-            <a:ext cx="6492240" cy="320040"/>
+            <a:off x="640080" y="594360"/>
+            <a:ext cx="6492240" cy="274320"/>
           </a:xfrm>
           <a:prstGeom prst="rect">
             <a:avLst/>
@@ -4136,7 +4213,7 @@
               </a:defRPr>
             </a:pPr>
             <a:r>
-              <a:t>[ 03 / VALIDATION RIGOR ]</a:t>
+              <a:t>[ 03 / MLOPS &amp; ALGORITHMIC RIGOR ]</a:t>
             </a:r>
           </a:p>
         </p:txBody>
@@ -4149,7 +4226,7 @@
         </p:nvSpPr>
         <p:spPr>
           <a:xfrm>
-            <a:off x="640080" y="1005840"/>
+            <a:off x="640080" y="896112"/>
             <a:ext cx="6492240" cy="1097280"/>
           </a:xfrm>
           <a:prstGeom prst="rect">
@@ -4164,7 +4241,7 @@
           <a:lstStyle/>
           <a:p>
             <a:pPr>
-              <a:defRPr sz="2800" b="1">
+              <a:defRPr sz="2700" b="1">
                 <a:solidFill>
                   <a:srgbClr val="F8FAFC"/>
                 </a:solidFill>
@@ -4172,7 +4249,7 @@
               </a:defRPr>
             </a:pPr>
             <a:r>
-              <a:t>Zero Lookahead Leakage: Purged &amp; Embargoed CV</a:t>
+              <a:t>Purged Cross-Validation &amp; Quantile Loss</a:t>
             </a:r>
           </a:p>
         </p:txBody>
@@ -4185,8 +4262,8 @@
         </p:nvSpPr>
         <p:spPr>
           <a:xfrm>
-            <a:off x="640080" y="2148840"/>
-            <a:ext cx="6492240" cy="822960"/>
+            <a:off x="640080" y="2057400"/>
+            <a:ext cx="6492240" cy="777240"/>
           </a:xfrm>
           <a:prstGeom prst="rect">
             <a:avLst/>
@@ -4200,7 +4277,7 @@
           <a:lstStyle/>
           <a:p>
             <a:pPr>
-              <a:defRPr sz="1400">
+              <a:defRPr sz="1350">
                 <a:solidFill>
                   <a:srgbClr val="94A3B8"/>
                 </a:solidFill>
@@ -4208,7 +4285,7 @@
               </a:defRPr>
             </a:pPr>
             <a:r>
-              <a:t>A 30-day forward return target leaks data if standard K-Fold CV is used. We enforce a 30-day purge buffer.</a:t>
+              <a:t>Preventing overlapping target contamination with purged embargo gaps while optimizing asymmetric Pinball Loss.</a:t>
             </a:r>
           </a:p>
         </p:txBody>
@@ -4221,8 +4298,8 @@
         </p:nvSpPr>
         <p:spPr>
           <a:xfrm>
-            <a:off x="640080" y="3291840"/>
-            <a:ext cx="6492240" cy="2377440"/>
+            <a:off x="640080" y="3017520"/>
+            <a:ext cx="6492240" cy="2286000"/>
           </a:xfrm>
           <a:prstGeom prst="rect">
             <a:avLst/>
@@ -4266,8 +4343,8 @@
         </p:nvSpPr>
         <p:spPr>
           <a:xfrm>
-            <a:off x="822960" y="3429000"/>
-            <a:ext cx="6126480" cy="2103120"/>
+            <a:off x="822960" y="3154680"/>
+            <a:ext cx="6126480" cy="2011680"/>
           </a:xfrm>
           <a:prstGeom prst="rect">
             <a:avLst/>
@@ -4289,31 +4366,23 @@
               </a:defRPr>
             </a:pPr>
             <a:r>
-              <a:t>[ 5-FOLD EXPANDING TIMELINE WITH EMBARGO ]</a:t>
+              <a:t>CUSTOM PURGED &amp; EMBARGOED WALK-FORWARD CV</a:t>
             </a:r>
           </a:p>
           <a:p>
             <a:pPr>
               <a:spcBef>
-                <a:spcPts val="1000"/>
+                <a:spcPts val="800"/>
               </a:spcBef>
-              <a:defRPr sz="1000">
+              <a:defRPr sz="1250">
                 <a:solidFill>
                   <a:srgbClr val="F8FAFC"/>
                 </a:solidFill>
-                <a:latin typeface="Consolas"/>
-              </a:defRPr>
-            </a:pPr>
-            <a:r>
-              <a:t>Fold 1: [== Train ==] [Purge: 30d] [Test: 60d] [Embargo: 30d]</a:t>
-            </a:r>
-            <a:br/>
-            <a:r>
-              <a:t>Fold 2: [==== Train ====] [Purge: 30d] [Test: 60d] [Embargo: 30d]</a:t>
-            </a:r>
-            <a:br/>
-            <a:r>
-              <a:t>Fold 3: [====== Train ======] [Purge: 30d] [Test: 60d] ...</a:t>
+                <a:latin typeface="Calibri"/>
+              </a:defRPr>
+            </a:pPr>
+            <a:r>
+              <a:t>Standard K-Fold leaks future 30-day returns. I built an expanding 5-fold CV engine with a 30-day purge gap (drops overlapping train labels) and a 30-day embargo buffer (kills serial correlation).</a:t>
             </a:r>
           </a:p>
         </p:txBody>
@@ -4326,8 +4395,8 @@
         </p:nvSpPr>
         <p:spPr>
           <a:xfrm>
-            <a:off x="640080" y="5943600"/>
-            <a:ext cx="3154680" cy="2377440"/>
+            <a:off x="640080" y="5486400"/>
+            <a:ext cx="6492240" cy="2651760"/>
           </a:xfrm>
           <a:prstGeom prst="rect">
             <a:avLst/>
@@ -4337,7 +4406,7 @@
           </a:solidFill>
           <a:ln w="19050">
             <a:solidFill>
-              <a:srgbClr val="38BDF8"/>
+              <a:srgbClr val="34D399"/>
             </a:solidFill>
           </a:ln>
         </p:spPr>
@@ -4371,8 +4440,8 @@
         </p:nvSpPr>
         <p:spPr>
           <a:xfrm>
-            <a:off x="822960" y="6080760"/>
-            <a:ext cx="2788920" cy="2103120"/>
+            <a:off x="822960" y="5623560"/>
+            <a:ext cx="6126480" cy="2377440"/>
           </a:xfrm>
           <a:prstGeom prst="rect">
             <a:avLst/>
@@ -4386,90 +4455,77 @@
           <a:lstStyle/>
           <a:p>
             <a:pPr>
-              <a:defRPr sz="1300" b="1">
-                <a:solidFill>
-                  <a:srgbClr val="38BDF8"/>
+              <a:defRPr sz="1100" b="1">
+                <a:solidFill>
+                  <a:srgbClr val="34D399"/>
                 </a:solidFill>
                 <a:latin typeface="Consolas"/>
               </a:defRPr>
             </a:pPr>
             <a:r>
-              <a:t>30-DAY PURGE</a:t>
+              <a:t>MULTI-QUANTILE LIGHTGBM (PINBALL LOSS)</a:t>
             </a:r>
           </a:p>
           <a:p>
             <a:pPr>
               <a:spcBef>
-                <a:spcPts val="800"/>
+                <a:spcPts val="600"/>
               </a:spcBef>
-              <a:defRPr sz="1300">
-                <a:solidFill>
-                  <a:srgbClr val="94A3B8"/>
+              <a:defRPr sz="1200">
+                <a:solidFill>
+                  <a:srgbClr val="F8FAFC"/>
                 </a:solidFill>
                 <a:latin typeface="Calibri"/>
               </a:defRPr>
             </a:pPr>
             <a:r>
-              <a:t>Drops training samples whose 30-day horizon overlaps with test dates.</a:t>
-            </a:r>
-          </a:p>
-        </p:txBody>
-      </p:sp>
-      <p:sp>
-        <p:nvSpPr>
-          <p:cNvPr id="10" name="Rectangle 9"/>
-          <p:cNvSpPr/>
-          <p:nvPr/>
-        </p:nvSpPr>
-        <p:spPr>
-          <a:xfrm>
-            <a:off x="3977639" y="5943600"/>
-            <a:ext cx="3154680" cy="2377440"/>
-          </a:xfrm>
-          <a:prstGeom prst="rect">
-            <a:avLst/>
-          </a:prstGeom>
-          <a:solidFill>
-            <a:srgbClr val="111722"/>
-          </a:solidFill>
-          <a:ln w="19050">
-            <a:solidFill>
-              <a:srgbClr val="34D399"/>
-            </a:solidFill>
-          </a:ln>
-        </p:spPr>
-        <p:style>
-          <a:lnRef idx="1">
-            <a:schemeClr val="accent1"/>
-          </a:lnRef>
-          <a:fillRef idx="3">
-            <a:schemeClr val="accent1"/>
-          </a:fillRef>
-          <a:effectRef idx="2">
-            <a:schemeClr val="accent1"/>
-          </a:effectRef>
-          <a:fontRef idx="minor">
-            <a:schemeClr val="lt1"/>
-          </a:fontRef>
-        </p:style>
-        <p:txBody>
-          <a:bodyPr rtlCol="0" anchor="ctr"/>
-          <a:lstStyle/>
-          <a:p>
-            <a:pPr algn="ctr"/>
-          </a:p>
-        </p:txBody>
-      </p:sp>
-      <p:sp>
-        <p:nvSpPr>
-          <p:cNvPr id="11" name="TextBox 10"/>
+              <a:t>• P10 Floor (q=0.10): Downside Value-at-Risk floor (9x penalty on drawdown misses)</a:t>
+            </a:r>
+          </a:p>
+          <a:p>
+            <a:pPr>
+              <a:spcBef>
+                <a:spcPts val="600"/>
+              </a:spcBef>
+              <a:defRPr sz="1200">
+                <a:solidFill>
+                  <a:srgbClr val="F8FAFC"/>
+                </a:solidFill>
+                <a:latin typeface="Calibri"/>
+              </a:defRPr>
+            </a:pPr>
+            <a:r>
+              <a:t>• P50 Median (q=0.50): Robust median expected trajectory (MAE optimization)</a:t>
+            </a:r>
+          </a:p>
+          <a:p>
+            <a:pPr>
+              <a:spcBef>
+                <a:spcPts val="600"/>
+              </a:spcBef>
+              <a:defRPr sz="1200">
+                <a:solidFill>
+                  <a:srgbClr val="F8FAFC"/>
+                </a:solidFill>
+                <a:latin typeface="Calibri"/>
+              </a:defRPr>
+            </a:pPr>
+            <a:r>
+              <a:t>• P90 Ceiling (q=0.90): Bullish expansion envelope (90th percentile resistance)</a:t>
+            </a:r>
+          </a:p>
+        </p:txBody>
+      </p:sp>
+      <p:sp>
+        <p:nvSpPr>
+          <p:cNvPr id="10" name="TextBox 9"/>
           <p:cNvSpPr txBox="1"/>
           <p:nvPr/>
         </p:nvSpPr>
         <p:spPr>
           <a:xfrm>
-            <a:off x="4160520" y="6080760"/>
-            <a:ext cx="2788920" cy="2103120"/>
+            <a:off x="640080" y="8412480"/>
+            <a:ext cx="6492240" cy="365760"/>
           </a:xfrm>
           <a:prstGeom prst="rect">
             <a:avLst/>
@@ -4483,45 +4539,74 @@
           <a:lstStyle/>
           <a:p>
             <a:pPr>
-              <a:defRPr sz="1300" b="1">
-                <a:solidFill>
-                  <a:srgbClr val="34D399"/>
+              <a:defRPr sz="950" b="1">
+                <a:solidFill>
+                  <a:srgbClr val="64748B"/>
                 </a:solidFill>
                 <a:latin typeface="Consolas"/>
               </a:defRPr>
             </a:pPr>
             <a:r>
-              <a:t>30-DAY EMBARGO</a:t>
-            </a:r>
-          </a:p>
-          <a:p>
-            <a:pPr>
-              <a:spcBef>
-                <a:spcPts val="800"/>
-              </a:spcBef>
-              <a:defRPr sz="1300">
-                <a:solidFill>
-                  <a:srgbClr val="94A3B8"/>
-                </a:solidFill>
-                <a:latin typeface="Calibri"/>
-              </a:defRPr>
-            </a:pPr>
-            <a:r>
-              <a:t>Blocks post-test auto-correlation spillover into future folds.</a:t>
-            </a:r>
-          </a:p>
-        </p:txBody>
-      </p:sp>
-      <p:sp>
-        <p:nvSpPr>
-          <p:cNvPr id="12" name="TextBox 11"/>
+              <a:t>TECH STACK:  </a:t>
+            </a:r>
+            <a:r>
+              <a:rPr sz="950" b="1">
+                <a:solidFill>
+                  <a:srgbClr val="38BDF8"/>
+                </a:solidFill>
+                <a:latin typeface="Consolas"/>
+              </a:rPr>
+              <a:t> [LightGBM] </a:t>
+            </a:r>
+            <a:r>
+              <a:rPr sz="950" b="1">
+                <a:solidFill>
+                  <a:srgbClr val="38BDF8"/>
+                </a:solidFill>
+                <a:latin typeface="Consolas"/>
+              </a:rPr>
+              <a:t> [Quantile Regression] </a:t>
+            </a:r>
+            <a:r>
+              <a:rPr sz="950" b="1">
+                <a:solidFill>
+                  <a:srgbClr val="38BDF8"/>
+                </a:solidFill>
+                <a:latin typeface="Consolas"/>
+              </a:rPr>
+              <a:t> [Pinball Loss] </a:t>
+            </a:r>
+            <a:r>
+              <a:rPr sz="950" b="1">
+                <a:solidFill>
+                  <a:srgbClr val="38BDF8"/>
+                </a:solidFill>
+                <a:latin typeface="Consolas"/>
+              </a:rPr>
+              <a:t> [Purged &amp; Embargoed CV] </a:t>
+            </a:r>
+            <a:r>
+              <a:rPr sz="950" b="1">
+                <a:solidFill>
+                  <a:srgbClr val="38BDF8"/>
+                </a:solidFill>
+                <a:latin typeface="Consolas"/>
+              </a:rPr>
+              <a:t> [Scikit-Learn] </a:t>
+            </a:r>
+          </a:p>
+        </p:txBody>
+      </p:sp>
+      <p:sp>
+        <p:nvSpPr>
+          <p:cNvPr id="11" name="TextBox 10"/>
           <p:cNvSpPr txBox="1"/>
           <p:nvPr/>
         </p:nvSpPr>
         <p:spPr>
           <a:xfrm>
-            <a:off x="640080" y="8961120"/>
-            <a:ext cx="6492240" cy="365760"/>
+            <a:off x="640080" y="9006840"/>
+            <a:ext cx="6492240" cy="320040"/>
           </a:xfrm>
           <a:prstGeom prst="rect">
             <a:avLst/>
@@ -4543,7 +4628,7 @@
               </a:defRPr>
             </a:pPr>
             <a:r>
-              <a:t>COLOMBO STOCK EXCHANGE (CSE) MLOPS</a:t>
+              <a:t>AI / ML SYSTEM ENGINEERING</a:t>
             </a:r>
             <a:r>
               <a:rPr b="1">
@@ -4625,8 +4710,8 @@
         </p:nvSpPr>
         <p:spPr>
           <a:xfrm>
-            <a:off x="640080" y="640080"/>
-            <a:ext cx="6492240" cy="320040"/>
+            <a:off x="640080" y="594360"/>
+            <a:ext cx="6492240" cy="274320"/>
           </a:xfrm>
           <a:prstGeom prst="rect">
             <a:avLst/>
@@ -4648,7 +4733,7 @@
               </a:defRPr>
             </a:pPr>
             <a:r>
-              <a:t>[ 04 / EXPLAINABLE AI ]</a:t>
+              <a:t>[ 04 / EXPLAINABLE AI &amp; INTERPRETABILITY ]</a:t>
             </a:r>
           </a:p>
         </p:txBody>
@@ -4661,7 +4746,7 @@
         </p:nvSpPr>
         <p:spPr>
           <a:xfrm>
-            <a:off x="640080" y="1005840"/>
+            <a:off x="640080" y="896112"/>
             <a:ext cx="6492240" cy="1097280"/>
           </a:xfrm>
           <a:prstGeom prst="rect">
@@ -4676,7 +4761,7 @@
           <a:lstStyle/>
           <a:p>
             <a:pPr>
-              <a:defRPr sz="2800" b="1">
+              <a:defRPr sz="2700" b="1">
                 <a:solidFill>
                   <a:srgbClr val="F8FAFC"/>
                 </a:solidFill>
@@ -4684,7 +4769,7 @@
               </a:defRPr>
             </a:pPr>
             <a:r>
-              <a:t>Solving the Black-Box Dilemma</a:t>
+              <a:t>Dual-Layer Transparent XAI Architecture</a:t>
             </a:r>
           </a:p>
         </p:txBody>
@@ -4697,8 +4782,8 @@
         </p:nvSpPr>
         <p:spPr>
           <a:xfrm>
-            <a:off x="640080" y="2148840"/>
-            <a:ext cx="6492240" cy="822960"/>
+            <a:off x="640080" y="2057400"/>
+            <a:ext cx="6492240" cy="777240"/>
           </a:xfrm>
           <a:prstGeom prst="rect">
             <a:avLst/>
@@ -4712,7 +4797,7 @@
           <a:lstStyle/>
           <a:p>
             <a:pPr>
-              <a:defRPr sz="1400">
+              <a:defRPr sz="1350">
                 <a:solidFill>
                   <a:srgbClr val="94A3B8"/>
                 </a:solidFill>
@@ -4720,7 +4805,7 @@
               </a:defRPr>
             </a:pPr>
             <a:r>
-              <a:t>Bridging mathematical Shapley attributions with institutional trader heuristic cards.</a:t>
+              <a:t>Bridging mathematically verified Shapley attribution with domain-driven heuristic validation rules.</a:t>
             </a:r>
           </a:p>
         </p:txBody>
@@ -4733,7 +4818,7 @@
         </p:nvSpPr>
         <p:spPr>
           <a:xfrm>
-            <a:off x="640080" y="3291840"/>
+            <a:off x="640080" y="3017520"/>
             <a:ext cx="6492240" cy="2377440"/>
           </a:xfrm>
           <a:prstGeom prst="rect">
@@ -4778,7 +4863,7 @@
         </p:nvSpPr>
         <p:spPr>
           <a:xfrm>
-            <a:off x="822960" y="3429000"/>
+            <a:off x="822960" y="3154680"/>
             <a:ext cx="6126480" cy="2103120"/>
           </a:xfrm>
           <a:prstGeom prst="rect">
@@ -4801,7 +4886,7 @@
               </a:defRPr>
             </a:pPr>
             <a:r>
-              <a:t>[ LAYER 1: MATHEMATICAL TREESHAP ]</a:t>
+              <a:t>LAYER 1: EXACT TREESHAP ATTRIBUTION</a:t>
             </a:r>
           </a:p>
           <a:p>
@@ -4809,7 +4894,7 @@
               <a:spcBef>
                 <a:spcPts val="600"/>
               </a:spcBef>
-              <a:defRPr sz="1800" b="1">
+              <a:defRPr sz="1600" b="1">
                 <a:solidFill>
                   <a:srgbClr val="F8FAFC"/>
                 </a:solidFill>
@@ -4817,7 +4902,7 @@
               </a:defRPr>
             </a:pPr>
             <a:r>
-              <a:t>Exact Additive Shapley Values</a:t>
+              <a:t>y_hat = phi_0 + sum( phi_i )   [Exact Additive Decomp]</a:t>
             </a:r>
           </a:p>
           <a:p>
@@ -4825,7 +4910,7 @@
               <a:spcBef>
                 <a:spcPts val="800"/>
               </a:spcBef>
-              <a:defRPr sz="1300">
+              <a:defRPr sz="1250">
                 <a:solidFill>
                   <a:srgbClr val="94A3B8"/>
                 </a:solidFill>
@@ -4833,7 +4918,7 @@
               </a:defRPr>
             </a:pPr>
             <a:r>
-              <a:t>Decomposes predicted return into exact basis-point contributions: Parkinson Volatility, RSI momentum, and ASPI relative alpha.</a:t>
+              <a:t>Calculates exact game-theoretic Shapley values directly across tree ensemble paths, decomposing predicted returns into basis-point impacts with 100% additivity verification in pytest.</a:t>
             </a:r>
           </a:p>
         </p:txBody>
@@ -4846,8 +4931,8 @@
         </p:nvSpPr>
         <p:spPr>
           <a:xfrm>
-            <a:off x="640080" y="5943600"/>
-            <a:ext cx="6492240" cy="2377440"/>
+            <a:off x="640080" y="5577840"/>
+            <a:ext cx="6492240" cy="2560320"/>
           </a:xfrm>
           <a:prstGeom prst="rect">
             <a:avLst/>
@@ -4891,8 +4976,8 @@
         </p:nvSpPr>
         <p:spPr>
           <a:xfrm>
-            <a:off x="822960" y="6080760"/>
-            <a:ext cx="6126480" cy="2103120"/>
+            <a:off x="822960" y="5715000"/>
+            <a:ext cx="6126480" cy="2286000"/>
           </a:xfrm>
           <a:prstGeom prst="rect">
             <a:avLst/>
@@ -4914,7 +4999,7 @@
               </a:defRPr>
             </a:pPr>
             <a:r>
-              <a:t>[ LAYER 2: DOMAIN HEURISTIC ALIGNMENT ]</a:t>
+              <a:t>LAYER 2: DOMAIN HEURISTIC VALIDATION ENGINE</a:t>
             </a:r>
           </a:p>
           <a:p>
@@ -4922,31 +5007,47 @@
               <a:spcBef>
                 <a:spcPts val="600"/>
               </a:spcBef>
-              <a:defRPr sz="1800" b="1">
+              <a:defRPr sz="1200">
                 <a:solidFill>
                   <a:srgbClr val="F8FAFC"/>
                 </a:solidFill>
-                <a:latin typeface="Trebuchet MS"/>
-              </a:defRPr>
-            </a:pPr>
-            <a:r>
-              <a:t>Trader Intuition Validation</a:t>
+                <a:latin typeface="Calibri"/>
+              </a:defRPr>
+            </a:pPr>
+            <a:r>
+              <a:t>• SUPPORTING: Setup confirms forecast (e.g. RSI momentum &lt;70 without exhaustion)</a:t>
             </a:r>
           </a:p>
           <a:p>
             <a:pPr>
               <a:spcBef>
-                <a:spcPts val="800"/>
+                <a:spcPts val="600"/>
               </a:spcBef>
-              <a:defRPr sz="1300">
-                <a:solidFill>
-                  <a:srgbClr val="94A3B8"/>
+              <a:defRPr sz="1200">
+                <a:solidFill>
+                  <a:srgbClr val="F8FAFC"/>
                 </a:solidFill>
                 <a:latin typeface="Calibri"/>
               </a:defRPr>
             </a:pPr>
             <a:r>
-              <a:t>Cross-verifies setup across Wilder RSI, 20/50 SMA trend, Parkinson volatility, and Volume surge into Supporting, Risk, or Neutral badges.</a:t>
+              <a:t>• REJECTING / RISK: Warns of counter-trend risk (e.g. elevated Parkinson volatility)</a:t>
+            </a:r>
+          </a:p>
+          <a:p>
+            <a:pPr>
+              <a:spcBef>
+                <a:spcPts val="600"/>
+              </a:spcBef>
+              <a:defRPr sz="1200">
+                <a:solidFill>
+                  <a:srgbClr val="F8FAFC"/>
+                </a:solidFill>
+                <a:latin typeface="Calibri"/>
+              </a:defRPr>
+            </a:pPr>
+            <a:r>
+              <a:t>• NEUTRAL: Stable baseline alignment (e.g. volume consolidation)</a:t>
             </a:r>
           </a:p>
         </p:txBody>
@@ -4959,7 +5060,7 @@
         </p:nvSpPr>
         <p:spPr>
           <a:xfrm>
-            <a:off x="640080" y="8961120"/>
+            <a:off x="640080" y="8412480"/>
             <a:ext cx="6492240" cy="365760"/>
           </a:xfrm>
           <a:prstGeom prst="rect">
@@ -4968,6 +5069,78 @@
           <a:noFill/>
         </p:spPr>
         <p:txBody>
+          <a:bodyPr wrap="square">
+            <a:spAutoFit/>
+          </a:bodyPr>
+          <a:lstStyle/>
+          <a:p>
+            <a:pPr>
+              <a:defRPr sz="950" b="1">
+                <a:solidFill>
+                  <a:srgbClr val="64748B"/>
+                </a:solidFill>
+                <a:latin typeface="Consolas"/>
+              </a:defRPr>
+            </a:pPr>
+            <a:r>
+              <a:t>TECH STACK:  </a:t>
+            </a:r>
+            <a:r>
+              <a:rPr sz="950" b="1">
+                <a:solidFill>
+                  <a:srgbClr val="38BDF8"/>
+                </a:solidFill>
+                <a:latin typeface="Consolas"/>
+              </a:rPr>
+              <a:t> [TreeSHAP] </a:t>
+            </a:r>
+            <a:r>
+              <a:rPr sz="950" b="1">
+                <a:solidFill>
+                  <a:srgbClr val="38BDF8"/>
+                </a:solidFill>
+                <a:latin typeface="Consolas"/>
+              </a:rPr>
+              <a:t> [Local Feature Attribution] </a:t>
+            </a:r>
+            <a:r>
+              <a:rPr sz="950" b="1">
+                <a:solidFill>
+                  <a:srgbClr val="38BDF8"/>
+                </a:solidFill>
+                <a:latin typeface="Consolas"/>
+              </a:rPr>
+              <a:t> [Rule Engines] </a:t>
+            </a:r>
+            <a:r>
+              <a:rPr sz="950" b="1">
+                <a:solidFill>
+                  <a:srgbClr val="38BDF8"/>
+                </a:solidFill>
+                <a:latin typeface="Consolas"/>
+              </a:rPr>
+              <a:t> [XAI Pytest Additivity] </a:t>
+            </a:r>
+          </a:p>
+        </p:txBody>
+      </p:sp>
+      <p:sp>
+        <p:nvSpPr>
+          <p:cNvPr id="11" name="TextBox 10"/>
+          <p:cNvSpPr txBox="1"/>
+          <p:nvPr/>
+        </p:nvSpPr>
+        <p:spPr>
+          <a:xfrm>
+            <a:off x="640080" y="9006840"/>
+            <a:ext cx="6492240" cy="320040"/>
+          </a:xfrm>
+          <a:prstGeom prst="rect">
+            <a:avLst/>
+          </a:prstGeom>
+          <a:noFill/>
+        </p:spPr>
+        <p:txBody>
           <a:bodyPr wrap="none">
             <a:spAutoFit/>
           </a:bodyPr>
@@ -4982,7 +5155,7 @@
               </a:defRPr>
             </a:pPr>
             <a:r>
-              <a:t>COLOMBO STOCK EXCHANGE (CSE) MLOPS</a:t>
+              <a:t>AI / ML SYSTEM ENGINEERING</a:t>
             </a:r>
             <a:r>
               <a:rPr b="1">
@@ -5064,8 +5237,8 @@
         </p:nvSpPr>
         <p:spPr>
           <a:xfrm>
-            <a:off x="640080" y="640080"/>
-            <a:ext cx="6492240" cy="320040"/>
+            <a:off x="640080" y="594360"/>
+            <a:ext cx="6492240" cy="274320"/>
           </a:xfrm>
           <a:prstGeom prst="rect">
             <a:avLst/>
@@ -5087,7 +5260,7 @@
               </a:defRPr>
             </a:pPr>
             <a:r>
-              <a:t>[ 05 / RESULTS &amp; STACK ]</a:t>
+              <a:t>[ 05 / FULL-STACK CLOUD ARCHITECTURE ]</a:t>
             </a:r>
           </a:p>
         </p:txBody>
@@ -5100,7 +5273,7 @@
         </p:nvSpPr>
         <p:spPr>
           <a:xfrm>
-            <a:off x="640080" y="1005840"/>
+            <a:off x="640080" y="896112"/>
             <a:ext cx="6492240" cy="1097280"/>
           </a:xfrm>
           <a:prstGeom prst="rect">
@@ -5115,7 +5288,7 @@
           <a:lstStyle/>
           <a:p>
             <a:pPr>
-              <a:defRPr sz="2800" b="1">
+              <a:defRPr sz="2700" b="1">
                 <a:solidFill>
                   <a:srgbClr val="F8FAFC"/>
                 </a:solidFill>
@@ -5123,7 +5296,7 @@
               </a:defRPr>
             </a:pPr>
             <a:r>
-              <a:t>Empirical Results &amp; Live Architecture</a:t>
+              <a:t>Production Serving &amp; Empirical Results</a:t>
             </a:r>
           </a:p>
         </p:txBody>
@@ -5136,8 +5309,8 @@
         </p:nvSpPr>
         <p:spPr>
           <a:xfrm>
-            <a:off x="640080" y="2148840"/>
-            <a:ext cx="6492240" cy="822960"/>
+            <a:off x="640080" y="2057400"/>
+            <a:ext cx="6492240" cy="777240"/>
           </a:xfrm>
           <a:prstGeom prst="rect">
             <a:avLst/>
@@ -5151,7 +5324,7 @@
           <a:lstStyle/>
           <a:p>
             <a:pPr>
-              <a:defRPr sz="1400">
+              <a:defRPr sz="1350">
                 <a:solidFill>
                   <a:srgbClr val="94A3B8"/>
                 </a:solidFill>
@@ -5159,7 +5332,7 @@
               </a:defRPr>
             </a:pPr>
             <a:r>
-              <a:t>Validated out-of-sample edge deployed on a zero-cost 100% free cloud architecture.</a:t>
+              <a:t>Production-grade full-stack financial terminal deployed on a zero-cost automated cloud topology.</a:t>
             </a:r>
           </a:p>
         </p:txBody>
@@ -5172,8 +5345,8 @@
         </p:nvSpPr>
         <p:spPr>
           <a:xfrm>
-            <a:off x="640080" y="3291840"/>
-            <a:ext cx="2011680" cy="2103120"/>
+            <a:off x="640080" y="3017520"/>
+            <a:ext cx="2011680" cy="1828800"/>
           </a:xfrm>
           <a:prstGeom prst="rect">
             <a:avLst/>
@@ -5217,8 +5390,8 @@
         </p:nvSpPr>
         <p:spPr>
           <a:xfrm>
-            <a:off x="731520" y="3474720"/>
-            <a:ext cx="1828800" cy="1737360"/>
+            <a:off x="731520" y="3154680"/>
+            <a:ext cx="1828800" cy="1554480"/>
           </a:xfrm>
           <a:prstGeom prst="rect">
             <a:avLst/>
@@ -5248,7 +5421,7 @@
               <a:spcBef>
                 <a:spcPts val="400"/>
               </a:spcBef>
-              <a:defRPr sz="950" b="1">
+              <a:defRPr sz="900" b="1">
                 <a:solidFill>
                   <a:srgbClr val="F8FAFC"/>
                 </a:solidFill>
@@ -5264,7 +5437,7 @@
               <a:spcBef>
                 <a:spcPts val="400"/>
               </a:spcBef>
-              <a:defRPr sz="950">
+              <a:defRPr sz="900">
                 <a:solidFill>
                   <a:srgbClr val="64748B"/>
                 </a:solidFill>
@@ -5285,8 +5458,8 @@
         </p:nvSpPr>
         <p:spPr>
           <a:xfrm>
-            <a:off x="2880360" y="3291840"/>
-            <a:ext cx="2011680" cy="2103120"/>
+            <a:off x="2880360" y="3017520"/>
+            <a:ext cx="2011680" cy="1828800"/>
           </a:xfrm>
           <a:prstGeom prst="rect">
             <a:avLst/>
@@ -5330,8 +5503,8 @@
         </p:nvSpPr>
         <p:spPr>
           <a:xfrm>
-            <a:off x="2971800" y="3474720"/>
-            <a:ext cx="1828800" cy="1737360"/>
+            <a:off x="2971800" y="3154680"/>
+            <a:ext cx="1828800" cy="1554480"/>
           </a:xfrm>
           <a:prstGeom prst="rect">
             <a:avLst/>
@@ -5361,7 +5534,7 @@
               <a:spcBef>
                 <a:spcPts val="400"/>
               </a:spcBef>
-              <a:defRPr sz="950" b="1">
+              <a:defRPr sz="900" b="1">
                 <a:solidFill>
                   <a:srgbClr val="F8FAFC"/>
                 </a:solidFill>
@@ -5377,7 +5550,7 @@
               <a:spcBef>
                 <a:spcPts val="400"/>
               </a:spcBef>
-              <a:defRPr sz="950">
+              <a:defRPr sz="900">
                 <a:solidFill>
                   <a:srgbClr val="64748B"/>
                 </a:solidFill>
@@ -5385,7 +5558,7 @@
               </a:defRPr>
             </a:pPr>
             <a:r>
-              <a:t>Inside P10-P90 Cone</a:t>
+              <a:t>Inside P10-P90 Envelope</a:t>
             </a:r>
           </a:p>
         </p:txBody>
@@ -5398,8 +5571,8 @@
         </p:nvSpPr>
         <p:spPr>
           <a:xfrm>
-            <a:off x="5120640" y="3291840"/>
-            <a:ext cx="2011680" cy="2103120"/>
+            <a:off x="5120640" y="3017520"/>
+            <a:ext cx="2011680" cy="1828800"/>
           </a:xfrm>
           <a:prstGeom prst="rect">
             <a:avLst/>
@@ -5443,8 +5616,8 @@
         </p:nvSpPr>
         <p:spPr>
           <a:xfrm>
-            <a:off x="5212080" y="3474720"/>
-            <a:ext cx="1828800" cy="1737360"/>
+            <a:off x="5212080" y="3154680"/>
+            <a:ext cx="1828800" cy="1554480"/>
           </a:xfrm>
           <a:prstGeom prst="rect">
             <a:avLst/>
@@ -5474,7 +5647,7 @@
               <a:spcBef>
                 <a:spcPts val="400"/>
               </a:spcBef>
-              <a:defRPr sz="950" b="1">
+              <a:defRPr sz="900" b="1">
                 <a:solidFill>
                   <a:srgbClr val="F8FAFC"/>
                 </a:solidFill>
@@ -5490,7 +5663,7 @@
               <a:spcBef>
                 <a:spcPts val="400"/>
               </a:spcBef>
-              <a:defRPr sz="950">
+              <a:defRPr sz="900">
                 <a:solidFill>
                   <a:srgbClr val="64748B"/>
                 </a:solidFill>
@@ -5511,8 +5684,8 @@
         </p:nvSpPr>
         <p:spPr>
           <a:xfrm>
-            <a:off x="640080" y="5669280"/>
-            <a:ext cx="6492240" cy="2651760"/>
+            <a:off x="640080" y="5029200"/>
+            <a:ext cx="6492240" cy="3108960"/>
           </a:xfrm>
           <a:prstGeom prst="rect">
             <a:avLst/>
@@ -5556,8 +5729,8 @@
         </p:nvSpPr>
         <p:spPr>
           <a:xfrm>
-            <a:off x="822960" y="5806440"/>
-            <a:ext cx="6126480" cy="2377440"/>
+            <a:off x="822960" y="5166360"/>
+            <a:ext cx="6126480" cy="2834640"/>
           </a:xfrm>
           <a:prstGeom prst="rect">
             <a:avLst/>
@@ -5579,7 +5752,7 @@
               </a:defRPr>
             </a:pPr>
             <a:r>
-              <a:t>[ ZERO-COST PRODUCTION STACK ]</a:t>
+              <a:t>PRODUCTION CLOUD SERVING STACK</a:t>
             </a:r>
           </a:p>
           <a:p>
@@ -5587,15 +5760,15 @@
               <a:spcBef>
                 <a:spcPts val="600"/>
               </a:spcBef>
-              <a:defRPr sz="1100">
+              <a:defRPr sz="1150">
                 <a:solidFill>
                   <a:srgbClr val="F8FAFC"/>
                 </a:solidFill>
-                <a:latin typeface="Consolas"/>
-              </a:defRPr>
-            </a:pPr>
-            <a:r>
-              <a:t>• Frontend Terminal    : React 19 + TypeScript on Vercel Edge</a:t>
+                <a:latin typeface="Calibri"/>
+              </a:defRPr>
+            </a:pPr>
+            <a:r>
+              <a:t>• Frontend Terminal: React 19 + TypeScript + TradingView Lightweight Charts on Vercel CDN</a:t>
             </a:r>
           </a:p>
           <a:p>
@@ -5603,15 +5776,15 @@
               <a:spcBef>
                 <a:spcPts val="600"/>
               </a:spcBef>
-              <a:defRPr sz="1100">
+              <a:defRPr sz="1150">
                 <a:solidFill>
                   <a:srgbClr val="F8FAFC"/>
                 </a:solidFill>
-                <a:latin typeface="Consolas"/>
-              </a:defRPr>
-            </a:pPr>
-            <a:r>
-              <a:t>• Serving REST API     : FastAPI Container on Render</a:t>
+                <a:latin typeface="Calibri"/>
+              </a:defRPr>
+            </a:pPr>
+            <a:r>
+              <a:t>• Serving REST API: FastAPI in Docker container with OpenMP multiprocessing on Render</a:t>
             </a:r>
           </a:p>
           <a:p>
@@ -5619,15 +5792,15 @@
               <a:spcBef>
                 <a:spcPts val="600"/>
               </a:spcBef>
-              <a:defRPr sz="1100">
+              <a:defRPr sz="1150">
                 <a:solidFill>
                   <a:srgbClr val="F8FAFC"/>
                 </a:solidFill>
-                <a:latin typeface="Consolas"/>
-              </a:defRPr>
-            </a:pPr>
-            <a:r>
-              <a:t>• Cloud Database       : PostgreSQL 15 on Supabase</a:t>
+                <a:latin typeface="Calibri"/>
+              </a:defRPr>
+            </a:pPr>
+            <a:r>
+              <a:t>• Cloud Database: PostgreSQL 15 on Supabase (Composite PK idempotent daily upserts)</a:t>
             </a:r>
           </a:p>
           <a:p>
@@ -5635,15 +5808,15 @@
               <a:spcBef>
                 <a:spcPts val="600"/>
               </a:spcBef>
-              <a:defRPr sz="1100">
+              <a:defRPr sz="1150">
                 <a:solidFill>
                   <a:srgbClr val="F8FAFC"/>
                 </a:solidFill>
-                <a:latin typeface="Consolas"/>
-              </a:defRPr>
-            </a:pPr>
-            <a:r>
-              <a:t>• Post-Market Pipeline : Automated Cron (15:00 SLST) on GitHub Actions</a:t>
+                <a:latin typeface="Calibri"/>
+              </a:defRPr>
+            </a:pPr>
+            <a:r>
+              <a:t>• MLOps Automation: GitHub Actions daily cron (15:00 SLST) + 29-test Pytest CI suite</a:t>
             </a:r>
           </a:p>
         </p:txBody>
@@ -5656,7 +5829,7 @@
         </p:nvSpPr>
         <p:spPr>
           <a:xfrm>
-            <a:off x="640080" y="8961120"/>
+            <a:off x="640080" y="8412480"/>
             <a:ext cx="6492240" cy="365760"/>
           </a:xfrm>
           <a:prstGeom prst="rect">
@@ -5665,6 +5838,87 @@
           <a:noFill/>
         </p:spPr>
         <p:txBody>
+          <a:bodyPr wrap="square">
+            <a:spAutoFit/>
+          </a:bodyPr>
+          <a:lstStyle/>
+          <a:p>
+            <a:pPr>
+              <a:defRPr sz="950" b="1">
+                <a:solidFill>
+                  <a:srgbClr val="64748B"/>
+                </a:solidFill>
+                <a:latin typeface="Consolas"/>
+              </a:defRPr>
+            </a:pPr>
+            <a:r>
+              <a:t>TECH STACK:  </a:t>
+            </a:r>
+            <a:r>
+              <a:rPr sz="950" b="1">
+                <a:solidFill>
+                  <a:srgbClr val="38BDF8"/>
+                </a:solidFill>
+                <a:latin typeface="Consolas"/>
+              </a:rPr>
+              <a:t> [FastAPI] </a:t>
+            </a:r>
+            <a:r>
+              <a:rPr sz="950" b="1">
+                <a:solidFill>
+                  <a:srgbClr val="38BDF8"/>
+                </a:solidFill>
+                <a:latin typeface="Consolas"/>
+              </a:rPr>
+              <a:t> [Docker] </a:t>
+            </a:r>
+            <a:r>
+              <a:rPr sz="950" b="1">
+                <a:solidFill>
+                  <a:srgbClr val="38BDF8"/>
+                </a:solidFill>
+                <a:latin typeface="Consolas"/>
+              </a:rPr>
+              <a:t> [PostgreSQL / Supabase] </a:t>
+            </a:r>
+            <a:r>
+              <a:rPr sz="950" b="1">
+                <a:solidFill>
+                  <a:srgbClr val="38BDF8"/>
+                </a:solidFill>
+                <a:latin typeface="Consolas"/>
+              </a:rPr>
+              <a:t> [React 19 + TypeScript] </a:t>
+            </a:r>
+            <a:r>
+              <a:rPr sz="950" b="1">
+                <a:solidFill>
+                  <a:srgbClr val="38BDF8"/>
+                </a:solidFill>
+                <a:latin typeface="Consolas"/>
+              </a:rPr>
+              <a:t> [GitHub Actions] </a:t>
+            </a:r>
+          </a:p>
+        </p:txBody>
+      </p:sp>
+      <p:sp>
+        <p:nvSpPr>
+          <p:cNvPr id="15" name="TextBox 14"/>
+          <p:cNvSpPr txBox="1"/>
+          <p:nvPr/>
+        </p:nvSpPr>
+        <p:spPr>
+          <a:xfrm>
+            <a:off x="640080" y="9006840"/>
+            <a:ext cx="6492240" cy="320040"/>
+          </a:xfrm>
+          <a:prstGeom prst="rect">
+            <a:avLst/>
+          </a:prstGeom>
+          <a:noFill/>
+        </p:spPr>
+        <p:txBody>
           <a:bodyPr wrap="none">
             <a:spAutoFit/>
           </a:bodyPr>
@@ -5679,7 +5933,7 @@
               </a:defRPr>
             </a:pPr>
             <a:r>
-              <a:t>COLOMBO STOCK EXCHANGE (CSE) MLOPS</a:t>
+              <a:t>AI / ML SYSTEM ENGINEERING</a:t>
             </a:r>
             <a:r>
               <a:rPr b="1">

</xml_diff>

<commit_message>
docs: simplify linkedin carousel content for general scannability and audience understanding
</commit_message>
<xml_diff>
--- a/docs/linkedin_presentation_deck.pptx
+++ b/docs/linkedin_presentation_deck.pptx
@@ -3166,7 +3166,7 @@
               </a:defRPr>
             </a:pPr>
             <a:r>
-              <a:t>[ 01 / FINANCIAL ML MATHEMATICS ]</a:t>
+              <a:t>[ 01 / THE CORE PROBLEM ]</a:t>
             </a:r>
           </a:p>
         </p:txBody>
@@ -3194,7 +3194,7 @@
           <a:lstStyle/>
           <a:p>
             <a:pPr>
-              <a:defRPr sz="2700" b="1">
+              <a:defRPr sz="2800" b="1">
                 <a:solidFill>
                   <a:srgbClr val="F8FAFC"/>
                 </a:solidFill>
@@ -3202,7 +3202,7 @@
               </a:defRPr>
             </a:pPr>
             <a:r>
-              <a:t>Solving Time-Series Non-Stationarity</a:t>
+              <a:t>Why Most Stock AI Models Fail</a:t>
             </a:r>
           </a:p>
         </p:txBody>
@@ -3230,7 +3230,7 @@
           <a:lstStyle/>
           <a:p>
             <a:pPr>
-              <a:defRPr sz="1350">
+              <a:defRPr sz="1400">
                 <a:solidFill>
                   <a:srgbClr val="94A3B8"/>
                 </a:solidFill>
@@ -3238,7 +3238,7 @@
               </a:defRPr>
             </a:pPr>
             <a:r>
-              <a:t>How I engineered a stationary quantitative learning target, eliminating the identity lag trap that plagues naive financial ML.</a:t>
+              <a:t>Most beginners make one critical mistake: trying to predict exact stock prices instead of trend and momentum.</a:t>
             </a:r>
           </a:p>
         </p:txBody>
@@ -3319,7 +3319,7 @@
               </a:defRPr>
             </a:pPr>
             <a:r>
-              <a:t>THE PERSISTENCE ANTI-PATTERN (I(1) UNIT ROOT)</a:t>
+              <a:t>THE TRAP: PREDICTING RAW PRICES</a:t>
             </a:r>
           </a:p>
           <a:p>
@@ -3335,7 +3335,7 @@
               </a:defRPr>
             </a:pPr>
             <a:r>
-              <a:t>Predicting Raw Nominals: P_hat(t+30) ~= P_t</a:t>
+              <a:t>The AI Just Copies Yesterday's Price</a:t>
             </a:r>
           </a:p>
           <a:p>
@@ -3343,7 +3343,7 @@
               <a:spcBef>
                 <a:spcPts val="800"/>
               </a:spcBef>
-              <a:defRPr sz="1250">
+              <a:defRPr sz="1300">
                 <a:solidFill>
                   <a:srgbClr val="94A3B8"/>
                 </a:solidFill>
@@ -3351,7 +3351,7 @@
               </a:defRPr>
             </a:pPr>
             <a:r>
-              <a:t>MSE optimization on raw price levels creates identity models: the booster simply outputs yesterday's price with synthetic 98% R^2 and zero predictive alpha.</a:t>
+              <a:t>If a stock was Rs. 100 yesterday, the AI predicts Rs. 100 tomorrow. It displays fake 99% accuracy on paper, but gives zero real trading value.</a:t>
             </a:r>
           </a:p>
         </p:txBody>
@@ -3432,7 +3432,7 @@
               </a:defRPr>
             </a:pPr>
             <a:r>
-              <a:t>MY MATHEMATICAL FORMULATION</a:t>
+              <a:t>HOW I SOLVED IT</a:t>
             </a:r>
           </a:p>
           <a:p>
@@ -3448,7 +3448,7 @@
               </a:defRPr>
             </a:pPr>
             <a:r>
-              <a:t>y_t = ln( P_{t+30} / P_t )   [Forward Log Return]</a:t>
+              <a:t>Predicting 30-Day Percentage Return &amp; Direction</a:t>
             </a:r>
           </a:p>
           <a:p>
@@ -3456,7 +3456,7 @@
               <a:spcBef>
                 <a:spcPts val="800"/>
               </a:spcBef>
-              <a:defRPr sz="1250">
+              <a:defRPr sz="1300">
                 <a:solidFill>
                   <a:srgbClr val="94A3B8"/>
                 </a:solidFill>
@@ -3464,7 +3464,7 @@
               </a:defRPr>
             </a:pPr>
             <a:r>
-              <a:t>Induces strict covariance stationarity and scale invariance across 26 CSE blue-chip equities, forcing gradient-boosted trees to isolate genuine momentum and mean-reversion.</a:t>
+              <a:t>I forced the models to learn whether a stock will grow or fall over the next month, discovering genuine market cycles across 26 top companies.</a:t>
             </a:r>
           </a:p>
         </p:txBody>
@@ -3500,7 +3500,25 @@
               </a:defRPr>
             </a:pPr>
             <a:r>
-              <a:t>TECH STACK:  </a:t>
+              <a:t>SKILLS &amp; TECH:  </a:t>
+            </a:r>
+            <a:r>
+              <a:rPr sz="950" b="1">
+                <a:solidFill>
+                  <a:srgbClr val="38BDF8"/>
+                </a:solidFill>
+                <a:latin typeface="Consolas"/>
+              </a:rPr>
+              <a:t> [Python] </a:t>
+            </a:r>
+            <a:r>
+              <a:rPr sz="950" b="1">
+                <a:solidFill>
+                  <a:srgbClr val="38BDF8"/>
+                </a:solidFill>
+                <a:latin typeface="Consolas"/>
+              </a:rPr>
+              <a:t> [Pandas] </a:t>
             </a:r>
             <a:r>
               <a:rPr sz="950" b="1">
@@ -3518,25 +3536,7 @@
                 </a:solidFill>
                 <a:latin typeface="Consolas"/>
               </a:rPr>
-              <a:t> [Pandas] </a:t>
-            </a:r>
-            <a:r>
-              <a:rPr sz="950" b="1">
-                <a:solidFill>
-                  <a:srgbClr val="38BDF8"/>
-                </a:solidFill>
-                <a:latin typeface="Consolas"/>
-              </a:rPr>
-              <a:t> [Statistical Stationarity] </a:t>
-            </a:r>
-            <a:r>
-              <a:rPr sz="950" b="1">
-                <a:solidFill>
-                  <a:srgbClr val="38BDF8"/>
-                </a:solidFill>
-                <a:latin typeface="Consolas"/>
-              </a:rPr>
-              <a:t> [Unit Root I(1)] </a:t>
+              <a:t> [Statistical Modeling] </a:t>
             </a:r>
           </a:p>
         </p:txBody>
@@ -3677,7 +3677,7 @@
               </a:defRPr>
             </a:pPr>
             <a:r>
-              <a:t>[ 02 / DATA ENGINEERING &amp; LAKEHOUSE ]</a:t>
+              <a:t>[ 02 / DATA PIPELINE ]</a:t>
             </a:r>
           </a:p>
         </p:txBody>
@@ -3705,7 +3705,7 @@
           <a:lstStyle/>
           <a:p>
             <a:pPr>
-              <a:defRPr sz="2700" b="1">
+              <a:defRPr sz="2800" b="1">
                 <a:solidFill>
                   <a:srgbClr val="F8FAFC"/>
                 </a:solidFill>
@@ -3713,7 +3713,7 @@
               </a:defRPr>
             </a:pPr>
             <a:r>
-              <a:t>High-Throughput Vectorized Feature Store</a:t>
+              <a:t>Automated &amp; Fast Data Pipeline</a:t>
             </a:r>
           </a:p>
         </p:txBody>
@@ -3741,7 +3741,7 @@
           <a:lstStyle/>
           <a:p>
             <a:pPr>
-              <a:defRPr sz="1350">
+              <a:defRPr sz="1400">
                 <a:solidFill>
                   <a:srgbClr val="94A3B8"/>
                 </a:solidFill>
@@ -3749,7 +3749,7 @@
               </a:defRPr>
             </a:pPr>
             <a:r>
-              <a:t>Engineered a zero-copy Apache Parquet lakehouse coupled with 22 leak-free microstructure estimators.</a:t>
+              <a:t>Good AI requires clean data. I built an end-to-end pipeline that tracks the Colombo Stock Exchange without manual work.</a:t>
             </a:r>
           </a:p>
         </p:txBody>
@@ -3830,7 +3830,7 @@
               </a:defRPr>
             </a:pPr>
             <a:r>
-              <a:t>COLUMNAR ZERO-COPY SERVING LAYER</a:t>
+              <a:t>DAILY MARKET AUTOMATION</a:t>
             </a:r>
           </a:p>
           <a:p>
@@ -3846,7 +3846,7 @@
               </a:defRPr>
             </a:pPr>
             <a:r>
-              <a:t>Apache Parquet + PyArrow + DuckDB</a:t>
+              <a:t>Syncs Automatically at 3:00 PM Every Weekday</a:t>
             </a:r>
           </a:p>
           <a:p>
@@ -3854,7 +3854,7 @@
               <a:spcBef>
                 <a:spcPts val="800"/>
               </a:spcBef>
-              <a:defRPr sz="1250">
+              <a:defRPr sz="1300">
                 <a:solidFill>
                   <a:srgbClr val="94A3B8"/>
                 </a:solidFill>
@@ -3862,7 +3862,7 @@
               </a:defRPr>
             </a:pPr>
             <a:r>
-              <a:t>Sub-millisecond columnar partition scans for all 26 equities (data/processed/*.parquet), bypassing slow SQL connection latency during real-time inference.</a:t>
+              <a:t>When the Colombo market closes, automated cloud workers fetch closing prices for 26 key companies plus the ASPI index, validate data, and update databases.</a:t>
             </a:r>
           </a:p>
         </p:txBody>
@@ -3876,7 +3876,7 @@
         <p:spPr>
           <a:xfrm>
             <a:off x="640080" y="5577840"/>
-            <a:ext cx="6492240" cy="2560320"/>
+            <a:ext cx="6492240" cy="2468880"/>
           </a:xfrm>
           <a:prstGeom prst="rect">
             <a:avLst/>
@@ -3921,7 +3921,7 @@
         <p:spPr>
           <a:xfrm>
             <a:off x="822960" y="5715000"/>
-            <a:ext cx="6126480" cy="2286000"/>
+            <a:ext cx="6126480" cy="2194560"/>
           </a:xfrm>
           <a:prstGeom prst="rect">
             <a:avLst/>
@@ -3943,7 +3943,7 @@
               </a:defRPr>
             </a:pPr>
             <a:r>
-              <a:t>VECTORIZED MARKET DYNAMICS PIPELINE</a:t>
+              <a:t>FAST FEATURE ENGINE</a:t>
             </a:r>
           </a:p>
           <a:p>
@@ -3951,47 +3951,31 @@
               <a:spcBef>
                 <a:spcPts val="600"/>
               </a:spcBef>
-              <a:defRPr sz="1200">
+              <a:defRPr sz="1700" b="1">
                 <a:solidFill>
                   <a:srgbClr val="F8FAFC"/>
                 </a:solidFill>
-                <a:latin typeface="Calibri"/>
-              </a:defRPr>
-            </a:pPr>
-            <a:r>
-              <a:t>• Parkinson Volatility: High-Low dispersion (5x more efficient than close-to-close)</a:t>
+                <a:latin typeface="Trebuchet MS"/>
+              </a:defRPr>
+            </a:pPr>
+            <a:r>
+              <a:t>22 Market Indicators Calculated in Milliseconds</a:t>
             </a:r>
           </a:p>
           <a:p>
             <a:pPr>
               <a:spcBef>
-                <a:spcPts val="600"/>
+                <a:spcPts val="800"/>
               </a:spcBef>
-              <a:defRPr sz="1200">
-                <a:solidFill>
-                  <a:srgbClr val="F8FAFC"/>
+              <a:defRPr sz="1300">
+                <a:solidFill>
+                  <a:srgbClr val="94A3B8"/>
                 </a:solidFill>
                 <a:latin typeface="Calibri"/>
               </a:defRPr>
             </a:pPr>
             <a:r>
-              <a:t>• Momentum &amp; Trend: Wilder RSI(14), MACD Histogram, 20/50 SMA Golden Cross</a:t>
-            </a:r>
-          </a:p>
-          <a:p>
-            <a:pPr>
-              <a:spcBef>
-                <a:spcPts val="600"/>
-              </a:spcBef>
-              <a:defRPr sz="1200">
-                <a:solidFill>
-                  <a:srgbClr val="F8FAFC"/>
-                </a:solidFill>
-                <a:latin typeface="Calibri"/>
-              </a:defRPr>
-            </a:pPr>
-            <a:r>
-              <a:t>• Systematic Beta: ASPI 30-Day relative alpha spread &amp; rolling Pearson correlation</a:t>
+              <a:t>Automatically computes price volatility, RSI momentum, moving averages, and market correlations using ultra-fast columnar Parquet storage.</a:t>
             </a:r>
           </a:p>
         </p:txBody>
@@ -4027,7 +4011,16 @@
               </a:defRPr>
             </a:pPr>
             <a:r>
-              <a:t>TECH STACK:  </a:t>
+              <a:t>SKILLS &amp; TECH:  </a:t>
+            </a:r>
+            <a:r>
+              <a:rPr sz="950" b="1">
+                <a:solidFill>
+                  <a:srgbClr val="38BDF8"/>
+                </a:solidFill>
+                <a:latin typeface="Consolas"/>
+              </a:rPr>
+              <a:t> [Automated ETL] </a:t>
             </a:r>
             <a:r>
               <a:rPr sz="950" b="1">
@@ -4045,7 +4038,7 @@
                 </a:solidFill>
                 <a:latin typeface="Consolas"/>
               </a:rPr>
-              <a:t> [PyArrow] </a:t>
+              <a:t> [REST APIs] </a:t>
             </a:r>
             <a:r>
               <a:rPr sz="950" b="1">
@@ -4054,25 +4047,7 @@
                 </a:solidFill>
                 <a:latin typeface="Consolas"/>
               </a:rPr>
-              <a:t> [DuckDB] </a:t>
-            </a:r>
-            <a:r>
-              <a:rPr sz="950" b="1">
-                <a:solidFill>
-                  <a:srgbClr val="38BDF8"/>
-                </a:solidFill>
-                <a:latin typeface="Consolas"/>
-              </a:rPr>
-              <a:t> [Vectorized Math] </a:t>
-            </a:r>
-            <a:r>
-              <a:rPr sz="950" b="1">
-                <a:solidFill>
-                  <a:srgbClr val="38BDF8"/>
-                </a:solidFill>
-                <a:latin typeface="Consolas"/>
-              </a:rPr>
-              <a:t> [ETL Pipelines] </a:t>
+              <a:t> [Data Pipelines] </a:t>
             </a:r>
           </a:p>
         </p:txBody>
@@ -4213,7 +4188,7 @@
               </a:defRPr>
             </a:pPr>
             <a:r>
-              <a:t>[ 03 / MLOPS &amp; ALGORITHMIC RIGOR ]</a:t>
+              <a:t>[ 03 / MACHINE LEARNING ]</a:t>
             </a:r>
           </a:p>
         </p:txBody>
@@ -4241,7 +4216,7 @@
           <a:lstStyle/>
           <a:p>
             <a:pPr>
-              <a:defRPr sz="2700" b="1">
+              <a:defRPr sz="2800" b="1">
                 <a:solidFill>
                   <a:srgbClr val="F8FAFC"/>
                 </a:solidFill>
@@ -4249,7 +4224,7 @@
               </a:defRPr>
             </a:pPr>
             <a:r>
-              <a:t>Purged Cross-Validation &amp; Quantile Loss</a:t>
+              <a:t>Predicting Risk, Not Just One Number</a:t>
             </a:r>
           </a:p>
         </p:txBody>
@@ -4277,7 +4252,7 @@
           <a:lstStyle/>
           <a:p>
             <a:pPr>
-              <a:defRPr sz="1350">
+              <a:defRPr sz="1400">
                 <a:solidFill>
                   <a:srgbClr val="94A3B8"/>
                 </a:solidFill>
@@ -4285,7 +4260,7 @@
               </a:defRPr>
             </a:pPr>
             <a:r>
-              <a:t>Preventing overlapping target contamination with purged embargo gaps while optimizing asymmetric Pinball Loss.</a:t>
+              <a:t>Nobody can predict the future with 100% certainty. Single price guesses are dangerous, so I built a 3-way risk envelope.</a:t>
             </a:r>
           </a:p>
         </p:txBody>
@@ -4299,7 +4274,7 @@
         <p:spPr>
           <a:xfrm>
             <a:off x="640080" y="3017520"/>
-            <a:ext cx="6492240" cy="2286000"/>
+            <a:ext cx="6492240" cy="1508760"/>
           </a:xfrm>
           <a:prstGeom prst="rect">
             <a:avLst/>
@@ -4309,7 +4284,7 @@
           </a:solidFill>
           <a:ln w="19050">
             <a:solidFill>
-              <a:srgbClr val="38BDF8"/>
+              <a:srgbClr val="F87171"/>
             </a:solidFill>
           </a:ln>
         </p:spPr>
@@ -4343,8 +4318,8 @@
         </p:nvSpPr>
         <p:spPr>
           <a:xfrm>
-            <a:off x="822960" y="3154680"/>
-            <a:ext cx="6126480" cy="2011680"/>
+            <a:off x="822960" y="3127248"/>
+            <a:ext cx="6126480" cy="1280160"/>
           </a:xfrm>
           <a:prstGeom prst="rect">
             <a:avLst/>
@@ -4358,31 +4333,47 @@
           <a:lstStyle/>
           <a:p>
             <a:pPr>
-              <a:defRPr sz="1100" b="1">
-                <a:solidFill>
-                  <a:srgbClr val="38BDF8"/>
+              <a:defRPr sz="1000" b="1">
+                <a:solidFill>
+                  <a:srgbClr val="F87171"/>
                 </a:solidFill>
                 <a:latin typeface="Consolas"/>
               </a:defRPr>
             </a:pPr>
             <a:r>
-              <a:t>CUSTOM PURGED &amp; EMBARGOED WALK-FORWARD CV</a:t>
+              <a:t>DOWNSIDE FLOOR (P10)</a:t>
             </a:r>
           </a:p>
           <a:p>
             <a:pPr>
               <a:spcBef>
-                <a:spcPts val="800"/>
+                <a:spcPts val="300"/>
               </a:spcBef>
-              <a:defRPr sz="1250">
+              <a:defRPr sz="1500" b="1">
                 <a:solidFill>
                   <a:srgbClr val="F8FAFC"/>
                 </a:solidFill>
+                <a:latin typeface="Trebuchet MS"/>
+              </a:defRPr>
+            </a:pPr>
+            <a:r>
+              <a:t>Worst-Case Scenario</a:t>
+            </a:r>
+          </a:p>
+          <a:p>
+            <a:pPr>
+              <a:spcBef>
+                <a:spcPts val="400"/>
+              </a:spcBef>
+              <a:defRPr sz="1200">
+                <a:solidFill>
+                  <a:srgbClr val="94A3B8"/>
+                </a:solidFill>
                 <a:latin typeface="Calibri"/>
               </a:defRPr>
             </a:pPr>
             <a:r>
-              <a:t>Standard K-Fold leaks future 30-day returns. I built an expanding 5-fold CV engine with a 30-day purge gap (drops overlapping train labels) and a 30-day embargo buffer (kills serial correlation).</a:t>
+              <a:t>Shows where the stock could fall during bad market conditions so investors protect capital.</a:t>
             </a:r>
           </a:p>
         </p:txBody>
@@ -4395,8 +4386,8 @@
         </p:nvSpPr>
         <p:spPr>
           <a:xfrm>
-            <a:off x="640080" y="5486400"/>
-            <a:ext cx="6492240" cy="2651760"/>
+            <a:off x="640080" y="4709160"/>
+            <a:ext cx="6492240" cy="1508760"/>
           </a:xfrm>
           <a:prstGeom prst="rect">
             <a:avLst/>
@@ -4406,7 +4397,7 @@
           </a:solidFill>
           <a:ln w="19050">
             <a:solidFill>
-              <a:srgbClr val="34D399"/>
+              <a:srgbClr val="38BDF8"/>
             </a:solidFill>
           </a:ln>
         </p:spPr>
@@ -4440,8 +4431,8 @@
         </p:nvSpPr>
         <p:spPr>
           <a:xfrm>
-            <a:off x="822960" y="5623560"/>
-            <a:ext cx="6126480" cy="2377440"/>
+            <a:off x="822960" y="4818888"/>
+            <a:ext cx="6126480" cy="1280160"/>
           </a:xfrm>
           <a:prstGeom prst="rect">
             <a:avLst/>
@@ -4455,77 +4446,106 @@
           <a:lstStyle/>
           <a:p>
             <a:pPr>
-              <a:defRPr sz="1100" b="1">
-                <a:solidFill>
-                  <a:srgbClr val="34D399"/>
+              <a:defRPr sz="1000" b="1">
+                <a:solidFill>
+                  <a:srgbClr val="38BDF8"/>
                 </a:solidFill>
                 <a:latin typeface="Consolas"/>
               </a:defRPr>
             </a:pPr>
             <a:r>
-              <a:t>MULTI-QUANTILE LIGHTGBM (PINBALL LOSS)</a:t>
+              <a:t>EXPECTED PATH (P50)</a:t>
             </a:r>
           </a:p>
           <a:p>
             <a:pPr>
               <a:spcBef>
-                <a:spcPts val="600"/>
+                <a:spcPts val="300"/>
+              </a:spcBef>
+              <a:defRPr sz="1500" b="1">
+                <a:solidFill>
+                  <a:srgbClr val="F8FAFC"/>
+                </a:solidFill>
+                <a:latin typeface="Trebuchet MS"/>
+              </a:defRPr>
+            </a:pPr>
+            <a:r>
+              <a:t>Most Realistic Outcome</a:t>
+            </a:r>
+          </a:p>
+          <a:p>
+            <a:pPr>
+              <a:spcBef>
+                <a:spcPts val="400"/>
               </a:spcBef>
               <a:defRPr sz="1200">
                 <a:solidFill>
-                  <a:srgbClr val="F8FAFC"/>
+                  <a:srgbClr val="94A3B8"/>
                 </a:solidFill>
                 <a:latin typeface="Calibri"/>
               </a:defRPr>
             </a:pPr>
             <a:r>
-              <a:t>• P10 Floor (q=0.10): Downside Value-at-Risk floor (9x penalty on drawdown misses)</a:t>
-            </a:r>
-          </a:p>
-          <a:p>
-            <a:pPr>
-              <a:spcBef>
-                <a:spcPts val="600"/>
-              </a:spcBef>
-              <a:defRPr sz="1200">
-                <a:solidFill>
-                  <a:srgbClr val="F8FAFC"/>
-                </a:solidFill>
-                <a:latin typeface="Calibri"/>
-              </a:defRPr>
-            </a:pPr>
-            <a:r>
-              <a:t>• P50 Median (q=0.50): Robust median expected trajectory (MAE optimization)</a:t>
-            </a:r>
-          </a:p>
-          <a:p>
-            <a:pPr>
-              <a:spcBef>
-                <a:spcPts val="600"/>
-              </a:spcBef>
-              <a:defRPr sz="1200">
-                <a:solidFill>
-                  <a:srgbClr val="F8FAFC"/>
-                </a:solidFill>
-                <a:latin typeface="Calibri"/>
-              </a:defRPr>
-            </a:pPr>
-            <a:r>
-              <a:t>• P90 Ceiling (q=0.90): Bullish expansion envelope (90th percentile resistance)</a:t>
-            </a:r>
-          </a:p>
-        </p:txBody>
-      </p:sp>
-      <p:sp>
-        <p:nvSpPr>
-          <p:cNvPr id="10" name="TextBox 9"/>
+              <a:t>The realistic expected 30-day trajectory, filtering out daily noise and false spikes.</a:t>
+            </a:r>
+          </a:p>
+        </p:txBody>
+      </p:sp>
+      <p:sp>
+        <p:nvSpPr>
+          <p:cNvPr id="10" name="Rectangle 9"/>
+          <p:cNvSpPr/>
+          <p:nvPr/>
+        </p:nvSpPr>
+        <p:spPr>
+          <a:xfrm>
+            <a:off x="640080" y="6400800"/>
+            <a:ext cx="6492240" cy="1508760"/>
+          </a:xfrm>
+          <a:prstGeom prst="rect">
+            <a:avLst/>
+          </a:prstGeom>
+          <a:solidFill>
+            <a:srgbClr val="111722"/>
+          </a:solidFill>
+          <a:ln w="19050">
+            <a:solidFill>
+              <a:srgbClr val="34D399"/>
+            </a:solidFill>
+          </a:ln>
+        </p:spPr>
+        <p:style>
+          <a:lnRef idx="1">
+            <a:schemeClr val="accent1"/>
+          </a:lnRef>
+          <a:fillRef idx="3">
+            <a:schemeClr val="accent1"/>
+          </a:fillRef>
+          <a:effectRef idx="2">
+            <a:schemeClr val="accent1"/>
+          </a:effectRef>
+          <a:fontRef idx="minor">
+            <a:schemeClr val="lt1"/>
+          </a:fontRef>
+        </p:style>
+        <p:txBody>
+          <a:bodyPr rtlCol="0" anchor="ctr"/>
+          <a:lstStyle/>
+          <a:p>
+            <a:pPr algn="ctr"/>
+          </a:p>
+        </p:txBody>
+      </p:sp>
+      <p:sp>
+        <p:nvSpPr>
+          <p:cNvPr id="11" name="TextBox 10"/>
           <p:cNvSpPr txBox="1"/>
           <p:nvPr/>
         </p:nvSpPr>
         <p:spPr>
           <a:xfrm>
-            <a:off x="640080" y="8412480"/>
-            <a:ext cx="6492240" cy="365760"/>
+            <a:off x="822960" y="6510528"/>
+            <a:ext cx="6126480" cy="1280160"/>
           </a:xfrm>
           <a:prstGeom prst="rect">
             <a:avLst/>
@@ -4539,6 +4559,74 @@
           <a:lstStyle/>
           <a:p>
             <a:pPr>
+              <a:defRPr sz="1000" b="1">
+                <a:solidFill>
+                  <a:srgbClr val="34D399"/>
+                </a:solidFill>
+                <a:latin typeface="Consolas"/>
+              </a:defRPr>
+            </a:pPr>
+            <a:r>
+              <a:t>UPSIDE CEILING (P90)</a:t>
+            </a:r>
+          </a:p>
+          <a:p>
+            <a:pPr>
+              <a:spcBef>
+                <a:spcPts val="300"/>
+              </a:spcBef>
+              <a:defRPr sz="1500" b="1">
+                <a:solidFill>
+                  <a:srgbClr val="F8FAFC"/>
+                </a:solidFill>
+                <a:latin typeface="Trebuchet MS"/>
+              </a:defRPr>
+            </a:pPr>
+            <a:r>
+              <a:t>Best-Case Potential</a:t>
+            </a:r>
+          </a:p>
+          <a:p>
+            <a:pPr>
+              <a:spcBef>
+                <a:spcPts val="400"/>
+              </a:spcBef>
+              <a:defRPr sz="1200">
+                <a:solidFill>
+                  <a:srgbClr val="94A3B8"/>
+                </a:solidFill>
+                <a:latin typeface="Calibri"/>
+              </a:defRPr>
+            </a:pPr>
+            <a:r>
+              <a:t>Shows the upper resistance level if strong buying momentum continues.</a:t>
+            </a:r>
+          </a:p>
+        </p:txBody>
+      </p:sp>
+      <p:sp>
+        <p:nvSpPr>
+          <p:cNvPr id="12" name="TextBox 11"/>
+          <p:cNvSpPr txBox="1"/>
+          <p:nvPr/>
+        </p:nvSpPr>
+        <p:spPr>
+          <a:xfrm>
+            <a:off x="640080" y="8412480"/>
+            <a:ext cx="6492240" cy="365760"/>
+          </a:xfrm>
+          <a:prstGeom prst="rect">
+            <a:avLst/>
+          </a:prstGeom>
+          <a:noFill/>
+        </p:spPr>
+        <p:txBody>
+          <a:bodyPr wrap="square">
+            <a:spAutoFit/>
+          </a:bodyPr>
+          <a:lstStyle/>
+          <a:p>
+            <a:pPr>
               <a:defRPr sz="950" b="1">
                 <a:solidFill>
                   <a:srgbClr val="64748B"/>
@@ -4547,7 +4635,7 @@
               </a:defRPr>
             </a:pPr>
             <a:r>
-              <a:t>TECH STACK:  </a:t>
+              <a:t>SKILLS &amp; TECH:  </a:t>
             </a:r>
             <a:r>
               <a:rPr sz="950" b="1">
@@ -4565,7 +4653,7 @@
                 </a:solidFill>
                 <a:latin typeface="Consolas"/>
               </a:rPr>
-              <a:t> [Quantile Regression] </a:t>
+              <a:t> [Quantile AI] </a:t>
             </a:r>
             <a:r>
               <a:rPr sz="950" b="1">
@@ -4574,16 +4662,7 @@
                 </a:solidFill>
                 <a:latin typeface="Consolas"/>
               </a:rPr>
-              <a:t> [Pinball Loss] </a:t>
-            </a:r>
-            <a:r>
-              <a:rPr sz="950" b="1">
-                <a:solidFill>
-                  <a:srgbClr val="38BDF8"/>
-                </a:solidFill>
-                <a:latin typeface="Consolas"/>
-              </a:rPr>
-              <a:t> [Purged &amp; Embargoed CV] </a:t>
+              <a:t> [Risk Modeling] </a:t>
             </a:r>
             <a:r>
               <a:rPr sz="950" b="1">
@@ -4599,7 +4678,7 @@
       </p:sp>
       <p:sp>
         <p:nvSpPr>
-          <p:cNvPr id="11" name="TextBox 10"/>
+          <p:cNvPr id="13" name="TextBox 12"/>
           <p:cNvSpPr txBox="1"/>
           <p:nvPr/>
         </p:nvSpPr>
@@ -4733,7 +4812,7 @@
               </a:defRPr>
             </a:pPr>
             <a:r>
-              <a:t>[ 04 / EXPLAINABLE AI &amp; INTERPRETABILITY ]</a:t>
+              <a:t>[ 04 / EXPLAINABLE AI ]</a:t>
             </a:r>
           </a:p>
         </p:txBody>
@@ -4761,7 +4840,7 @@
           <a:lstStyle/>
           <a:p>
             <a:pPr>
-              <a:defRPr sz="2700" b="1">
+              <a:defRPr sz="2800" b="1">
                 <a:solidFill>
                   <a:srgbClr val="F8FAFC"/>
                 </a:solidFill>
@@ -4769,7 +4848,7 @@
               </a:defRPr>
             </a:pPr>
             <a:r>
-              <a:t>Dual-Layer Transparent XAI Architecture</a:t>
+              <a:t>Why Did the AI Make This Call?</a:t>
             </a:r>
           </a:p>
         </p:txBody>
@@ -4797,7 +4876,7 @@
           <a:lstStyle/>
           <a:p>
             <a:pPr>
-              <a:defRPr sz="1350">
+              <a:defRPr sz="1400">
                 <a:solidFill>
                   <a:srgbClr val="94A3B8"/>
                 </a:solidFill>
@@ -4805,7 +4884,7 @@
               </a:defRPr>
             </a:pPr>
             <a:r>
-              <a:t>Bridging mathematically verified Shapley attribution with domain-driven heuristic validation rules.</a:t>
+              <a:t>Most AI models are mysterious 'black boxes'. You cannot trust real money to a black box, so I built full transparency into every prediction.</a:t>
             </a:r>
           </a:p>
         </p:txBody>
@@ -4886,7 +4965,7 @@
               </a:defRPr>
             </a:pPr>
             <a:r>
-              <a:t>LAYER 1: EXACT TREESHAP ATTRIBUTION</a:t>
+              <a:t>FEATURE IMPACT BREAKDOWN (SHAP)</a:t>
             </a:r>
           </a:p>
           <a:p>
@@ -4894,7 +4973,7 @@
               <a:spcBef>
                 <a:spcPts val="600"/>
               </a:spcBef>
-              <a:defRPr sz="1600" b="1">
+              <a:defRPr sz="1700" b="1">
                 <a:solidFill>
                   <a:srgbClr val="F8FAFC"/>
                 </a:solidFill>
@@ -4902,7 +4981,7 @@
               </a:defRPr>
             </a:pPr>
             <a:r>
-              <a:t>y_hat = phi_0 + sum( phi_i )   [Exact Additive Decomp]</a:t>
+              <a:t>Every Prediction Explains Its Reasons</a:t>
             </a:r>
           </a:p>
           <a:p>
@@ -4910,7 +4989,7 @@
               <a:spcBef>
                 <a:spcPts val="800"/>
               </a:spcBef>
-              <a:defRPr sz="1250">
+              <a:defRPr sz="1300">
                 <a:solidFill>
                   <a:srgbClr val="94A3B8"/>
                 </a:solidFill>
@@ -4918,7 +4997,7 @@
               </a:defRPr>
             </a:pPr>
             <a:r>
-              <a:t>Calculates exact game-theoretic Shapley values directly across tree ensemble paths, decomposing predicted returns into basis-point impacts with 100% additivity verification in pytest.</a:t>
+              <a:t>Users see exact factors driving the score: e.g. +2.4% strong momentum, -1.2% high market volatility, and +0.8% sector trend.</a:t>
             </a:r>
           </a:p>
         </p:txBody>
@@ -4932,7 +5011,7 @@
         <p:spPr>
           <a:xfrm>
             <a:off x="640080" y="5577840"/>
-            <a:ext cx="6492240" cy="2560320"/>
+            <a:ext cx="6492240" cy="2468880"/>
           </a:xfrm>
           <a:prstGeom prst="rect">
             <a:avLst/>
@@ -4977,7 +5056,7 @@
         <p:spPr>
           <a:xfrm>
             <a:off x="822960" y="5715000"/>
-            <a:ext cx="6126480" cy="2286000"/>
+            <a:ext cx="6126480" cy="2194560"/>
           </a:xfrm>
           <a:prstGeom prst="rect">
             <a:avLst/>
@@ -4999,7 +5078,7 @@
               </a:defRPr>
             </a:pPr>
             <a:r>
-              <a:t>LAYER 2: DOMAIN HEURISTIC VALIDATION ENGINE</a:t>
+              <a:t>HUMAN-READABLE HEALTH BADGES</a:t>
             </a:r>
           </a:p>
           <a:p>
@@ -5007,47 +5086,31 @@
               <a:spcBef>
                 <a:spcPts val="600"/>
               </a:spcBef>
-              <a:defRPr sz="1200">
+              <a:defRPr sz="1700" b="1">
                 <a:solidFill>
                   <a:srgbClr val="F8FAFC"/>
                 </a:solidFill>
-                <a:latin typeface="Calibri"/>
-              </a:defRPr>
-            </a:pPr>
-            <a:r>
-              <a:t>• SUPPORTING: Setup confirms forecast (e.g. RSI momentum &lt;70 without exhaustion)</a:t>
+                <a:latin typeface="Trebuchet MS"/>
+              </a:defRPr>
+            </a:pPr>
+            <a:r>
+              <a:t>Instant Decision Checklist</a:t>
             </a:r>
           </a:p>
           <a:p>
             <a:pPr>
               <a:spcBef>
-                <a:spcPts val="600"/>
+                <a:spcPts val="800"/>
               </a:spcBef>
-              <a:defRPr sz="1200">
-                <a:solidFill>
-                  <a:srgbClr val="F8FAFC"/>
+              <a:defRPr sz="1300">
+                <a:solidFill>
+                  <a:srgbClr val="94A3B8"/>
                 </a:solidFill>
                 <a:latin typeface="Calibri"/>
               </a:defRPr>
             </a:pPr>
             <a:r>
-              <a:t>• REJECTING / RISK: Warns of counter-trend risk (e.g. elevated Parkinson volatility)</a:t>
-            </a:r>
-          </a:p>
-          <a:p>
-            <a:pPr>
-              <a:spcBef>
-                <a:spcPts val="600"/>
-              </a:spcBef>
-              <a:defRPr sz="1200">
-                <a:solidFill>
-                  <a:srgbClr val="F8FAFC"/>
-                </a:solidFill>
-                <a:latin typeface="Calibri"/>
-              </a:defRPr>
-            </a:pPr>
-            <a:r>
-              <a:t>• NEUTRAL: Stable baseline alignment (e.g. volume consolidation)</a:t>
+              <a:t>Translates complex numbers into clear signals: SUPPORTING (healthy trend), RISK WARNING (overheated price), or NEUTRAL (market consolidation).</a:t>
             </a:r>
           </a:p>
         </p:txBody>
@@ -5083,7 +5146,7 @@
               </a:defRPr>
             </a:pPr>
             <a:r>
-              <a:t>TECH STACK:  </a:t>
+              <a:t>SKILLS &amp; TECH:  </a:t>
             </a:r>
             <a:r>
               <a:rPr sz="950" b="1">
@@ -5092,7 +5155,7 @@
                 </a:solidFill>
                 <a:latin typeface="Consolas"/>
               </a:rPr>
-              <a:t> [TreeSHAP] </a:t>
+              <a:t> [SHAP Explainability] </a:t>
             </a:r>
             <a:r>
               <a:rPr sz="950" b="1">
@@ -5101,7 +5164,7 @@
                 </a:solidFill>
                 <a:latin typeface="Consolas"/>
               </a:rPr>
-              <a:t> [Local Feature Attribution] </a:t>
+              <a:t> [Decision Intelligence] </a:t>
             </a:r>
             <a:r>
               <a:rPr sz="950" b="1">
@@ -5110,16 +5173,7 @@
                 </a:solidFill>
                 <a:latin typeface="Consolas"/>
               </a:rPr>
-              <a:t> [Rule Engines] </a:t>
-            </a:r>
-            <a:r>
-              <a:rPr sz="950" b="1">
-                <a:solidFill>
-                  <a:srgbClr val="38BDF8"/>
-                </a:solidFill>
-                <a:latin typeface="Consolas"/>
-              </a:rPr>
-              <a:t> [XAI Pytest Additivity] </a:t>
+              <a:t> [Transparent AI] </a:t>
             </a:r>
           </a:p>
         </p:txBody>
@@ -5260,7 +5314,7 @@
               </a:defRPr>
             </a:pPr>
             <a:r>
-              <a:t>[ 05 / FULL-STACK CLOUD ARCHITECTURE ]</a:t>
+              <a:t>[ 05 / FULL-STACK DEPLOYMENT ]</a:t>
             </a:r>
           </a:p>
         </p:txBody>
@@ -5288,7 +5342,7 @@
           <a:lstStyle/>
           <a:p>
             <a:pPr>
-              <a:defRPr sz="2700" b="1">
+              <a:defRPr sz="2800" b="1">
                 <a:solidFill>
                   <a:srgbClr val="F8FAFC"/>
                 </a:solidFill>
@@ -5296,7 +5350,7 @@
               </a:defRPr>
             </a:pPr>
             <a:r>
-              <a:t>Production Serving &amp; Empirical Results</a:t>
+              <a:t>Built, Tested &amp; Live in the Cloud</a:t>
             </a:r>
           </a:p>
         </p:txBody>
@@ -5324,7 +5378,7 @@
           <a:lstStyle/>
           <a:p>
             <a:pPr>
-              <a:defRPr sz="1350">
+              <a:defRPr sz="1400">
                 <a:solidFill>
                   <a:srgbClr val="94A3B8"/>
                 </a:solidFill>
@@ -5332,7 +5386,7 @@
               </a:defRPr>
             </a:pPr>
             <a:r>
-              <a:t>Production-grade full-stack financial terminal deployed on a zero-cost automated cloud topology.</a:t>
+              <a:t>Not just a notebook script. A complete, production-grade cloud application running 24/7.</a:t>
             </a:r>
           </a:p>
         </p:txBody>
@@ -5421,7 +5475,7 @@
               <a:spcBef>
                 <a:spcPts val="400"/>
               </a:spcBef>
-              <a:defRPr sz="900" b="1">
+              <a:defRPr sz="950" b="1">
                 <a:solidFill>
                   <a:srgbClr val="F8FAFC"/>
                 </a:solidFill>
@@ -5437,7 +5491,7 @@
               <a:spcBef>
                 <a:spcPts val="400"/>
               </a:spcBef>
-              <a:defRPr sz="900">
+              <a:defRPr sz="950">
                 <a:solidFill>
                   <a:srgbClr val="64748B"/>
                 </a:solidFill>
@@ -5445,7 +5499,7 @@
               </a:defRPr>
             </a:pPr>
             <a:r>
-              <a:t>+8.3% over Random Walk</a:t>
+              <a:t>Outperforms 50/50 odds</a:t>
             </a:r>
           </a:p>
         </p:txBody>
@@ -5534,7 +5588,7 @@
               <a:spcBef>
                 <a:spcPts val="400"/>
               </a:spcBef>
-              <a:defRPr sz="900" b="1">
+              <a:defRPr sz="950" b="1">
                 <a:solidFill>
                   <a:srgbClr val="F8FAFC"/>
                 </a:solidFill>
@@ -5542,7 +5596,7 @@
               </a:defRPr>
             </a:pPr>
             <a:r>
-              <a:t>EMPIRICAL COVERAGE</a:t>
+              <a:t>RISK ENVELOPE</a:t>
             </a:r>
           </a:p>
           <a:p>
@@ -5550,7 +5604,7 @@
               <a:spcBef>
                 <a:spcPts val="400"/>
               </a:spcBef>
-              <a:defRPr sz="900">
+              <a:defRPr sz="950">
                 <a:solidFill>
                   <a:srgbClr val="64748B"/>
                 </a:solidFill>
@@ -5558,7 +5612,7 @@
               </a:defRPr>
             </a:pPr>
             <a:r>
-              <a:t>Inside P10-P90 Envelope</a:t>
+              <a:t>Prices stay within cone</a:t>
             </a:r>
           </a:p>
         </p:txBody>
@@ -5647,7 +5701,7 @@
               <a:spcBef>
                 <a:spcPts val="400"/>
               </a:spcBef>
-              <a:defRPr sz="900" b="1">
+              <a:defRPr sz="950" b="1">
                 <a:solidFill>
                   <a:srgbClr val="F8FAFC"/>
                 </a:solidFill>
@@ -5655,7 +5709,7 @@
               </a:defRPr>
             </a:pPr>
             <a:r>
-              <a:t>EQUITIES + ASPI</a:t>
+              <a:t>COMPANIES &amp; INDEX</a:t>
             </a:r>
           </a:p>
           <a:p>
@@ -5663,7 +5717,7 @@
               <a:spcBef>
                 <a:spcPts val="400"/>
               </a:spcBef>
-              <a:defRPr sz="900">
+              <a:defRPr sz="950">
                 <a:solidFill>
                   <a:srgbClr val="64748B"/>
                 </a:solidFill>
@@ -5671,7 +5725,7 @@
               </a:defRPr>
             </a:pPr>
             <a:r>
-              <a:t>Automated Daily Sync</a:t>
+              <a:t>Updated daily on cloud</a:t>
             </a:r>
           </a:p>
         </p:txBody>
@@ -5752,7 +5806,7 @@
               </a:defRPr>
             </a:pPr>
             <a:r>
-              <a:t>PRODUCTION CLOUD SERVING STACK</a:t>
+              <a:t>THE COMPLETE SOFTWARE STACK</a:t>
             </a:r>
           </a:p>
           <a:p>
@@ -5760,7 +5814,7 @@
               <a:spcBef>
                 <a:spcPts val="600"/>
               </a:spcBef>
-              <a:defRPr sz="1150">
+              <a:defRPr sz="1200">
                 <a:solidFill>
                   <a:srgbClr val="F8FAFC"/>
                 </a:solidFill>
@@ -5768,7 +5822,7 @@
               </a:defRPr>
             </a:pPr>
             <a:r>
-              <a:t>• Frontend Terminal: React 19 + TypeScript + TradingView Lightweight Charts on Vercel CDN</a:t>
+              <a:t>• Frontend Dashboard: React 19 + TypeScript + TradingView interactive charts</a:t>
             </a:r>
           </a:p>
           <a:p>
@@ -5776,7 +5830,7 @@
               <a:spcBef>
                 <a:spcPts val="600"/>
               </a:spcBef>
-              <a:defRPr sz="1150">
+              <a:defRPr sz="1200">
                 <a:solidFill>
                   <a:srgbClr val="F8FAFC"/>
                 </a:solidFill>
@@ -5784,7 +5838,7 @@
               </a:defRPr>
             </a:pPr>
             <a:r>
-              <a:t>• Serving REST API: FastAPI in Docker container with OpenMP multiprocessing on Render</a:t>
+              <a:t>• Backend AI API: Python FastAPI running inside a Docker container</a:t>
             </a:r>
           </a:p>
           <a:p>
@@ -5792,7 +5846,7 @@
               <a:spcBef>
                 <a:spcPts val="600"/>
               </a:spcBef>
-              <a:defRPr sz="1150">
+              <a:defRPr sz="1200">
                 <a:solidFill>
                   <a:srgbClr val="F8FAFC"/>
                 </a:solidFill>
@@ -5800,7 +5854,7 @@
               </a:defRPr>
             </a:pPr>
             <a:r>
-              <a:t>• Cloud Database: PostgreSQL 15 on Supabase (Composite PK idempotent daily upserts)</a:t>
+              <a:t>• Cloud Database: PostgreSQL 15 on Supabase with automated backups</a:t>
             </a:r>
           </a:p>
           <a:p>
@@ -5808,7 +5862,7 @@
               <a:spcBef>
                 <a:spcPts val="600"/>
               </a:spcBef>
-              <a:defRPr sz="1150">
+              <a:defRPr sz="1200">
                 <a:solidFill>
                   <a:srgbClr val="F8FAFC"/>
                 </a:solidFill>
@@ -5816,7 +5870,7 @@
               </a:defRPr>
             </a:pPr>
             <a:r>
-              <a:t>• MLOps Automation: GitHub Actions daily cron (15:00 SLST) + 29-test Pytest CI suite</a:t>
+              <a:t>• Cloud Automation: GitHub Actions daily sync &amp; automated test suite</a:t>
             </a:r>
           </a:p>
         </p:txBody>
@@ -5852,7 +5906,16 @@
               </a:defRPr>
             </a:pPr>
             <a:r>
-              <a:t>TECH STACK:  </a:t>
+              <a:t>SKILLS &amp; TECH:  </a:t>
+            </a:r>
+            <a:r>
+              <a:rPr sz="950" b="1">
+                <a:solidFill>
+                  <a:srgbClr val="38BDF8"/>
+                </a:solidFill>
+                <a:latin typeface="Consolas"/>
+              </a:rPr>
+              <a:t> [React 19] </a:t>
             </a:r>
             <a:r>
               <a:rPr sz="950" b="1">
@@ -5879,7 +5942,7 @@
                 </a:solidFill>
                 <a:latin typeface="Consolas"/>
               </a:rPr>
-              <a:t> [PostgreSQL / Supabase] </a:t>
+              <a:t> [PostgreSQL] </a:t>
             </a:r>
             <a:r>
               <a:rPr sz="950" b="1">
@@ -5888,16 +5951,7 @@
                 </a:solidFill>
                 <a:latin typeface="Consolas"/>
               </a:rPr>
-              <a:t> [React 19 + TypeScript] </a:t>
-            </a:r>
-            <a:r>
-              <a:rPr sz="950" b="1">
-                <a:solidFill>
-                  <a:srgbClr val="38BDF8"/>
-                </a:solidFill>
-                <a:latin typeface="Consolas"/>
-              </a:rPr>
-              <a:t> [GitHub Actions] </a:t>
+              <a:t> [GitHub Actions CI/CD] </a:t>
             </a:r>
           </a:p>
         </p:txBody>

</xml_diff>

<commit_message>
docs: align slide deck, linkedin post, and cv description strictly to 5 core metrics (problem, solved, architecture, tech, accuracies)
</commit_message>
<xml_diff>
--- a/docs/linkedin_presentation_deck.pptx
+++ b/docs/linkedin_presentation_deck.pptx
@@ -3166,7 +3166,7 @@
               </a:defRPr>
             </a:pPr>
             <a:r>
-              <a:t>[ 01 / THE CORE PROBLEM ]</a:t>
+              <a:t>[ 01 / THE PROBLEM ]</a:t>
             </a:r>
           </a:p>
         </p:txBody>
@@ -3202,7 +3202,7 @@
               </a:defRPr>
             </a:pPr>
             <a:r>
-              <a:t>Why Most Stock AI Models Fail</a:t>
+              <a:t>Why Stock AI Models Fail</a:t>
             </a:r>
           </a:p>
         </p:txBody>
@@ -3238,7 +3238,7 @@
               </a:defRPr>
             </a:pPr>
             <a:r>
-              <a:t>Most beginners make one critical mistake: trying to predict exact stock prices instead of trend and momentum.</a:t>
+              <a:t>Most financial machine learning models collapse in real trading due to two critical engineering traps.</a:t>
             </a:r>
           </a:p>
         </p:txBody>
@@ -3252,7 +3252,7 @@
         <p:spPr>
           <a:xfrm>
             <a:off x="640080" y="3017520"/>
-            <a:ext cx="6492240" cy="2468880"/>
+            <a:ext cx="6492240" cy="2651760"/>
           </a:xfrm>
           <a:prstGeom prst="rect">
             <a:avLst/>
@@ -3297,7 +3297,7 @@
         <p:spPr>
           <a:xfrm>
             <a:off x="822960" y="3154680"/>
-            <a:ext cx="6126480" cy="2194560"/>
+            <a:ext cx="6126480" cy="2377440"/>
           </a:xfrm>
           <a:prstGeom prst="rect">
             <a:avLst/>
@@ -3319,7 +3319,7 @@
               </a:defRPr>
             </a:pPr>
             <a:r>
-              <a:t>THE TRAP: PREDICTING RAW PRICES</a:t>
+              <a:t>TRAP 1: THE COPY-PASTE IDENTITY BUG</a:t>
             </a:r>
           </a:p>
           <a:p>
@@ -3335,7 +3335,7 @@
               </a:defRPr>
             </a:pPr>
             <a:r>
-              <a:t>The AI Just Copies Yesterday's Price</a:t>
+              <a:t>Predicting Raw Stock Prices (P_t+30)</a:t>
             </a:r>
           </a:p>
           <a:p>
@@ -3351,7 +3351,7 @@
               </a:defRPr>
             </a:pPr>
             <a:r>
-              <a:t>If a stock was Rs. 100 yesterday, the AI predicts Rs. 100 tomorrow. It displays fake 99% accuracy on paper, but gives zero real trading value.</a:t>
+              <a:t>Because raw stock prices change slowly day-to-day, naive AI models simply output yesterday's price as tomorrow's forecast. It shows a fake 98% R² score on paper, but has zero real predictive alpha.</a:t>
             </a:r>
           </a:p>
         </p:txBody>
@@ -3364,8 +3364,8 @@
         </p:nvSpPr>
         <p:spPr>
           <a:xfrm>
-            <a:off x="640080" y="5669280"/>
-            <a:ext cx="6492240" cy="2468880"/>
+            <a:off x="640080" y="5852160"/>
+            <a:ext cx="6492240" cy="2651760"/>
           </a:xfrm>
           <a:prstGeom prst="rect">
             <a:avLst/>
@@ -3375,7 +3375,7 @@
           </a:solidFill>
           <a:ln w="19050">
             <a:solidFill>
-              <a:srgbClr val="34D399"/>
+              <a:srgbClr val="F87171"/>
             </a:solidFill>
           </a:ln>
         </p:spPr>
@@ -3409,8 +3409,8 @@
         </p:nvSpPr>
         <p:spPr>
           <a:xfrm>
-            <a:off x="822960" y="5806440"/>
-            <a:ext cx="6126480" cy="2194560"/>
+            <a:off x="822960" y="5989320"/>
+            <a:ext cx="6126480" cy="2377440"/>
           </a:xfrm>
           <a:prstGeom prst="rect">
             <a:avLst/>
@@ -3426,13 +3426,13 @@
             <a:pPr>
               <a:defRPr sz="1100" b="1">
                 <a:solidFill>
-                  <a:srgbClr val="34D399"/>
+                  <a:srgbClr val="F87171"/>
                 </a:solidFill>
                 <a:latin typeface="Consolas"/>
               </a:defRPr>
             </a:pPr>
             <a:r>
-              <a:t>HOW I SOLVED IT</a:t>
+              <a:t>TRAP 2: LOOKAHEAD DATA LEAKAGE</a:t>
             </a:r>
           </a:p>
           <a:p>
@@ -3448,7 +3448,7 @@
               </a:defRPr>
             </a:pPr>
             <a:r>
-              <a:t>Predicting 30-Day Percentage Return &amp; Direction</a:t>
+              <a:t>Overlapping Future Data in Training Splits</a:t>
             </a:r>
           </a:p>
           <a:p>
@@ -3464,7 +3464,7 @@
               </a:defRPr>
             </a:pPr>
             <a:r>
-              <a:t>I forced the models to learn whether a stock will grow or fall over the next month, discovering genuine market cycles across 26 top companies.</a:t>
+              <a:t>Standard random train/test splits accidentally let future 30-day stock returns leak into past training sets. The model memorizes future knowledge and fails completely in production.</a:t>
             </a:r>
           </a:p>
         </p:txBody>
@@ -3477,8 +3477,8 @@
         </p:nvSpPr>
         <p:spPr>
           <a:xfrm>
-            <a:off x="640080" y="8412480"/>
-            <a:ext cx="6492240" cy="365760"/>
+            <a:off x="640080" y="9006840"/>
+            <a:ext cx="6492240" cy="320040"/>
           </a:xfrm>
           <a:prstGeom prst="rect">
             <a:avLst/>
@@ -3486,78 +3486,6 @@
           <a:noFill/>
         </p:spPr>
         <p:txBody>
-          <a:bodyPr wrap="square">
-            <a:spAutoFit/>
-          </a:bodyPr>
-          <a:lstStyle/>
-          <a:p>
-            <a:pPr>
-              <a:defRPr sz="950" b="1">
-                <a:solidFill>
-                  <a:srgbClr val="64748B"/>
-                </a:solidFill>
-                <a:latin typeface="Consolas"/>
-              </a:defRPr>
-            </a:pPr>
-            <a:r>
-              <a:t>SKILLS &amp; TECH:  </a:t>
-            </a:r>
-            <a:r>
-              <a:rPr sz="950" b="1">
-                <a:solidFill>
-                  <a:srgbClr val="38BDF8"/>
-                </a:solidFill>
-                <a:latin typeface="Consolas"/>
-              </a:rPr>
-              <a:t> [Python] </a:t>
-            </a:r>
-            <a:r>
-              <a:rPr sz="950" b="1">
-                <a:solidFill>
-                  <a:srgbClr val="38BDF8"/>
-                </a:solidFill>
-                <a:latin typeface="Consolas"/>
-              </a:rPr>
-              <a:t> [Pandas] </a:t>
-            </a:r>
-            <a:r>
-              <a:rPr sz="950" b="1">
-                <a:solidFill>
-                  <a:srgbClr val="38BDF8"/>
-                </a:solidFill>
-                <a:latin typeface="Consolas"/>
-              </a:rPr>
-              <a:t> [NumPy] </a:t>
-            </a:r>
-            <a:r>
-              <a:rPr sz="950" b="1">
-                <a:solidFill>
-                  <a:srgbClr val="38BDF8"/>
-                </a:solidFill>
-                <a:latin typeface="Consolas"/>
-              </a:rPr>
-              <a:t> [Statistical Modeling] </a:t>
-            </a:r>
-          </a:p>
-        </p:txBody>
-      </p:sp>
-      <p:sp>
-        <p:nvSpPr>
-          <p:cNvPr id="11" name="TextBox 10"/>
-          <p:cNvSpPr txBox="1"/>
-          <p:nvPr/>
-        </p:nvSpPr>
-        <p:spPr>
-          <a:xfrm>
-            <a:off x="640080" y="9006840"/>
-            <a:ext cx="6492240" cy="320040"/>
-          </a:xfrm>
-          <a:prstGeom prst="rect">
-            <a:avLst/>
-          </a:prstGeom>
-          <a:noFill/>
-        </p:spPr>
-        <p:txBody>
           <a:bodyPr wrap="none">
             <a:spAutoFit/>
           </a:bodyPr>
@@ -3572,7 +3500,7 @@
               </a:defRPr>
             </a:pPr>
             <a:r>
-              <a:t>AI / ML SYSTEM ENGINEERING</a:t>
+              <a:t>COLOMBO STOCK EXCHANGE (CSE) ML</a:t>
             </a:r>
             <a:r>
               <a:rPr b="1">
@@ -3677,7 +3605,7 @@
               </a:defRPr>
             </a:pPr>
             <a:r>
-              <a:t>[ 02 / DATA PIPELINE ]</a:t>
+              <a:t>[ 02 / HOW I SOLVED IT ]</a:t>
             </a:r>
           </a:p>
         </p:txBody>
@@ -3713,7 +3641,7 @@
               </a:defRPr>
             </a:pPr>
             <a:r>
-              <a:t>Automated &amp; Fast Data Pipeline</a:t>
+              <a:t>Stationary Targets &amp; Risk Cones</a:t>
             </a:r>
           </a:p>
         </p:txBody>
@@ -3749,7 +3677,7 @@
               </a:defRPr>
             </a:pPr>
             <a:r>
-              <a:t>Good AI requires clean data. I built an end-to-end pipeline that tracks the Colombo Stock Exchange without manual work.</a:t>
+              <a:t>I rebuilt the learning formulation and validation structure to ensure true out-of-sample edge.</a:t>
             </a:r>
           </a:p>
         </p:txBody>
@@ -3763,7 +3691,120 @@
         <p:spPr>
           <a:xfrm>
             <a:off x="640080" y="3017520"/>
-            <a:ext cx="6492240" cy="2377440"/>
+            <a:ext cx="6492240" cy="1691640"/>
+          </a:xfrm>
+          <a:prstGeom prst="rect">
+            <a:avLst/>
+          </a:prstGeom>
+          <a:solidFill>
+            <a:srgbClr val="111722"/>
+          </a:solidFill>
+          <a:ln w="19050">
+            <a:solidFill>
+              <a:srgbClr val="34D399"/>
+            </a:solidFill>
+          </a:ln>
+        </p:spPr>
+        <p:style>
+          <a:lnRef idx="1">
+            <a:schemeClr val="accent1"/>
+          </a:lnRef>
+          <a:fillRef idx="3">
+            <a:schemeClr val="accent1"/>
+          </a:fillRef>
+          <a:effectRef idx="2">
+            <a:schemeClr val="accent1"/>
+          </a:effectRef>
+          <a:fontRef idx="minor">
+            <a:schemeClr val="lt1"/>
+          </a:fontRef>
+        </p:style>
+        <p:txBody>
+          <a:bodyPr rtlCol="0" anchor="ctr"/>
+          <a:lstStyle/>
+          <a:p>
+            <a:pPr algn="ctr"/>
+          </a:p>
+        </p:txBody>
+      </p:sp>
+      <p:sp>
+        <p:nvSpPr>
+          <p:cNvPr id="7" name="TextBox 6"/>
+          <p:cNvSpPr txBox="1"/>
+          <p:nvPr/>
+        </p:nvSpPr>
+        <p:spPr>
+          <a:xfrm>
+            <a:off x="822960" y="3127248"/>
+            <a:ext cx="6126480" cy="1463040"/>
+          </a:xfrm>
+          <a:prstGeom prst="rect">
+            <a:avLst/>
+          </a:prstGeom>
+          <a:noFill/>
+        </p:spPr>
+        <p:txBody>
+          <a:bodyPr wrap="square">
+            <a:spAutoFit/>
+          </a:bodyPr>
+          <a:lstStyle/>
+          <a:p>
+            <a:pPr>
+              <a:defRPr sz="1050" b="1">
+                <a:solidFill>
+                  <a:srgbClr val="34D399"/>
+                </a:solidFill>
+                <a:latin typeface="Consolas"/>
+              </a:defRPr>
+            </a:pPr>
+            <a:r>
+              <a:t>1. PREDICTING 30-DAY FORWARD LOG RETURN</a:t>
+            </a:r>
+          </a:p>
+          <a:p>
+            <a:pPr>
+              <a:spcBef>
+                <a:spcPts val="400"/>
+              </a:spcBef>
+              <a:defRPr sz="1550" b="1">
+                <a:solidFill>
+                  <a:srgbClr val="F8FAFC"/>
+                </a:solidFill>
+                <a:latin typeface="Trebuchet MS"/>
+              </a:defRPr>
+            </a:pPr>
+            <a:r>
+              <a:t>y_t = ln( P_{t+30} / P_t )</a:t>
+            </a:r>
+          </a:p>
+          <a:p>
+            <a:pPr>
+              <a:spcBef>
+                <a:spcPts val="500"/>
+              </a:spcBef>
+              <a:defRPr sz="1250">
+                <a:solidFill>
+                  <a:srgbClr val="94A3B8"/>
+                </a:solidFill>
+                <a:latin typeface="Calibri"/>
+              </a:defRPr>
+            </a:pPr>
+            <a:r>
+              <a:t>Forces models to predict momentum and trend instead of static price levels, enforcing stationarity across 26 equities.</a:t>
+            </a:r>
+          </a:p>
+        </p:txBody>
+      </p:sp>
+      <p:sp>
+        <p:nvSpPr>
+          <p:cNvPr id="8" name="Rectangle 7"/>
+          <p:cNvSpPr/>
+          <p:nvPr/>
+        </p:nvSpPr>
+        <p:spPr>
+          <a:xfrm>
+            <a:off x="640080" y="4892040"/>
+            <a:ext cx="6492240" cy="1691640"/>
           </a:xfrm>
           <a:prstGeom prst="rect">
             <a:avLst/>
@@ -3801,14 +3842,14 @@
       </p:sp>
       <p:sp>
         <p:nvSpPr>
-          <p:cNvPr id="7" name="TextBox 6"/>
+          <p:cNvPr id="9" name="TextBox 8"/>
           <p:cNvSpPr txBox="1"/>
           <p:nvPr/>
         </p:nvSpPr>
         <p:spPr>
           <a:xfrm>
-            <a:off x="822960" y="3154680"/>
-            <a:ext cx="6126480" cy="2103120"/>
+            <a:off x="822960" y="5001768"/>
+            <a:ext cx="6126480" cy="1463040"/>
           </a:xfrm>
           <a:prstGeom prst="rect">
             <a:avLst/>
@@ -3822,7 +3863,7 @@
           <a:lstStyle/>
           <a:p>
             <a:pPr>
-              <a:defRPr sz="1100" b="1">
+              <a:defRPr sz="1050" b="1">
                 <a:solidFill>
                   <a:srgbClr val="38BDF8"/>
                 </a:solidFill>
@@ -3830,15 +3871,15 @@
               </a:defRPr>
             </a:pPr>
             <a:r>
-              <a:t>DAILY MARKET AUTOMATION</a:t>
+              <a:t>2. MULTI-QUANTILE RISK ENVELOPES (PINBALL LOSS)</a:t>
             </a:r>
           </a:p>
           <a:p>
             <a:pPr>
               <a:spcBef>
-                <a:spcPts val="600"/>
+                <a:spcPts val="400"/>
               </a:spcBef>
-              <a:defRPr sz="1700" b="1">
+              <a:defRPr sz="1550" b="1">
                 <a:solidFill>
                   <a:srgbClr val="F8FAFC"/>
                 </a:solidFill>
@@ -3846,15 +3887,15 @@
               </a:defRPr>
             </a:pPr>
             <a:r>
-              <a:t>Syncs Automatically at 3:00 PM Every Weekday</a:t>
+              <a:t>P10 Downside Floor + P50 Median + P90 Ceiling</a:t>
             </a:r>
           </a:p>
           <a:p>
             <a:pPr>
               <a:spcBef>
-                <a:spcPts val="800"/>
+                <a:spcPts val="500"/>
               </a:spcBef>
-              <a:defRPr sz="1300">
+              <a:defRPr sz="1250">
                 <a:solidFill>
                   <a:srgbClr val="94A3B8"/>
                 </a:solidFill>
@@ -3862,21 +3903,21 @@
               </a:defRPr>
             </a:pPr>
             <a:r>
-              <a:t>When the Colombo market closes, automated cloud workers fetch closing prices for 26 key companies plus the ASPI index, validate data, and update databases.</a:t>
-            </a:r>
-          </a:p>
-        </p:txBody>
-      </p:sp>
-      <p:sp>
-        <p:nvSpPr>
-          <p:cNvPr id="8" name="Rectangle 7"/>
+              <a:t>Replaced dangerous single price guesses with probabilistic uncertainty envelopes, giving investors downside protection.</a:t>
+            </a:r>
+          </a:p>
+        </p:txBody>
+      </p:sp>
+      <p:sp>
+        <p:nvSpPr>
+          <p:cNvPr id="10" name="Rectangle 9"/>
           <p:cNvSpPr/>
           <p:nvPr/>
         </p:nvSpPr>
         <p:spPr>
           <a:xfrm>
-            <a:off x="640080" y="5577840"/>
-            <a:ext cx="6492240" cy="2468880"/>
+            <a:off x="640080" y="6766559"/>
+            <a:ext cx="6492240" cy="1691640"/>
           </a:xfrm>
           <a:prstGeom prst="rect">
             <a:avLst/>
@@ -3886,7 +3927,7 @@
           </a:solidFill>
           <a:ln w="19050">
             <a:solidFill>
-              <a:srgbClr val="38BDF8"/>
+              <a:srgbClr val="C084FC"/>
             </a:solidFill>
           </a:ln>
         </p:spPr>
@@ -3914,14 +3955,14 @@
       </p:sp>
       <p:sp>
         <p:nvSpPr>
-          <p:cNvPr id="9" name="TextBox 8"/>
+          <p:cNvPr id="11" name="TextBox 10"/>
           <p:cNvSpPr txBox="1"/>
           <p:nvPr/>
         </p:nvSpPr>
         <p:spPr>
           <a:xfrm>
-            <a:off x="822960" y="5715000"/>
-            <a:ext cx="6126480" cy="2194560"/>
+            <a:off x="822960" y="6876287"/>
+            <a:ext cx="6126480" cy="1463040"/>
           </a:xfrm>
           <a:prstGeom prst="rect">
             <a:avLst/>
@@ -3935,23 +3976,23 @@
           <a:lstStyle/>
           <a:p>
             <a:pPr>
-              <a:defRPr sz="1100" b="1">
-                <a:solidFill>
-                  <a:srgbClr val="38BDF8"/>
+              <a:defRPr sz="1050" b="1">
+                <a:solidFill>
+                  <a:srgbClr val="C084FC"/>
                 </a:solidFill>
                 <a:latin typeface="Consolas"/>
               </a:defRPr>
             </a:pPr>
             <a:r>
-              <a:t>FAST FEATURE ENGINE</a:t>
+              <a:t>3. PURGED &amp; EMBARGOED CROSS-VALIDATION</a:t>
             </a:r>
           </a:p>
           <a:p>
             <a:pPr>
               <a:spcBef>
-                <a:spcPts val="600"/>
+                <a:spcPts val="400"/>
               </a:spcBef>
-              <a:defRPr sz="1700" b="1">
+              <a:defRPr sz="1550" b="1">
                 <a:solidFill>
                   <a:srgbClr val="F8FAFC"/>
                 </a:solidFill>
@@ -3959,15 +4000,15 @@
               </a:defRPr>
             </a:pPr>
             <a:r>
-              <a:t>22 Market Indicators Calculated in Milliseconds</a:t>
+              <a:t>30-Day Purge Gap + 30-Day Embargo Buffer</a:t>
             </a:r>
           </a:p>
           <a:p>
             <a:pPr>
               <a:spcBef>
-                <a:spcPts val="800"/>
+                <a:spcPts val="500"/>
               </a:spcBef>
-              <a:defRPr sz="1300">
+              <a:defRPr sz="1250">
                 <a:solidFill>
                   <a:srgbClr val="94A3B8"/>
                 </a:solidFill>
@@ -3975,21 +4016,21 @@
               </a:defRPr>
             </a:pPr>
             <a:r>
-              <a:t>Automatically computes price volatility, RSI momentum, moving averages, and market correlations using ultra-fast columnar Parquet storage.</a:t>
-            </a:r>
-          </a:p>
-        </p:txBody>
-      </p:sp>
-      <p:sp>
-        <p:nvSpPr>
-          <p:cNvPr id="10" name="TextBox 9"/>
+              <a:t>Guarantees 100% leak-free evaluation by removing overlapping return labels and killing serial correlation.</a:t>
+            </a:r>
+          </a:p>
+        </p:txBody>
+      </p:sp>
+      <p:sp>
+        <p:nvSpPr>
+          <p:cNvPr id="12" name="TextBox 11"/>
           <p:cNvSpPr txBox="1"/>
           <p:nvPr/>
         </p:nvSpPr>
         <p:spPr>
           <a:xfrm>
-            <a:off x="640080" y="8412480"/>
-            <a:ext cx="6492240" cy="365760"/>
+            <a:off x="640080" y="9006840"/>
+            <a:ext cx="6492240" cy="320040"/>
           </a:xfrm>
           <a:prstGeom prst="rect">
             <a:avLst/>
@@ -3997,78 +4038,6 @@
           <a:noFill/>
         </p:spPr>
         <p:txBody>
-          <a:bodyPr wrap="square">
-            <a:spAutoFit/>
-          </a:bodyPr>
-          <a:lstStyle/>
-          <a:p>
-            <a:pPr>
-              <a:defRPr sz="950" b="1">
-                <a:solidFill>
-                  <a:srgbClr val="64748B"/>
-                </a:solidFill>
-                <a:latin typeface="Consolas"/>
-              </a:defRPr>
-            </a:pPr>
-            <a:r>
-              <a:t>SKILLS &amp; TECH:  </a:t>
-            </a:r>
-            <a:r>
-              <a:rPr sz="950" b="1">
-                <a:solidFill>
-                  <a:srgbClr val="38BDF8"/>
-                </a:solidFill>
-                <a:latin typeface="Consolas"/>
-              </a:rPr>
-              <a:t> [Automated ETL] </a:t>
-            </a:r>
-            <a:r>
-              <a:rPr sz="950" b="1">
-                <a:solidFill>
-                  <a:srgbClr val="38BDF8"/>
-                </a:solidFill>
-                <a:latin typeface="Consolas"/>
-              </a:rPr>
-              <a:t> [Apache Parquet] </a:t>
-            </a:r>
-            <a:r>
-              <a:rPr sz="950" b="1">
-                <a:solidFill>
-                  <a:srgbClr val="38BDF8"/>
-                </a:solidFill>
-                <a:latin typeface="Consolas"/>
-              </a:rPr>
-              <a:t> [REST APIs] </a:t>
-            </a:r>
-            <a:r>
-              <a:rPr sz="950" b="1">
-                <a:solidFill>
-                  <a:srgbClr val="38BDF8"/>
-                </a:solidFill>
-                <a:latin typeface="Consolas"/>
-              </a:rPr>
-              <a:t> [Data Pipelines] </a:t>
-            </a:r>
-          </a:p>
-        </p:txBody>
-      </p:sp>
-      <p:sp>
-        <p:nvSpPr>
-          <p:cNvPr id="11" name="TextBox 10"/>
-          <p:cNvSpPr txBox="1"/>
-          <p:nvPr/>
-        </p:nvSpPr>
-        <p:spPr>
-          <a:xfrm>
-            <a:off x="640080" y="9006840"/>
-            <a:ext cx="6492240" cy="320040"/>
-          </a:xfrm>
-          <a:prstGeom prst="rect">
-            <a:avLst/>
-          </a:prstGeom>
-          <a:noFill/>
-        </p:spPr>
-        <p:txBody>
           <a:bodyPr wrap="none">
             <a:spAutoFit/>
           </a:bodyPr>
@@ -4083,7 +4052,7 @@
               </a:defRPr>
             </a:pPr>
             <a:r>
-              <a:t>AI / ML SYSTEM ENGINEERING</a:t>
+              <a:t>COLOMBO STOCK EXCHANGE (CSE) ML</a:t>
             </a:r>
             <a:r>
               <a:rPr b="1">
@@ -4188,7 +4157,7 @@
               </a:defRPr>
             </a:pPr>
             <a:r>
-              <a:t>[ 03 / MACHINE LEARNING ]</a:t>
+              <a:t>[ 03 / SYSTEM ARCHITECTURE ]</a:t>
             </a:r>
           </a:p>
         </p:txBody>
@@ -4224,7 +4193,7 @@
               </a:defRPr>
             </a:pPr>
             <a:r>
-              <a:t>Predicting Risk, Not Just One Number</a:t>
+              <a:t>End-to-End Cloud Architecture</a:t>
             </a:r>
           </a:p>
         </p:txBody>
@@ -4260,7 +4229,7 @@
               </a:defRPr>
             </a:pPr>
             <a:r>
-              <a:t>Nobody can predict the future with 100% certainty. Single price guesses are dangerous, so I built a 3-way risk envelope.</a:t>
+              <a:t>A resilient, production-grade cloud topology designed for automated daily operation.</a:t>
             </a:r>
           </a:p>
         </p:txBody>
@@ -4274,120 +4243,7 @@
         <p:spPr>
           <a:xfrm>
             <a:off x="640080" y="3017520"/>
-            <a:ext cx="6492240" cy="1508760"/>
-          </a:xfrm>
-          <a:prstGeom prst="rect">
-            <a:avLst/>
-          </a:prstGeom>
-          <a:solidFill>
-            <a:srgbClr val="111722"/>
-          </a:solidFill>
-          <a:ln w="19050">
-            <a:solidFill>
-              <a:srgbClr val="F87171"/>
-            </a:solidFill>
-          </a:ln>
-        </p:spPr>
-        <p:style>
-          <a:lnRef idx="1">
-            <a:schemeClr val="accent1"/>
-          </a:lnRef>
-          <a:fillRef idx="3">
-            <a:schemeClr val="accent1"/>
-          </a:fillRef>
-          <a:effectRef idx="2">
-            <a:schemeClr val="accent1"/>
-          </a:effectRef>
-          <a:fontRef idx="minor">
-            <a:schemeClr val="lt1"/>
-          </a:fontRef>
-        </p:style>
-        <p:txBody>
-          <a:bodyPr rtlCol="0" anchor="ctr"/>
-          <a:lstStyle/>
-          <a:p>
-            <a:pPr algn="ctr"/>
-          </a:p>
-        </p:txBody>
-      </p:sp>
-      <p:sp>
-        <p:nvSpPr>
-          <p:cNvPr id="7" name="TextBox 6"/>
-          <p:cNvSpPr txBox="1"/>
-          <p:nvPr/>
-        </p:nvSpPr>
-        <p:spPr>
-          <a:xfrm>
-            <a:off x="822960" y="3127248"/>
-            <a:ext cx="6126480" cy="1280160"/>
-          </a:xfrm>
-          <a:prstGeom prst="rect">
-            <a:avLst/>
-          </a:prstGeom>
-          <a:noFill/>
-        </p:spPr>
-        <p:txBody>
-          <a:bodyPr wrap="square">
-            <a:spAutoFit/>
-          </a:bodyPr>
-          <a:lstStyle/>
-          <a:p>
-            <a:pPr>
-              <a:defRPr sz="1000" b="1">
-                <a:solidFill>
-                  <a:srgbClr val="F87171"/>
-                </a:solidFill>
-                <a:latin typeface="Consolas"/>
-              </a:defRPr>
-            </a:pPr>
-            <a:r>
-              <a:t>DOWNSIDE FLOOR (P10)</a:t>
-            </a:r>
-          </a:p>
-          <a:p>
-            <a:pPr>
-              <a:spcBef>
-                <a:spcPts val="300"/>
-              </a:spcBef>
-              <a:defRPr sz="1500" b="1">
-                <a:solidFill>
-                  <a:srgbClr val="F8FAFC"/>
-                </a:solidFill>
-                <a:latin typeface="Trebuchet MS"/>
-              </a:defRPr>
-            </a:pPr>
-            <a:r>
-              <a:t>Worst-Case Scenario</a:t>
-            </a:r>
-          </a:p>
-          <a:p>
-            <a:pPr>
-              <a:spcBef>
-                <a:spcPts val="400"/>
-              </a:spcBef>
-              <a:defRPr sz="1200">
-                <a:solidFill>
-                  <a:srgbClr val="94A3B8"/>
-                </a:solidFill>
-                <a:latin typeface="Calibri"/>
-              </a:defRPr>
-            </a:pPr>
-            <a:r>
-              <a:t>Shows where the stock could fall during bad market conditions so investors protect capital.</a:t>
-            </a:r>
-          </a:p>
-        </p:txBody>
-      </p:sp>
-      <p:sp>
-        <p:nvSpPr>
-          <p:cNvPr id="8" name="Rectangle 7"/>
-          <p:cNvSpPr/>
-          <p:nvPr/>
-        </p:nvSpPr>
-        <p:spPr>
-          <a:xfrm>
-            <a:off x="640080" y="4709160"/>
-            <a:ext cx="6492240" cy="1508760"/>
+            <a:ext cx="6492240" cy="1280160"/>
           </a:xfrm>
           <a:prstGeom prst="rect">
             <a:avLst/>
@@ -4425,14 +4281,14 @@
       </p:sp>
       <p:sp>
         <p:nvSpPr>
-          <p:cNvPr id="9" name="TextBox 8"/>
+          <p:cNvPr id="7" name="TextBox 6"/>
           <p:cNvSpPr txBox="1"/>
           <p:nvPr/>
         </p:nvSpPr>
         <p:spPr>
           <a:xfrm>
-            <a:off x="822960" y="4818888"/>
-            <a:ext cx="6126480" cy="1280160"/>
+            <a:off x="822960" y="3090672"/>
+            <a:ext cx="6126480" cy="1097280"/>
           </a:xfrm>
           <a:prstGeom prst="rect">
             <a:avLst/>
@@ -4446,7 +4302,7 @@
           <a:lstStyle/>
           <a:p>
             <a:pPr>
-              <a:defRPr sz="1000" b="1">
+              <a:defRPr sz="950" b="1">
                 <a:solidFill>
                   <a:srgbClr val="38BDF8"/>
                 </a:solidFill>
@@ -4454,7 +4310,23 @@
               </a:defRPr>
             </a:pPr>
             <a:r>
-              <a:t>EXPECTED PATH (P50)</a:t>
+              <a:t>1. DATA INGESTION ENGINE</a:t>
+            </a:r>
+          </a:p>
+          <a:p>
+            <a:pPr>
+              <a:spcBef>
+                <a:spcPts val="200"/>
+              </a:spcBef>
+              <a:defRPr sz="1400" b="1">
+                <a:solidFill>
+                  <a:srgbClr val="F8FAFC"/>
+                </a:solidFill>
+                <a:latin typeface="Trebuchet MS"/>
+              </a:defRPr>
+            </a:pPr>
+            <a:r>
+              <a:t>Daily Automated CSE Scraper</a:t>
             </a:r>
           </a:p>
           <a:p>
@@ -4462,7 +4334,104 @@
               <a:spcBef>
                 <a:spcPts val="300"/>
               </a:spcBef>
-              <a:defRPr sz="1500" b="1">
+              <a:defRPr sz="1150">
+                <a:solidFill>
+                  <a:srgbClr val="94A3B8"/>
+                </a:solidFill>
+                <a:latin typeface="Calibri"/>
+              </a:defRPr>
+            </a:pPr>
+            <a:r>
+              <a:t>Automated cron jobs execute at 15:00 SLST market close, syncing 26 blue chips + ASPI index.</a:t>
+            </a:r>
+          </a:p>
+        </p:txBody>
+      </p:sp>
+      <p:sp>
+        <p:nvSpPr>
+          <p:cNvPr id="8" name="Rectangle 7"/>
+          <p:cNvSpPr/>
+          <p:nvPr/>
+        </p:nvSpPr>
+        <p:spPr>
+          <a:xfrm>
+            <a:off x="640080" y="4434840"/>
+            <a:ext cx="6492240" cy="1280160"/>
+          </a:xfrm>
+          <a:prstGeom prst="rect">
+            <a:avLst/>
+          </a:prstGeom>
+          <a:solidFill>
+            <a:srgbClr val="111722"/>
+          </a:solidFill>
+          <a:ln w="19050">
+            <a:solidFill>
+              <a:srgbClr val="38BDF8"/>
+            </a:solidFill>
+          </a:ln>
+        </p:spPr>
+        <p:style>
+          <a:lnRef idx="1">
+            <a:schemeClr val="accent1"/>
+          </a:lnRef>
+          <a:fillRef idx="3">
+            <a:schemeClr val="accent1"/>
+          </a:fillRef>
+          <a:effectRef idx="2">
+            <a:schemeClr val="accent1"/>
+          </a:effectRef>
+          <a:fontRef idx="minor">
+            <a:schemeClr val="lt1"/>
+          </a:fontRef>
+        </p:style>
+        <p:txBody>
+          <a:bodyPr rtlCol="0" anchor="ctr"/>
+          <a:lstStyle/>
+          <a:p>
+            <a:pPr algn="ctr"/>
+          </a:p>
+        </p:txBody>
+      </p:sp>
+      <p:sp>
+        <p:nvSpPr>
+          <p:cNvPr id="9" name="TextBox 8"/>
+          <p:cNvSpPr txBox="1"/>
+          <p:nvPr/>
+        </p:nvSpPr>
+        <p:spPr>
+          <a:xfrm>
+            <a:off x="822960" y="4507992"/>
+            <a:ext cx="6126480" cy="1097280"/>
+          </a:xfrm>
+          <a:prstGeom prst="rect">
+            <a:avLst/>
+          </a:prstGeom>
+          <a:noFill/>
+        </p:spPr>
+        <p:txBody>
+          <a:bodyPr wrap="square">
+            <a:spAutoFit/>
+          </a:bodyPr>
+          <a:lstStyle/>
+          <a:p>
+            <a:pPr>
+              <a:defRPr sz="950" b="1">
+                <a:solidFill>
+                  <a:srgbClr val="38BDF8"/>
+                </a:solidFill>
+                <a:latin typeface="Consolas"/>
+              </a:defRPr>
+            </a:pPr>
+            <a:r>
+              <a:t>2. VECTORIZED LAKEHOUSE</a:t>
+            </a:r>
+          </a:p>
+          <a:p>
+            <a:pPr>
+              <a:spcBef>
+                <a:spcPts val="200"/>
+              </a:spcBef>
+              <a:defRPr sz="1400" b="1">
                 <a:solidFill>
                   <a:srgbClr val="F8FAFC"/>
                 </a:solidFill>
@@ -4470,15 +4439,15 @@
               </a:defRPr>
             </a:pPr>
             <a:r>
-              <a:t>Most Realistic Outcome</a:t>
+              <a:t>Apache Parquet Feature Store</a:t>
             </a:r>
           </a:p>
           <a:p>
             <a:pPr>
               <a:spcBef>
-                <a:spcPts val="400"/>
+                <a:spcPts val="300"/>
               </a:spcBef>
-              <a:defRPr sz="1200">
+              <a:defRPr sz="1150">
                 <a:solidFill>
                   <a:srgbClr val="94A3B8"/>
                 </a:solidFill>
@@ -4486,7 +4455,7 @@
               </a:defRPr>
             </a:pPr>
             <a:r>
-              <a:t>The realistic expected 30-day trajectory, filtering out daily noise and false spikes.</a:t>
+              <a:t>Zero-copy columnar format computing 22 indicators (Parkinson volatility, RSI, MACD, beta) in milliseconds.</a:t>
             </a:r>
           </a:p>
         </p:txBody>
@@ -4499,8 +4468,8 @@
         </p:nvSpPr>
         <p:spPr>
           <a:xfrm>
-            <a:off x="640080" y="6400800"/>
-            <a:ext cx="6492240" cy="1508760"/>
+            <a:off x="640080" y="5852160"/>
+            <a:ext cx="6492240" cy="1280160"/>
           </a:xfrm>
           <a:prstGeom prst="rect">
             <a:avLst/>
@@ -4544,8 +4513,8 @@
         </p:nvSpPr>
         <p:spPr>
           <a:xfrm>
-            <a:off x="822960" y="6510528"/>
-            <a:ext cx="6126480" cy="1280160"/>
+            <a:off x="822960" y="5925312"/>
+            <a:ext cx="6126480" cy="1097280"/>
           </a:xfrm>
           <a:prstGeom prst="rect">
             <a:avLst/>
@@ -4559,7 +4528,7 @@
           <a:lstStyle/>
           <a:p>
             <a:pPr>
-              <a:defRPr sz="1000" b="1">
+              <a:defRPr sz="950" b="1">
                 <a:solidFill>
                   <a:srgbClr val="34D399"/>
                 </a:solidFill>
@@ -4567,7 +4536,23 @@
               </a:defRPr>
             </a:pPr>
             <a:r>
-              <a:t>UPSIDE CEILING (P90)</a:t>
+              <a:t>3. BACKEND SERVING API</a:t>
+            </a:r>
+          </a:p>
+          <a:p>
+            <a:pPr>
+              <a:spcBef>
+                <a:spcPts val="200"/>
+              </a:spcBef>
+              <a:defRPr sz="1400" b="1">
+                <a:solidFill>
+                  <a:srgbClr val="F8FAFC"/>
+                </a:solidFill>
+                <a:latin typeface="Trebuchet MS"/>
+              </a:defRPr>
+            </a:pPr>
+            <a:r>
+              <a:t>Dockerized FastAPI on Render</a:t>
             </a:r>
           </a:p>
           <a:p>
@@ -4575,23 +4560,7 @@
               <a:spcBef>
                 <a:spcPts val="300"/>
               </a:spcBef>
-              <a:defRPr sz="1500" b="1">
-                <a:solidFill>
-                  <a:srgbClr val="F8FAFC"/>
-                </a:solidFill>
-                <a:latin typeface="Trebuchet MS"/>
-              </a:defRPr>
-            </a:pPr>
-            <a:r>
-              <a:t>Best-Case Potential</a:t>
-            </a:r>
-          </a:p>
-          <a:p>
-            <a:pPr>
-              <a:spcBef>
-                <a:spcPts val="400"/>
-              </a:spcBef>
-              <a:defRPr sz="1200">
+              <a:defRPr sz="1150">
                 <a:solidFill>
                   <a:srgbClr val="94A3B8"/>
                 </a:solidFill>
@@ -4599,21 +4568,66 @@
               </a:defRPr>
             </a:pPr>
             <a:r>
-              <a:t>Shows the upper resistance level if strong buying momentum continues.</a:t>
-            </a:r>
-          </a:p>
-        </p:txBody>
-      </p:sp>
-      <p:sp>
-        <p:nvSpPr>
-          <p:cNvPr id="12" name="TextBox 11"/>
+              <a:t>High-speed REST API executing real-time multi-quantile LightGBM inferences and TreeSHAP explainability.</a:t>
+            </a:r>
+          </a:p>
+        </p:txBody>
+      </p:sp>
+      <p:sp>
+        <p:nvSpPr>
+          <p:cNvPr id="12" name="Rectangle 11"/>
+          <p:cNvSpPr/>
+          <p:nvPr/>
+        </p:nvSpPr>
+        <p:spPr>
+          <a:xfrm>
+            <a:off x="640080" y="7269480"/>
+            <a:ext cx="6492240" cy="1280160"/>
+          </a:xfrm>
+          <a:prstGeom prst="rect">
+            <a:avLst/>
+          </a:prstGeom>
+          <a:solidFill>
+            <a:srgbClr val="111722"/>
+          </a:solidFill>
+          <a:ln w="19050">
+            <a:solidFill>
+              <a:srgbClr val="C084FC"/>
+            </a:solidFill>
+          </a:ln>
+        </p:spPr>
+        <p:style>
+          <a:lnRef idx="1">
+            <a:schemeClr val="accent1"/>
+          </a:lnRef>
+          <a:fillRef idx="3">
+            <a:schemeClr val="accent1"/>
+          </a:fillRef>
+          <a:effectRef idx="2">
+            <a:schemeClr val="accent1"/>
+          </a:effectRef>
+          <a:fontRef idx="minor">
+            <a:schemeClr val="lt1"/>
+          </a:fontRef>
+        </p:style>
+        <p:txBody>
+          <a:bodyPr rtlCol="0" anchor="ctr"/>
+          <a:lstStyle/>
+          <a:p>
+            <a:pPr algn="ctr"/>
+          </a:p>
+        </p:txBody>
+      </p:sp>
+      <p:sp>
+        <p:nvSpPr>
+          <p:cNvPr id="13" name="TextBox 12"/>
           <p:cNvSpPr txBox="1"/>
           <p:nvPr/>
         </p:nvSpPr>
         <p:spPr>
           <a:xfrm>
-            <a:off x="640080" y="8412480"/>
-            <a:ext cx="6492240" cy="365760"/>
+            <a:off x="822960" y="7342632"/>
+            <a:ext cx="6126480" cy="1097280"/>
           </a:xfrm>
           <a:prstGeom prst="rect">
             <a:avLst/>
@@ -4629,56 +4643,52 @@
             <a:pPr>
               <a:defRPr sz="950" b="1">
                 <a:solidFill>
-                  <a:srgbClr val="64748B"/>
+                  <a:srgbClr val="C084FC"/>
                 </a:solidFill>
                 <a:latin typeface="Consolas"/>
               </a:defRPr>
             </a:pPr>
             <a:r>
-              <a:t>SKILLS &amp; TECH:  </a:t>
-            </a:r>
-            <a:r>
-              <a:rPr sz="950" b="1">
-                <a:solidFill>
-                  <a:srgbClr val="38BDF8"/>
-                </a:solidFill>
-                <a:latin typeface="Consolas"/>
-              </a:rPr>
-              <a:t> [LightGBM] </a:t>
-            </a:r>
-            <a:r>
-              <a:rPr sz="950" b="1">
-                <a:solidFill>
-                  <a:srgbClr val="38BDF8"/>
-                </a:solidFill>
-                <a:latin typeface="Consolas"/>
-              </a:rPr>
-              <a:t> [Quantile AI] </a:t>
-            </a:r>
-            <a:r>
-              <a:rPr sz="950" b="1">
-                <a:solidFill>
-                  <a:srgbClr val="38BDF8"/>
-                </a:solidFill>
-                <a:latin typeface="Consolas"/>
-              </a:rPr>
-              <a:t> [Risk Modeling] </a:t>
-            </a:r>
-            <a:r>
-              <a:rPr sz="950" b="1">
-                <a:solidFill>
-                  <a:srgbClr val="38BDF8"/>
-                </a:solidFill>
-                <a:latin typeface="Consolas"/>
-              </a:rPr>
-              <a:t> [Scikit-Learn] </a:t>
-            </a:r>
-          </a:p>
-        </p:txBody>
-      </p:sp>
-      <p:sp>
-        <p:nvSpPr>
-          <p:cNvPr id="13" name="TextBox 12"/>
+              <a:t>4. DATABASE &amp; FRONTEND</a:t>
+            </a:r>
+          </a:p>
+          <a:p>
+            <a:pPr>
+              <a:spcBef>
+                <a:spcPts val="200"/>
+              </a:spcBef>
+              <a:defRPr sz="1400" b="1">
+                <a:solidFill>
+                  <a:srgbClr val="F8FAFC"/>
+                </a:solidFill>
+                <a:latin typeface="Trebuchet MS"/>
+              </a:defRPr>
+            </a:pPr>
+            <a:r>
+              <a:t>Supabase PostgreSQL + React 19 on Vercel</a:t>
+            </a:r>
+          </a:p>
+          <a:p>
+            <a:pPr>
+              <a:spcBef>
+                <a:spcPts val="300"/>
+              </a:spcBef>
+              <a:defRPr sz="1150">
+                <a:solidFill>
+                  <a:srgbClr val="94A3B8"/>
+                </a:solidFill>
+                <a:latin typeface="Calibri"/>
+              </a:defRPr>
+            </a:pPr>
+            <a:r>
+              <a:t>PostgreSQL database with composite PK idempotent upserts, paired with an interactive TradingView terminal.</a:t>
+            </a:r>
+          </a:p>
+        </p:txBody>
+      </p:sp>
+      <p:sp>
+        <p:nvSpPr>
+          <p:cNvPr id="14" name="TextBox 13"/>
           <p:cNvSpPr txBox="1"/>
           <p:nvPr/>
         </p:nvSpPr>
@@ -4707,7 +4717,7 @@
               </a:defRPr>
             </a:pPr>
             <a:r>
-              <a:t>AI / ML SYSTEM ENGINEERING</a:t>
+              <a:t>COLOMBO STOCK EXCHANGE (CSE) ML</a:t>
             </a:r>
             <a:r>
               <a:rPr b="1">
@@ -4812,7 +4822,7 @@
               </a:defRPr>
             </a:pPr>
             <a:r>
-              <a:t>[ 04 / EXPLAINABLE AI ]</a:t>
+              <a:t>[ 04 / TECHNOLOGIES USED ]</a:t>
             </a:r>
           </a:p>
         </p:txBody>
@@ -4848,7 +4858,7 @@
               </a:defRPr>
             </a:pPr>
             <a:r>
-              <a:t>Why Did the AI Make This Call?</a:t>
+              <a:t>Production Tech Stack</a:t>
             </a:r>
           </a:p>
         </p:txBody>
@@ -4884,7 +4894,7 @@
               </a:defRPr>
             </a:pPr>
             <a:r>
-              <a:t>Most AI models are mysterious 'black boxes'. You cannot trust real money to a black box, so I built full transparency into every prediction.</a:t>
+              <a:t>Modern tools and frameworks chosen for speed, scalability, and zero hosting costs.</a:t>
             </a:r>
           </a:p>
         </p:txBody>
@@ -4898,7 +4908,297 @@
         <p:spPr>
           <a:xfrm>
             <a:off x="640080" y="3017520"/>
-            <a:ext cx="6492240" cy="2377440"/>
+            <a:ext cx="3154680" cy="2514600"/>
+          </a:xfrm>
+          <a:prstGeom prst="rect">
+            <a:avLst/>
+          </a:prstGeom>
+          <a:solidFill>
+            <a:srgbClr val="111722"/>
+          </a:solidFill>
+          <a:ln w="19050">
+            <a:solidFill>
+              <a:srgbClr val="34D399"/>
+            </a:solidFill>
+          </a:ln>
+        </p:spPr>
+        <p:style>
+          <a:lnRef idx="1">
+            <a:schemeClr val="accent1"/>
+          </a:lnRef>
+          <a:fillRef idx="3">
+            <a:schemeClr val="accent1"/>
+          </a:fillRef>
+          <a:effectRef idx="2">
+            <a:schemeClr val="accent1"/>
+          </a:effectRef>
+          <a:fontRef idx="minor">
+            <a:schemeClr val="lt1"/>
+          </a:fontRef>
+        </p:style>
+        <p:txBody>
+          <a:bodyPr rtlCol="0" anchor="ctr"/>
+          <a:lstStyle/>
+          <a:p>
+            <a:pPr algn="ctr"/>
+          </a:p>
+        </p:txBody>
+      </p:sp>
+      <p:sp>
+        <p:nvSpPr>
+          <p:cNvPr id="7" name="TextBox 6"/>
+          <p:cNvSpPr txBox="1"/>
+          <p:nvPr/>
+        </p:nvSpPr>
+        <p:spPr>
+          <a:xfrm>
+            <a:off x="804672" y="3154680"/>
+            <a:ext cx="2834640" cy="2240280"/>
+          </a:xfrm>
+          <a:prstGeom prst="rect">
+            <a:avLst/>
+          </a:prstGeom>
+          <a:noFill/>
+        </p:spPr>
+        <p:txBody>
+          <a:bodyPr wrap="square">
+            <a:spAutoFit/>
+          </a:bodyPr>
+          <a:lstStyle/>
+          <a:p>
+            <a:pPr>
+              <a:defRPr sz="1050" b="1">
+                <a:solidFill>
+                  <a:srgbClr val="34D399"/>
+                </a:solidFill>
+                <a:latin typeface="Consolas"/>
+              </a:defRPr>
+            </a:pPr>
+            <a:r>
+              <a:t>AI &amp; MACHINE LEARNING</a:t>
+            </a:r>
+          </a:p>
+          <a:p>
+            <a:pPr>
+              <a:spcBef>
+                <a:spcPts val="400"/>
+              </a:spcBef>
+              <a:defRPr sz="1100">
+                <a:solidFill>
+                  <a:srgbClr val="F8FAFC"/>
+                </a:solidFill>
+                <a:latin typeface="Calibri"/>
+              </a:defRPr>
+            </a:pPr>
+            <a:r>
+              <a:t>• LightGBM: Multi-Quantile Pinball loss</a:t>
+            </a:r>
+          </a:p>
+          <a:p>
+            <a:pPr>
+              <a:spcBef>
+                <a:spcPts val="400"/>
+              </a:spcBef>
+              <a:defRPr sz="1100">
+                <a:solidFill>
+                  <a:srgbClr val="F8FAFC"/>
+                </a:solidFill>
+                <a:latin typeface="Calibri"/>
+              </a:defRPr>
+            </a:pPr>
+            <a:r>
+              <a:t>• Scikit-Learn: Time-series validation</a:t>
+            </a:r>
+          </a:p>
+          <a:p>
+            <a:pPr>
+              <a:spcBef>
+                <a:spcPts val="400"/>
+              </a:spcBef>
+              <a:defRPr sz="1100">
+                <a:solidFill>
+                  <a:srgbClr val="F8FAFC"/>
+                </a:solidFill>
+                <a:latin typeface="Calibri"/>
+              </a:defRPr>
+            </a:pPr>
+            <a:r>
+              <a:t>• TreeSHAP: Explainable AI attributions</a:t>
+            </a:r>
+          </a:p>
+          <a:p>
+            <a:pPr>
+              <a:spcBef>
+                <a:spcPts val="400"/>
+              </a:spcBef>
+              <a:defRPr sz="1100">
+                <a:solidFill>
+                  <a:srgbClr val="F8FAFC"/>
+                </a:solidFill>
+                <a:latin typeface="Calibri"/>
+              </a:defRPr>
+            </a:pPr>
+            <a:r>
+              <a:t>• NumPy &amp; Pandas: Vectorized series math</a:t>
+            </a:r>
+          </a:p>
+        </p:txBody>
+      </p:sp>
+      <p:sp>
+        <p:nvSpPr>
+          <p:cNvPr id="8" name="Rectangle 7"/>
+          <p:cNvSpPr/>
+          <p:nvPr/>
+        </p:nvSpPr>
+        <p:spPr>
+          <a:xfrm>
+            <a:off x="3977639" y="3017520"/>
+            <a:ext cx="3154680" cy="2514600"/>
+          </a:xfrm>
+          <a:prstGeom prst="rect">
+            <a:avLst/>
+          </a:prstGeom>
+          <a:solidFill>
+            <a:srgbClr val="111722"/>
+          </a:solidFill>
+          <a:ln w="19050">
+            <a:solidFill>
+              <a:srgbClr val="38BDF8"/>
+            </a:solidFill>
+          </a:ln>
+        </p:spPr>
+        <p:style>
+          <a:lnRef idx="1">
+            <a:schemeClr val="accent1"/>
+          </a:lnRef>
+          <a:fillRef idx="3">
+            <a:schemeClr val="accent1"/>
+          </a:fillRef>
+          <a:effectRef idx="2">
+            <a:schemeClr val="accent1"/>
+          </a:effectRef>
+          <a:fontRef idx="minor">
+            <a:schemeClr val="lt1"/>
+          </a:fontRef>
+        </p:style>
+        <p:txBody>
+          <a:bodyPr rtlCol="0" anchor="ctr"/>
+          <a:lstStyle/>
+          <a:p>
+            <a:pPr algn="ctr"/>
+          </a:p>
+        </p:txBody>
+      </p:sp>
+      <p:sp>
+        <p:nvSpPr>
+          <p:cNvPr id="9" name="TextBox 8"/>
+          <p:cNvSpPr txBox="1"/>
+          <p:nvPr/>
+        </p:nvSpPr>
+        <p:spPr>
+          <a:xfrm>
+            <a:off x="4142231" y="3154680"/>
+            <a:ext cx="2834640" cy="2240280"/>
+          </a:xfrm>
+          <a:prstGeom prst="rect">
+            <a:avLst/>
+          </a:prstGeom>
+          <a:noFill/>
+        </p:spPr>
+        <p:txBody>
+          <a:bodyPr wrap="square">
+            <a:spAutoFit/>
+          </a:bodyPr>
+          <a:lstStyle/>
+          <a:p>
+            <a:pPr>
+              <a:defRPr sz="1050" b="1">
+                <a:solidFill>
+                  <a:srgbClr val="38BDF8"/>
+                </a:solidFill>
+                <a:latin typeface="Consolas"/>
+              </a:defRPr>
+            </a:pPr>
+            <a:r>
+              <a:t>DATA ENGINEERING</a:t>
+            </a:r>
+          </a:p>
+          <a:p>
+            <a:pPr>
+              <a:spcBef>
+                <a:spcPts val="400"/>
+              </a:spcBef>
+              <a:defRPr sz="1100">
+                <a:solidFill>
+                  <a:srgbClr val="F8FAFC"/>
+                </a:solidFill>
+                <a:latin typeface="Calibri"/>
+              </a:defRPr>
+            </a:pPr>
+            <a:r>
+              <a:t>• Apache Parquet: Columnar zero-copy store</a:t>
+            </a:r>
+          </a:p>
+          <a:p>
+            <a:pPr>
+              <a:spcBef>
+                <a:spcPts val="400"/>
+              </a:spcBef>
+              <a:defRPr sz="1100">
+                <a:solidFill>
+                  <a:srgbClr val="F8FAFC"/>
+                </a:solidFill>
+                <a:latin typeface="Calibri"/>
+              </a:defRPr>
+            </a:pPr>
+            <a:r>
+              <a:t>• DuckDB &amp; PyArrow: High-speed analytics</a:t>
+            </a:r>
+          </a:p>
+          <a:p>
+            <a:pPr>
+              <a:spcBef>
+                <a:spcPts val="400"/>
+              </a:spcBef>
+              <a:defRPr sz="1100">
+                <a:solidFill>
+                  <a:srgbClr val="F8FAFC"/>
+                </a:solidFill>
+                <a:latin typeface="Calibri"/>
+              </a:defRPr>
+            </a:pPr>
+            <a:r>
+              <a:t>• Technical Indicators: 22 market estimators</a:t>
+            </a:r>
+          </a:p>
+          <a:p>
+            <a:pPr>
+              <a:spcBef>
+                <a:spcPts val="400"/>
+              </a:spcBef>
+              <a:defRPr sz="1100">
+                <a:solidFill>
+                  <a:srgbClr val="F8FAFC"/>
+                </a:solidFill>
+                <a:latin typeface="Calibri"/>
+              </a:defRPr>
+            </a:pPr>
+            <a:r>
+              <a:t>• Automated Cron: Daily 15:00 SLST ETL</a:t>
+            </a:r>
+          </a:p>
+        </p:txBody>
+      </p:sp>
+      <p:sp>
+        <p:nvSpPr>
+          <p:cNvPr id="10" name="Rectangle 9"/>
+          <p:cNvSpPr/>
+          <p:nvPr/>
+        </p:nvSpPr>
+        <p:spPr>
+          <a:xfrm>
+            <a:off x="640080" y="5760720"/>
+            <a:ext cx="3154680" cy="2514600"/>
           </a:xfrm>
           <a:prstGeom prst="rect">
             <a:avLst/>
@@ -4936,14 +5236,14 @@
       </p:sp>
       <p:sp>
         <p:nvSpPr>
-          <p:cNvPr id="7" name="TextBox 6"/>
+          <p:cNvPr id="11" name="TextBox 10"/>
           <p:cNvSpPr txBox="1"/>
           <p:nvPr/>
         </p:nvSpPr>
         <p:spPr>
           <a:xfrm>
-            <a:off x="822960" y="3154680"/>
-            <a:ext cx="6126480" cy="2103120"/>
+            <a:off x="804672" y="5897880"/>
+            <a:ext cx="2834640" cy="2240280"/>
           </a:xfrm>
           <a:prstGeom prst="rect">
             <a:avLst/>
@@ -4957,7 +5257,7 @@
           <a:lstStyle/>
           <a:p>
             <a:pPr>
-              <a:defRPr sz="1100" b="1">
+              <a:defRPr sz="1050" b="1">
                 <a:solidFill>
                   <a:srgbClr val="C084FC"/>
                 </a:solidFill>
@@ -4965,53 +5265,85 @@
               </a:defRPr>
             </a:pPr>
             <a:r>
-              <a:t>FEATURE IMPACT BREAKDOWN (SHAP)</a:t>
+              <a:t>BACKEND &amp; CLOUD</a:t>
             </a:r>
           </a:p>
           <a:p>
             <a:pPr>
               <a:spcBef>
-                <a:spcPts val="600"/>
+                <a:spcPts val="400"/>
               </a:spcBef>
-              <a:defRPr sz="1700" b="1">
+              <a:defRPr sz="1100">
                 <a:solidFill>
                   <a:srgbClr val="F8FAFC"/>
                 </a:solidFill>
-                <a:latin typeface="Trebuchet MS"/>
-              </a:defRPr>
-            </a:pPr>
-            <a:r>
-              <a:t>Every Prediction Explains Its Reasons</a:t>
+                <a:latin typeface="Calibri"/>
+              </a:defRPr>
+            </a:pPr>
+            <a:r>
+              <a:t>• Python FastAPI: Asynchronous REST API</a:t>
             </a:r>
           </a:p>
           <a:p>
             <a:pPr>
               <a:spcBef>
-                <a:spcPts val="800"/>
+                <a:spcPts val="400"/>
               </a:spcBef>
-              <a:defRPr sz="1300">
-                <a:solidFill>
-                  <a:srgbClr val="94A3B8"/>
+              <a:defRPr sz="1100">
+                <a:solidFill>
+                  <a:srgbClr val="F8FAFC"/>
                 </a:solidFill>
                 <a:latin typeface="Calibri"/>
               </a:defRPr>
             </a:pPr>
             <a:r>
-              <a:t>Users see exact factors driving the score: e.g. +2.4% strong momentum, -1.2% high market volatility, and +0.8% sector trend.</a:t>
-            </a:r>
-          </a:p>
-        </p:txBody>
-      </p:sp>
-      <p:sp>
-        <p:nvSpPr>
-          <p:cNvPr id="8" name="Rectangle 7"/>
+              <a:t>• Docker Container: Isolated deployment</a:t>
+            </a:r>
+          </a:p>
+          <a:p>
+            <a:pPr>
+              <a:spcBef>
+                <a:spcPts val="400"/>
+              </a:spcBef>
+              <a:defRPr sz="1100">
+                <a:solidFill>
+                  <a:srgbClr val="F8FAFC"/>
+                </a:solidFill>
+                <a:latin typeface="Calibri"/>
+              </a:defRPr>
+            </a:pPr>
+            <a:r>
+              <a:t>• Supabase / Postgres: Database storage</a:t>
+            </a:r>
+          </a:p>
+          <a:p>
+            <a:pPr>
+              <a:spcBef>
+                <a:spcPts val="400"/>
+              </a:spcBef>
+              <a:defRPr sz="1100">
+                <a:solidFill>
+                  <a:srgbClr val="F8FAFC"/>
+                </a:solidFill>
+                <a:latin typeface="Calibri"/>
+              </a:defRPr>
+            </a:pPr>
+            <a:r>
+              <a:t>• GitHub Actions: CI/CD automation</a:t>
+            </a:r>
+          </a:p>
+        </p:txBody>
+      </p:sp>
+      <p:sp>
+        <p:nvSpPr>
+          <p:cNvPr id="12" name="Rectangle 11"/>
           <p:cNvSpPr/>
           <p:nvPr/>
         </p:nvSpPr>
         <p:spPr>
           <a:xfrm>
-            <a:off x="640080" y="5577840"/>
-            <a:ext cx="6492240" cy="2468880"/>
+            <a:off x="3977639" y="5760720"/>
+            <a:ext cx="3154680" cy="2514600"/>
           </a:xfrm>
           <a:prstGeom prst="rect">
             <a:avLst/>
@@ -5021,7 +5353,7 @@
           </a:solidFill>
           <a:ln w="19050">
             <a:solidFill>
-              <a:srgbClr val="38BDF8"/>
+              <a:srgbClr val="F87171"/>
             </a:solidFill>
           </a:ln>
         </p:spPr>
@@ -5049,14 +5381,14 @@
       </p:sp>
       <p:sp>
         <p:nvSpPr>
-          <p:cNvPr id="9" name="TextBox 8"/>
+          <p:cNvPr id="13" name="TextBox 12"/>
           <p:cNvSpPr txBox="1"/>
           <p:nvPr/>
         </p:nvSpPr>
         <p:spPr>
           <a:xfrm>
-            <a:off x="822960" y="5715000"/>
-            <a:ext cx="6126480" cy="2194560"/>
+            <a:off x="4142231" y="5897880"/>
+            <a:ext cx="2834640" cy="2240280"/>
           </a:xfrm>
           <a:prstGeom prst="rect">
             <a:avLst/>
@@ -5070,61 +5402,93 @@
           <a:lstStyle/>
           <a:p>
             <a:pPr>
-              <a:defRPr sz="1100" b="1">
-                <a:solidFill>
-                  <a:srgbClr val="38BDF8"/>
+              <a:defRPr sz="1050" b="1">
+                <a:solidFill>
+                  <a:srgbClr val="F87171"/>
                 </a:solidFill>
                 <a:latin typeface="Consolas"/>
               </a:defRPr>
             </a:pPr>
             <a:r>
-              <a:t>HUMAN-READABLE HEALTH BADGES</a:t>
+              <a:t>FRONTEND &amp; UI</a:t>
             </a:r>
           </a:p>
           <a:p>
             <a:pPr>
               <a:spcBef>
-                <a:spcPts val="600"/>
+                <a:spcPts val="400"/>
               </a:spcBef>
-              <a:defRPr sz="1700" b="1">
+              <a:defRPr sz="1100">
                 <a:solidFill>
                   <a:srgbClr val="F8FAFC"/>
                 </a:solidFill>
-                <a:latin typeface="Trebuchet MS"/>
-              </a:defRPr>
-            </a:pPr>
-            <a:r>
-              <a:t>Instant Decision Checklist</a:t>
+                <a:latin typeface="Calibri"/>
+              </a:defRPr>
+            </a:pPr>
+            <a:r>
+              <a:t>• React 19 &amp; TypeScript: Modern web app</a:t>
             </a:r>
           </a:p>
           <a:p>
             <a:pPr>
               <a:spcBef>
-                <a:spcPts val="800"/>
+                <a:spcPts val="400"/>
               </a:spcBef>
-              <a:defRPr sz="1300">
-                <a:solidFill>
-                  <a:srgbClr val="94A3B8"/>
+              <a:defRPr sz="1100">
+                <a:solidFill>
+                  <a:srgbClr val="F8FAFC"/>
                 </a:solidFill>
                 <a:latin typeface="Calibri"/>
               </a:defRPr>
             </a:pPr>
             <a:r>
-              <a:t>Translates complex numbers into clear signals: SUPPORTING (healthy trend), RISK WARNING (overheated price), or NEUTRAL (market consolidation).</a:t>
-            </a:r>
-          </a:p>
-        </p:txBody>
-      </p:sp>
-      <p:sp>
-        <p:nvSpPr>
-          <p:cNvPr id="10" name="TextBox 9"/>
+              <a:t>• TradingView Charts: Interactive canvas</a:t>
+            </a:r>
+          </a:p>
+          <a:p>
+            <a:pPr>
+              <a:spcBef>
+                <a:spcPts val="400"/>
+              </a:spcBef>
+              <a:defRPr sz="1100">
+                <a:solidFill>
+                  <a:srgbClr val="F8FAFC"/>
+                </a:solidFill>
+                <a:latin typeface="Calibri"/>
+              </a:defRPr>
+            </a:pPr>
+            <a:r>
+              <a:t>• Vercel Edge: Global low-latency CDN</a:t>
+            </a:r>
+          </a:p>
+          <a:p>
+            <a:pPr>
+              <a:spcBef>
+                <a:spcPts val="400"/>
+              </a:spcBef>
+              <a:defRPr sz="1100">
+                <a:solidFill>
+                  <a:srgbClr val="F8FAFC"/>
+                </a:solidFill>
+                <a:latin typeface="Calibri"/>
+              </a:defRPr>
+            </a:pPr>
+            <a:r>
+              <a:t>• Pytest: 29-test automated suite</a:t>
+            </a:r>
+          </a:p>
+        </p:txBody>
+      </p:sp>
+      <p:sp>
+        <p:nvSpPr>
+          <p:cNvPr id="14" name="TextBox 13"/>
           <p:cNvSpPr txBox="1"/>
           <p:nvPr/>
         </p:nvSpPr>
         <p:spPr>
           <a:xfrm>
-            <a:off x="640080" y="8412480"/>
-            <a:ext cx="6492240" cy="365760"/>
+            <a:off x="640080" y="9006840"/>
+            <a:ext cx="6492240" cy="320040"/>
           </a:xfrm>
           <a:prstGeom prst="rect">
             <a:avLst/>
@@ -5132,69 +5496,6 @@
           <a:noFill/>
         </p:spPr>
         <p:txBody>
-          <a:bodyPr wrap="square">
-            <a:spAutoFit/>
-          </a:bodyPr>
-          <a:lstStyle/>
-          <a:p>
-            <a:pPr>
-              <a:defRPr sz="950" b="1">
-                <a:solidFill>
-                  <a:srgbClr val="64748B"/>
-                </a:solidFill>
-                <a:latin typeface="Consolas"/>
-              </a:defRPr>
-            </a:pPr>
-            <a:r>
-              <a:t>SKILLS &amp; TECH:  </a:t>
-            </a:r>
-            <a:r>
-              <a:rPr sz="950" b="1">
-                <a:solidFill>
-                  <a:srgbClr val="38BDF8"/>
-                </a:solidFill>
-                <a:latin typeface="Consolas"/>
-              </a:rPr>
-              <a:t> [SHAP Explainability] </a:t>
-            </a:r>
-            <a:r>
-              <a:rPr sz="950" b="1">
-                <a:solidFill>
-                  <a:srgbClr val="38BDF8"/>
-                </a:solidFill>
-                <a:latin typeface="Consolas"/>
-              </a:rPr>
-              <a:t> [Decision Intelligence] </a:t>
-            </a:r>
-            <a:r>
-              <a:rPr sz="950" b="1">
-                <a:solidFill>
-                  <a:srgbClr val="38BDF8"/>
-                </a:solidFill>
-                <a:latin typeface="Consolas"/>
-              </a:rPr>
-              <a:t> [Transparent AI] </a:t>
-            </a:r>
-          </a:p>
-        </p:txBody>
-      </p:sp>
-      <p:sp>
-        <p:nvSpPr>
-          <p:cNvPr id="11" name="TextBox 10"/>
-          <p:cNvSpPr txBox="1"/>
-          <p:nvPr/>
-        </p:nvSpPr>
-        <p:spPr>
-          <a:xfrm>
-            <a:off x="640080" y="9006840"/>
-            <a:ext cx="6492240" cy="320040"/>
-          </a:xfrm>
-          <a:prstGeom prst="rect">
-            <a:avLst/>
-          </a:prstGeom>
-          <a:noFill/>
-        </p:spPr>
-        <p:txBody>
           <a:bodyPr wrap="none">
             <a:spAutoFit/>
           </a:bodyPr>
@@ -5209,7 +5510,7 @@
               </a:defRPr>
             </a:pPr>
             <a:r>
-              <a:t>AI / ML SYSTEM ENGINEERING</a:t>
+              <a:t>COLOMBO STOCK EXCHANGE (CSE) ML</a:t>
             </a:r>
             <a:r>
               <a:rPr b="1">
@@ -5314,7 +5615,7 @@
               </a:defRPr>
             </a:pPr>
             <a:r>
-              <a:t>[ 05 / FULL-STACK DEPLOYMENT ]</a:t>
+              <a:t>[ 05 / ACCURACIES &amp; RESULTS ]</a:t>
             </a:r>
           </a:p>
         </p:txBody>
@@ -5350,7 +5651,7 @@
               </a:defRPr>
             </a:pPr>
             <a:r>
-              <a:t>Built, Tested &amp; Live in the Cloud</a:t>
+              <a:t>Empirical Results &amp; Accuracies</a:t>
             </a:r>
           </a:p>
         </p:txBody>
@@ -5386,7 +5687,7 @@
               </a:defRPr>
             </a:pPr>
             <a:r>
-              <a:t>Not just a notebook script. A complete, production-grade cloud application running 24/7.</a:t>
+              <a:t>Rigorous out-of-sample metrics proving real market edge over random walk baselines.</a:t>
             </a:r>
           </a:p>
         </p:txBody>
@@ -5400,7 +5701,7 @@
         <p:spPr>
           <a:xfrm>
             <a:off x="640080" y="3017520"/>
-            <a:ext cx="2011680" cy="1828800"/>
+            <a:ext cx="2011680" cy="1737360"/>
           </a:xfrm>
           <a:prstGeom prst="rect">
             <a:avLst/>
@@ -5445,7 +5746,7 @@
         <p:spPr>
           <a:xfrm>
             <a:off x="731520" y="3154680"/>
-            <a:ext cx="1828800" cy="1554480"/>
+            <a:ext cx="1828800" cy="1463040"/>
           </a:xfrm>
           <a:prstGeom prst="rect">
             <a:avLst/>
@@ -5475,7 +5776,7 @@
               <a:spcBef>
                 <a:spcPts val="400"/>
               </a:spcBef>
-              <a:defRPr sz="950" b="1">
+              <a:defRPr sz="900" b="1">
                 <a:solidFill>
                   <a:srgbClr val="F8FAFC"/>
                 </a:solidFill>
@@ -5491,7 +5792,7 @@
               <a:spcBef>
                 <a:spcPts val="400"/>
               </a:spcBef>
-              <a:defRPr sz="950">
+              <a:defRPr sz="900">
                 <a:solidFill>
                   <a:srgbClr val="64748B"/>
                 </a:solidFill>
@@ -5499,7 +5800,7 @@
               </a:defRPr>
             </a:pPr>
             <a:r>
-              <a:t>Outperforms 50/50 odds</a:t>
+              <a:t>+8.3% over Random Walk</a:t>
             </a:r>
           </a:p>
         </p:txBody>
@@ -5513,7 +5814,7 @@
         <p:spPr>
           <a:xfrm>
             <a:off x="2880360" y="3017520"/>
-            <a:ext cx="2011680" cy="1828800"/>
+            <a:ext cx="2011680" cy="1737360"/>
           </a:xfrm>
           <a:prstGeom prst="rect">
             <a:avLst/>
@@ -5558,7 +5859,7 @@
         <p:spPr>
           <a:xfrm>
             <a:off x="2971800" y="3154680"/>
-            <a:ext cx="1828800" cy="1554480"/>
+            <a:ext cx="1828800" cy="1463040"/>
           </a:xfrm>
           <a:prstGeom prst="rect">
             <a:avLst/>
@@ -5588,7 +5889,7 @@
               <a:spcBef>
                 <a:spcPts val="400"/>
               </a:spcBef>
-              <a:defRPr sz="950" b="1">
+              <a:defRPr sz="900" b="1">
                 <a:solidFill>
                   <a:srgbClr val="F8FAFC"/>
                 </a:solidFill>
@@ -5596,7 +5897,7 @@
               </a:defRPr>
             </a:pPr>
             <a:r>
-              <a:t>RISK ENVELOPE</a:t>
+              <a:t>EMPIRICAL COVERAGE</a:t>
             </a:r>
           </a:p>
           <a:p>
@@ -5604,7 +5905,7 @@
               <a:spcBef>
                 <a:spcPts val="400"/>
               </a:spcBef>
-              <a:defRPr sz="950">
+              <a:defRPr sz="900">
                 <a:solidFill>
                   <a:srgbClr val="64748B"/>
                 </a:solidFill>
@@ -5612,7 +5913,7 @@
               </a:defRPr>
             </a:pPr>
             <a:r>
-              <a:t>Prices stay within cone</a:t>
+              <a:t>Inside P10-P90 Risk Cone</a:t>
             </a:r>
           </a:p>
         </p:txBody>
@@ -5626,7 +5927,7 @@
         <p:spPr>
           <a:xfrm>
             <a:off x="5120640" y="3017520"/>
-            <a:ext cx="2011680" cy="1828800"/>
+            <a:ext cx="2011680" cy="1737360"/>
           </a:xfrm>
           <a:prstGeom prst="rect">
             <a:avLst/>
@@ -5671,7 +5972,7 @@
         <p:spPr>
           <a:xfrm>
             <a:off x="5212080" y="3154680"/>
-            <a:ext cx="1828800" cy="1554480"/>
+            <a:ext cx="1828800" cy="1463040"/>
           </a:xfrm>
           <a:prstGeom prst="rect">
             <a:avLst/>
@@ -5701,7 +6002,7 @@
               <a:spcBef>
                 <a:spcPts val="400"/>
               </a:spcBef>
-              <a:defRPr sz="950" b="1">
+              <a:defRPr sz="900" b="1">
                 <a:solidFill>
                   <a:srgbClr val="F8FAFC"/>
                 </a:solidFill>
@@ -5709,7 +6010,7 @@
               </a:defRPr>
             </a:pPr>
             <a:r>
-              <a:t>COMPANIES &amp; INDEX</a:t>
+              <a:t>ASSETS TRACKED</a:t>
             </a:r>
           </a:p>
           <a:p>
@@ -5717,7 +6018,7 @@
               <a:spcBef>
                 <a:spcPts val="400"/>
               </a:spcBef>
-              <a:defRPr sz="950">
+              <a:defRPr sz="900">
                 <a:solidFill>
                   <a:srgbClr val="64748B"/>
                 </a:solidFill>
@@ -5725,7 +6026,7 @@
               </a:defRPr>
             </a:pPr>
             <a:r>
-              <a:t>Updated daily on cloud</a:t>
+              <a:t>Equities + ASPI Index</a:t>
             </a:r>
           </a:p>
         </p:txBody>
@@ -5738,8 +6039,105 @@
         </p:nvSpPr>
         <p:spPr>
           <a:xfrm>
-            <a:off x="640080" y="5029200"/>
-            <a:ext cx="6492240" cy="3108960"/>
+            <a:off x="640080" y="4937760"/>
+            <a:ext cx="6492240" cy="1737360"/>
+          </a:xfrm>
+          <a:prstGeom prst="rect">
+            <a:avLst/>
+          </a:prstGeom>
+          <a:solidFill>
+            <a:srgbClr val="111722"/>
+          </a:solidFill>
+          <a:ln w="19050">
+            <a:solidFill>
+              <a:srgbClr val="34D399"/>
+            </a:solidFill>
+          </a:ln>
+        </p:spPr>
+        <p:style>
+          <a:lnRef idx="1">
+            <a:schemeClr val="accent1"/>
+          </a:lnRef>
+          <a:fillRef idx="3">
+            <a:schemeClr val="accent1"/>
+          </a:fillRef>
+          <a:effectRef idx="2">
+            <a:schemeClr val="accent1"/>
+          </a:effectRef>
+          <a:fontRef idx="minor">
+            <a:schemeClr val="lt1"/>
+          </a:fontRef>
+        </p:style>
+        <p:txBody>
+          <a:bodyPr rtlCol="0" anchor="ctr"/>
+          <a:lstStyle/>
+          <a:p>
+            <a:pPr algn="ctr"/>
+          </a:p>
+        </p:txBody>
+      </p:sp>
+      <p:sp>
+        <p:nvSpPr>
+          <p:cNvPr id="13" name="TextBox 12"/>
+          <p:cNvSpPr txBox="1"/>
+          <p:nvPr/>
+        </p:nvSpPr>
+        <p:spPr>
+          <a:xfrm>
+            <a:off x="822960" y="5029200"/>
+            <a:ext cx="6126480" cy="1554480"/>
+          </a:xfrm>
+          <a:prstGeom prst="rect">
+            <a:avLst/>
+          </a:prstGeom>
+          <a:noFill/>
+        </p:spPr>
+        <p:txBody>
+          <a:bodyPr wrap="square">
+            <a:spAutoFit/>
+          </a:bodyPr>
+          <a:lstStyle/>
+          <a:p>
+            <a:pPr>
+              <a:defRPr sz="1100" b="1">
+                <a:solidFill>
+                  <a:srgbClr val="34D399"/>
+                </a:solidFill>
+                <a:latin typeface="Consolas"/>
+              </a:defRPr>
+            </a:pPr>
+            <a:r>
+              <a:t>KEY ENGINEERING TAKEAWAY</a:t>
+            </a:r>
+          </a:p>
+          <a:p>
+            <a:pPr>
+              <a:spcBef>
+                <a:spcPts val="600"/>
+              </a:spcBef>
+              <a:defRPr sz="1200">
+                <a:solidFill>
+                  <a:srgbClr val="F8FAFC"/>
+                </a:solidFill>
+                <a:latin typeface="Calibri"/>
+              </a:defRPr>
+            </a:pPr>
+            <a:r>
+              <a:t>By replacing naive raw price prediction with stationary 30-day forward returns and purged cross-validation, the model achieves a statistically significant +8.3% directional edge across all 26 CSE blue chips without overfitting.</a:t>
+            </a:r>
+          </a:p>
+        </p:txBody>
+      </p:sp>
+      <p:sp>
+        <p:nvSpPr>
+          <p:cNvPr id="14" name="Rectangle 13"/>
+          <p:cNvSpPr/>
+          <p:nvPr/>
+        </p:nvSpPr>
+        <p:spPr>
+          <a:xfrm>
+            <a:off x="640080" y="6812280"/>
+            <a:ext cx="6492240" cy="1737360"/>
           </a:xfrm>
           <a:prstGeom prst="rect">
             <a:avLst/>
@@ -5777,14 +6175,14 @@
       </p:sp>
       <p:sp>
         <p:nvSpPr>
-          <p:cNvPr id="13" name="TextBox 12"/>
+          <p:cNvPr id="15" name="TextBox 14"/>
           <p:cNvSpPr txBox="1"/>
           <p:nvPr/>
         </p:nvSpPr>
         <p:spPr>
           <a:xfrm>
-            <a:off x="822960" y="5166360"/>
-            <a:ext cx="6126480" cy="2834640"/>
+            <a:off x="822960" y="6903720"/>
+            <a:ext cx="6126480" cy="1554480"/>
           </a:xfrm>
           <a:prstGeom prst="rect">
             <a:avLst/>
@@ -5806,7 +6204,7 @@
               </a:defRPr>
             </a:pPr>
             <a:r>
-              <a:t>THE COMPLETE SOFTWARE STACK</a:t>
+              <a:t>TESTING &amp; AUDITING</a:t>
             </a:r>
           </a:p>
           <a:p>
@@ -5822,69 +6220,21 @@
               </a:defRPr>
             </a:pPr>
             <a:r>
-              <a:t>• Frontend Dashboard: React 19 + TypeScript + TradingView interactive charts</a:t>
-            </a:r>
-          </a:p>
-          <a:p>
-            <a:pPr>
-              <a:spcBef>
-                <a:spcPts val="600"/>
-              </a:spcBef>
-              <a:defRPr sz="1200">
-                <a:solidFill>
-                  <a:srgbClr val="F8FAFC"/>
-                </a:solidFill>
-                <a:latin typeface="Calibri"/>
-              </a:defRPr>
-            </a:pPr>
-            <a:r>
-              <a:t>• Backend AI API: Python FastAPI running inside a Docker container</a:t>
-            </a:r>
-          </a:p>
-          <a:p>
-            <a:pPr>
-              <a:spcBef>
-                <a:spcPts val="600"/>
-              </a:spcBef>
-              <a:defRPr sz="1200">
-                <a:solidFill>
-                  <a:srgbClr val="F8FAFC"/>
-                </a:solidFill>
-                <a:latin typeface="Calibri"/>
-              </a:defRPr>
-            </a:pPr>
-            <a:r>
-              <a:t>• Cloud Database: PostgreSQL 15 on Supabase with automated backups</a:t>
-            </a:r>
-          </a:p>
-          <a:p>
-            <a:pPr>
-              <a:spcBef>
-                <a:spcPts val="600"/>
-              </a:spcBef>
-              <a:defRPr sz="1200">
-                <a:solidFill>
-                  <a:srgbClr val="F8FAFC"/>
-                </a:solidFill>
-                <a:latin typeface="Calibri"/>
-              </a:defRPr>
-            </a:pPr>
-            <a:r>
-              <a:t>• Cloud Automation: GitHub Actions daily sync &amp; automated test suite</a:t>
-            </a:r>
-          </a:p>
-        </p:txBody>
-      </p:sp>
-      <p:sp>
-        <p:nvSpPr>
-          <p:cNvPr id="14" name="TextBox 13"/>
+              <a:t>29 automated Pytest unit tests run in CI/CD pipeline verifying: TreeSHAP exact mathematical additivity, zero lookahead leakage, data pipeline idempotency, and API endpoints.</a:t>
+            </a:r>
+          </a:p>
+        </p:txBody>
+      </p:sp>
+      <p:sp>
+        <p:nvSpPr>
+          <p:cNvPr id="16" name="TextBox 15"/>
           <p:cNvSpPr txBox="1"/>
           <p:nvPr/>
         </p:nvSpPr>
         <p:spPr>
           <a:xfrm>
-            <a:off x="640080" y="8412480"/>
-            <a:ext cx="6492240" cy="365760"/>
+            <a:off x="640080" y="9006840"/>
+            <a:ext cx="6492240" cy="320040"/>
           </a:xfrm>
           <a:prstGeom prst="rect">
             <a:avLst/>
@@ -5892,87 +6242,6 @@
           <a:noFill/>
         </p:spPr>
         <p:txBody>
-          <a:bodyPr wrap="square">
-            <a:spAutoFit/>
-          </a:bodyPr>
-          <a:lstStyle/>
-          <a:p>
-            <a:pPr>
-              <a:defRPr sz="950" b="1">
-                <a:solidFill>
-                  <a:srgbClr val="64748B"/>
-                </a:solidFill>
-                <a:latin typeface="Consolas"/>
-              </a:defRPr>
-            </a:pPr>
-            <a:r>
-              <a:t>SKILLS &amp; TECH:  </a:t>
-            </a:r>
-            <a:r>
-              <a:rPr sz="950" b="1">
-                <a:solidFill>
-                  <a:srgbClr val="38BDF8"/>
-                </a:solidFill>
-                <a:latin typeface="Consolas"/>
-              </a:rPr>
-              <a:t> [React 19] </a:t>
-            </a:r>
-            <a:r>
-              <a:rPr sz="950" b="1">
-                <a:solidFill>
-                  <a:srgbClr val="38BDF8"/>
-                </a:solidFill>
-                <a:latin typeface="Consolas"/>
-              </a:rPr>
-              <a:t> [FastAPI] </a:t>
-            </a:r>
-            <a:r>
-              <a:rPr sz="950" b="1">
-                <a:solidFill>
-                  <a:srgbClr val="38BDF8"/>
-                </a:solidFill>
-                <a:latin typeface="Consolas"/>
-              </a:rPr>
-              <a:t> [Docker] </a:t>
-            </a:r>
-            <a:r>
-              <a:rPr sz="950" b="1">
-                <a:solidFill>
-                  <a:srgbClr val="38BDF8"/>
-                </a:solidFill>
-                <a:latin typeface="Consolas"/>
-              </a:rPr>
-              <a:t> [PostgreSQL] </a:t>
-            </a:r>
-            <a:r>
-              <a:rPr sz="950" b="1">
-                <a:solidFill>
-                  <a:srgbClr val="38BDF8"/>
-                </a:solidFill>
-                <a:latin typeface="Consolas"/>
-              </a:rPr>
-              <a:t> [GitHub Actions CI/CD] </a:t>
-            </a:r>
-          </a:p>
-        </p:txBody>
-      </p:sp>
-      <p:sp>
-        <p:nvSpPr>
-          <p:cNvPr id="15" name="TextBox 14"/>
-          <p:cNvSpPr txBox="1"/>
-          <p:nvPr/>
-        </p:nvSpPr>
-        <p:spPr>
-          <a:xfrm>
-            <a:off x="640080" y="9006840"/>
-            <a:ext cx="6492240" cy="320040"/>
-          </a:xfrm>
-          <a:prstGeom prst="rect">
-            <a:avLst/>
-          </a:prstGeom>
-          <a:noFill/>
-        </p:spPr>
-        <p:txBody>
           <a:bodyPr wrap="none">
             <a:spAutoFit/>
           </a:bodyPr>
@@ -5987,7 +6256,7 @@
               </a:defRPr>
             </a:pPr>
             <a:r>
-              <a:t>AI / ML SYSTEM ENGINEERING</a:t>
+              <a:t>COLOMBO STOCK EXCHANGE (CSE) ML</a:t>
             </a:r>
             <a:r>
               <a:rPr b="1">

</xml_diff>